<commit_message>
Refresh EWMA progress review deck
Updated the EWMA covariate shift progress review presentation to reflect the latest project updates and revisions in the slide deck.
</commit_message>
<xml_diff>
--- a/presentations/EWMA_Covariate_Shift_Progress_Review_Haocheng_Lin.pptx
+++ b/presentations/EWMA_Covariate_Shift_Progress_Review_Haocheng_Lin.pptx
@@ -149,25 +149,25 @@
 <pc:chgInfo xmlns:a="http://schemas.openxmlformats.org/drawingml/2006/main" xmlns:r="http://schemas.openxmlformats.org/officeDocument/2006/relationships" xmlns:ac="http://schemas.microsoft.com/office/drawing/2013/main/command" xmlns:pc="http://schemas.microsoft.com/office/powerpoint/2013/main/command">
   <pc:docChgLst>
     <pc:chgData name="Haocheng Lin" userId="3c9af17cd41df8cf" providerId="LiveId" clId="{E85DCD58-ED75-4D29-A2F4-F018EE94DF03}"/>
-    <pc:docChg chg="modSld">
-      <pc:chgData name="Haocheng Lin" userId="3c9af17cd41df8cf" providerId="LiveId" clId="{E85DCD58-ED75-4D29-A2F4-F018EE94DF03}" dt="2026-10-04T11:19:44.586" v="0" actId="1076"/>
+    <pc:docChg chg="custSel modSld">
+      <pc:chgData name="Haocheng Lin" userId="3c9af17cd41df8cf" providerId="LiveId" clId="{E85DCD58-ED75-4D29-A2F4-F018EE94DF03}" dt="2026-10-04T12:43:25.747" v="0" actId="21"/>
       <pc:docMkLst>
         <pc:docMk/>
       </pc:docMkLst>
-      <pc:sldChg chg="modSp mod">
-        <pc:chgData name="Haocheng Lin" userId="3c9af17cd41df8cf" providerId="LiveId" clId="{E85DCD58-ED75-4D29-A2F4-F018EE94DF03}" dt="2026-10-04T11:19:44.586" v="0" actId="1076"/>
+      <pc:sldChg chg="delSp mod">
+        <pc:chgData name="Haocheng Lin" userId="3c9af17cd41df8cf" providerId="LiveId" clId="{E85DCD58-ED75-4D29-A2F4-F018EE94DF03}" dt="2026-10-04T12:43:25.747" v="0" actId="21"/>
         <pc:sldMkLst>
           <pc:docMk/>
-          <pc:sldMk cId="0" sldId="2002"/>
+          <pc:sldMk cId="382100174" sldId="257"/>
         </pc:sldMkLst>
-        <pc:graphicFrameChg chg="mod">
-          <ac:chgData name="Haocheng Lin" userId="3c9af17cd41df8cf" providerId="LiveId" clId="{E85DCD58-ED75-4D29-A2F4-F018EE94DF03}" dt="2026-10-04T11:19:44.586" v="0" actId="1076"/>
-          <ac:graphicFrameMkLst>
+        <pc:spChg chg="del">
+          <ac:chgData name="Haocheng Lin" userId="3c9af17cd41df8cf" providerId="LiveId" clId="{E85DCD58-ED75-4D29-A2F4-F018EE94DF03}" dt="2026-10-04T12:43:25.747" v="0" actId="21"/>
+          <ac:spMkLst>
             <pc:docMk/>
-            <pc:sldMk cId="0" sldId="2002"/>
-            <ac:graphicFrameMk id="8" creationId="{00000000-0000-0000-0000-000000000000}"/>
-          </ac:graphicFrameMkLst>
-        </pc:graphicFrameChg>
+            <pc:sldMk cId="382100174" sldId="257"/>
+            <ac:spMk id="4" creationId="{00000000-0000-0000-0000-000000000000}"/>
+          </ac:spMkLst>
+        </pc:spChg>
       </pc:sldChg>
     </pc:docChg>
   </pc:docChgLst>
@@ -390,25 +390,53 @@
           <a:lstStyle/>
           <a:p>
             <a:r>
-              <a:t>Updated evidence includes complementary 20-seed and 100-seed synthetic experiments and a magnitude-6 comparison. Stored results are an evidence snapshot, not proof that every output was regenerated at this commit.</a:t>
-            </a:r>
-          </a:p>
-          <a:p>
-            <a:endParaRPr/>
-          </a:p>
-          <a:p>
-            <a:r>
-              <a:t>Repository snapshot: a3271c2, 30 September 2026.</a:t>
-            </a:r>
-          </a:p>
-          <a:p>
-            <a:r>
-              <a:t>https://github.com/hlin863/ewma_covariate_shift_demo/blob/a3271c24b2aefebeaa45ca805536a6a76c17d0e6/README.md</a:t>
-            </a:r>
-          </a:p>
-          <a:p>
-            <a:r>
-              <a:t>https://github.com/hlin863/ewma_covariate_shift_demo/blob/a3271c24b2aefebeaa45ca805536a6a76c17d0e6/outputs/complementary_100/summary.csv</a:t>
+              <a:rPr dirty="0"/>
+              <a:t>PRESENTER PREPARATION — Opening</a:t>
+            </a:r>
+          </a:p>
+          <a:p>
+            <a:endParaRPr dirty="0"/>
+          </a:p>
+          <a:p>
+            <a:r>
+              <a:rPr dirty="0"/>
+              <a:t>Suggested explanation (30–60 seconds):</a:t>
+            </a:r>
+          </a:p>
+          <a:p>
+            <a:r>
+              <a:rPr dirty="0"/>
+              <a:t>My project investigates when a detected change in EEG features should lead to a model update. I have built the detection and adaptation components, stored benchmark evidence, and started controlled policy comparisons. I will separate published findings from my implementation and results.</a:t>
+            </a:r>
+          </a:p>
+          <a:p>
+            <a:endParaRPr dirty="0"/>
+          </a:p>
+          <a:p>
+            <a:r>
+              <a:rPr dirty="0"/>
+              <a:t>Likely question and answer:</a:t>
+            </a:r>
+          </a:p>
+          <a:p>
+            <a:r>
+              <a:rPr dirty="0"/>
+              <a:t>What is the contribution? An auditable reconstruction and experimental framework; validated novelty and general adaptive gains are still research goals.</a:t>
+            </a:r>
+          </a:p>
+          <a:p>
+            <a:endParaRPr dirty="0"/>
+          </a:p>
+          <a:p>
+            <a:r>
+              <a:rPr dirty="0"/>
+              <a:t>Evidence and cautions:</a:t>
+            </a:r>
+          </a:p>
+          <a:p>
+            <a:r>
+              <a:rPr dirty="0"/>
+              <a:t>Roadmap: literature, implementation, evidence, next experiment.</a:t>
             </a:r>
           </a:p>
         </p:txBody>
@@ -485,7 +513,46 @@
           <a:lstStyle/>
           <a:p>
             <a:r>
-              <a:t>Repository evidence: 2a8d20b. Implemented capabilities and stored results are distinguished.</a:t>
+              <a:t>PRESENTER PREPARATION — Implementation responsibilities</a:t>
+            </a:r>
+          </a:p>
+          <a:p>
+            <a:endParaRPr/>
+          </a:p>
+          <a:p>
+            <a:r>
+              <a:t>Suggested explanation (30–60 seconds):</a:t>
+            </a:r>
+          </a:p>
+          <a:p>
+            <a:r>
+              <a:t>The update policy consumes evidence. A warning, a confirmation and performance deterioration are different signals. Labels can be supervised or pseudo-labelled. The current Diethe experiment uses fixed CSE, not the complementary score/residual extension.</a:t>
+            </a:r>
+          </a:p>
+          <a:p>
+            <a:endParaRPr/>
+          </a:p>
+          <a:p>
+            <a:r>
+              <a:t>Likely question and answer:</a:t>
+            </a:r>
+          </a:p>
+          <a:p>
+            <a:r>
+              <a:t>Is the whole model continuously learning? The current loop appends data and retrains; representation and detector stay fixed in Diethe.</a:t>
+            </a:r>
+          </a:p>
+          <a:p>
+            <a:endParaRPr/>
+          </a:p>
+          <a:p>
+            <a:r>
+              <a:t>Evidence and cautions:</a:t>
+            </a:r>
+          </a:p>
+          <a:p>
+            <a:r>
+              <a:t>src/adaptation/experiments/diethe.py and docs/diethe_experiments.md.</a:t>
             </a:r>
           </a:p>
         </p:txBody>
@@ -541,7 +608,7 @@
             <a:spLocks noGrp="1" noRot="1" noChangeAspect="1"/>
           </p:cNvSpPr>
           <p:nvPr>
-            <p:ph type="sldImg"/>
+            <p:ph type="sldImg" idx="2"/>
           </p:nvPr>
         </p:nvSpPr>
         <p:spPr/>
@@ -553,7 +620,7 @@
             <a:spLocks noGrp="1"/>
           </p:cNvSpPr>
           <p:nvPr>
-            <p:ph type="body" idx="1"/>
+            <p:ph type="body" sz="quarter" idx="3"/>
           </p:nvPr>
         </p:nvSpPr>
         <p:spPr/>
@@ -562,7 +629,7 @@
           <a:lstStyle/>
           <a:p>
             <a:r>
-              <a:t>CSE uses the Session-I (2A) and Sessions-I–III (2B) development pools with stratified 70/30 splitting before feature fitting. The paper does not report exact partition membership or seed. Published lambda overrides remain the default Table-I runner choice. The classifier benchmark has a separate protocol: 2A fits Session I and tests II; stored 2B metrics use I–II fitting and Session III GDF-only holdout. Optional released-label 2B evaluation is not the source of the shown benchmark numbers.</a:t>
+              <a:t>PRESENTER PREPARATION — Equation explanation</a:t>
             </a:r>
           </a:p>
           <a:p>
@@ -570,22 +637,38 @@
           </a:p>
           <a:p>
             <a:r>
-              <a:t>Repository snapshot: a3271c2, 30 September 2026.</a:t>
-            </a:r>
-          </a:p>
-          <a:p>
-            <a:r>
-              <a:t>https://github.com/hlin863/ewma_covariate_shift_demo/blob/a3271c24b2aefebeaa45ca805536a6a76c17d0e6/README.md</a:t>
-            </a:r>
-          </a:p>
-          <a:p>
-            <a:r>
-              <a:t>https://github.com/hlin863/ewma_covariate_shift_demo/blob/a3271c24b2aefebeaa45ca805536a6a76c17d0e6/src/adaptation/experiments/bagging_bci.py</a:t>
-            </a:r>
-          </a:p>
-          <a:p>
-            <a:r>
-              <a:t>https://github.com/hlin863/ewma_covariate_shift_demo/blob/a3271c24b2aefebeaa45ca805536a6a76c17d0e6/outputs/metrics/bagging_bci_real.csv</a:t>
+              <a:t>Suggested explanation (30–60 seconds):</a:t>
+            </a:r>
+          </a:p>
+          <a:p>
+            <a:r>
+              <a:t>Explain x as a PC1 score, z as its EWMA and e as the score prediction error. This is not a classification error. Then explain Stage II as comparison of multivariate means under the selected test.</a:t>
+            </a:r>
+          </a:p>
+          <a:p>
+            <a:endParaRPr/>
+          </a:p>
+          <a:p>
+            <a:r>
+              <a:t>Likely question and answer:</a:t>
+            </a:r>
+          </a:p>
+          <a:p>
+            <a:r>
+              <a:t>Is this exactly Chowdhury Eq9? No. Chowdhury prints separate covariance-over-sample-size terms. The slide shows the pooled repository mode; H is the sample-window size and d its dimension. The degrees-of-freedom condition alone does not guarantee invertible covariance.</a:t>
+            </a:r>
+          </a:p>
+          <a:p>
+            <a:endParaRPr/>
+          </a:p>
+          <a:p>
+            <a:r>
+              <a:t>Evidence and cautions:</a:t>
+            </a:r>
+          </a:p>
+          <a:p>
+            <a:r>
+              <a:t>Chowdhury II.E.3 Eqs3–9 pp1074–1075. Repository paper_two_sample mode. Do not call Hotelling nonparametric or claim it detects every distribution change.</a:t>
             </a:r>
           </a:p>
         </p:txBody>
@@ -597,17 +680,10 @@
             <a:spLocks noGrp="1"/>
           </p:cNvSpPr>
           <p:nvPr>
-            <p:ph type="sldNum" idx="5"/>
+            <p:ph type="sldNum" sz="quarter" idx="5"/>
           </p:nvPr>
         </p:nvSpPr>
         <p:spPr/>
-        <p:txBody>
-          <a:bodyPr/>
-          <a:lstStyle/>
-          <a:p>
-            <a:endParaRPr/>
-          </a:p>
-        </p:txBody>
       </p:sp>
     </p:spTree>
   </p:cSld>
@@ -662,17 +738,7 @@
           <a:lstStyle/>
           <a:p>
             <a:r>
-              <a:t>Classifier accuracies are unweighted means of nine subject accuracies per dataset, calculated from bagging_bci_real.csv. Changes are percentage points using unrounded values. Bagging uses 30 linear SVM members and sample fraction 0.8. No statistical significance or universal gain is claimed.</a:t>
-            </a:r>
-          </a:p>
-          <a:p>
-            <a:r>
-              <a:t>Synthetic table: outputs/complementary_100/summary.csv, 100 seeds, alpha 0.01, lambda 0.2, magnitude 3, detection horizon 20. Detection means at least one alarm within the 20-sample post-shift window. No-shift matched-window alarm rates are 21% score, 21% residual, 26% combined; full no-shift per-sample rates are 0.991%, 1.052%, 1.060%. This prevents interpreting the 1% calibration alpha as a 1% window-level rate. Magnitude-6 PC1 detection: score 88%, residual 21%, combined 82%. These controlled synthetic results do not establish real EEG shift-detection accuracy.</a:t>
-            </a:r>
-          </a:p>
-          <a:p>
-            <a:r>
-              <a:t>The committed pytest report dates to 22 September and contains 216 tests with one path-format assertion failure. It is not current-HEAD verification.</a:t>
+              <a:t>PRESENTER PREPARATION — Protocol separation</a:t>
             </a:r>
           </a:p>
           <a:p>
@@ -680,37 +746,38 @@
           </a:p>
           <a:p>
             <a:r>
-              <a:t>Repository snapshot: a3271c2, 30 September 2026.</a:t>
-            </a:r>
-          </a:p>
-          <a:p>
-            <a:r>
-              <a:t>https://github.com/hlin863/ewma_covariate_shift_demo/blob/a3271c24b2aefebeaa45ca805536a6a76c17d0e6/outputs/metrics/bagging_bci_real.csv</a:t>
-            </a:r>
-          </a:p>
-          <a:p>
-            <a:r>
-              <a:t>https://github.com/hlin863/ewma_covariate_shift_demo/blob/a3271c24b2aefebeaa45ca805536a6a76c17d0e6/outputs/complementary_100/summary.csv</a:t>
-            </a:r>
-          </a:p>
-          <a:p>
-            <a:r>
-              <a:t>https://github.com/hlin863/ewma_covariate_shift_demo/blob/a3271c24b2aefebeaa45ca805536a6a76c17d0e6/outputs/complementary_100/config.json</a:t>
-            </a:r>
-          </a:p>
-          <a:p>
-            <a:r>
-              <a:t>https://github.com/hlin863/ewma_covariate_shift_demo/blob/a3271c24b2aefebeaa45ca805536a6a76c17d0e6/outputs/complementary_magnitude6/summary.csv</a:t>
-            </a:r>
-          </a:p>
-          <a:p>
-            <a:r>
-              <a:t>https://github.com/hlin863/ewma_covariate_shift_demo/blob/a3271c24b2aefebeaa45ca805536a6a76c17d0e6/scripts/run_complementary_monitoring.py</a:t>
-            </a:r>
-          </a:p>
-          <a:p>
-            <a:r>
-              <a:t>https://github.com/hlin863/ewma_covariate_shift_demo/blob/a3271c24b2aefebeaa45ca805536a6a76c17d0e6/outputs/metrics/pytest_results.xml</a:t>
+              <a:t>Suggested explanation (30–60 seconds):</a:t>
+            </a:r>
+          </a:p>
+          <a:p>
+            <a:r>
+              <a:t>Fit preprocessing only on development training data and reuse it for held-out evaluation. CSE reproduction and classifier benchmarking have distinct split contracts.</a:t>
+            </a:r>
+          </a:p>
+          <a:p>
+            <a:endParaRPr/>
+          </a:p>
+          <a:p>
+            <a:r>
+              <a:t>Likely question and answer:</a:t>
+            </a:r>
+          </a:p>
+          <a:p>
+            <a:r>
+              <a:t>Why does 2B use different sessions in different slides? Different experiments answer different questions. Use the protocol table on slide16 to keep them explicit.</a:t>
+            </a:r>
+          </a:p>
+          <a:p>
+            <a:endParaRPr/>
+          </a:p>
+          <a:p>
+            <a:r>
+              <a:t>Evidence and cautions:</a:t>
+            </a:r>
+          </a:p>
+          <a:p>
+            <a:r>
+              <a:t>Repository dataset runners and stored bagging evaluation_scope fields.</a:t>
             </a:r>
           </a:p>
         </p:txBody>
@@ -787,7 +854,46 @@
           <a:lstStyle/>
           <a:p>
             <a:r>
-              <a:t>Sources: outputs/metrics/bci_2b_table1_results.csv and bci_table1_comparison.csv at 2a8d20b.</a:t>
+              <a:t>PRESENTER PREPARATION — Stored benchmark evidence</a:t>
+            </a:r>
+          </a:p>
+          <a:p>
+            <a:endParaRPr/>
+          </a:p>
+          <a:p>
+            <a:r>
+              <a:t>Suggested explanation (30–60 seconds):</a:t>
+            </a:r>
+          </a:p>
+          <a:p>
+            <a:r>
+              <a:t>Bagging changes accuracy only slightly and inconsistently across datasets. In synthetic monitoring, residuals detect orthogonal shifts missed by PC1, but combination has sensitivity and alarm-burden trade-offs.</a:t>
+            </a:r>
+          </a:p>
+          <a:p>
+            <a:endParaRPr/>
+          </a:p>
+          <a:p>
+            <a:r>
+              <a:t>Likely question and answer:</a:t>
+            </a:r>
+          </a:p>
+          <a:p>
+            <a:r>
+              <a:t>Does 100% PC2 detection establish superiority? Only for the specified synthetic conditions. The no-change window alarm rate and PC1 trade-off must also be reported.</a:t>
+            </a:r>
+          </a:p>
+          <a:p>
+            <a:endParaRPr/>
+          </a:p>
+          <a:p>
+            <a:r>
+              <a:t>Evidence and cautions:</a:t>
+            </a:r>
+          </a:p>
+          <a:p>
+            <a:r>
+              <a:t>outputs/metrics/bagging_bci_real.csv; outputs/complementary_100/summary.csv; magnitude6 summary. CI numbers on slide are explicitly the 2a8d20b snapshot, not a new test run.</a:t>
             </a:r>
           </a:p>
         </p:txBody>
@@ -812,11 +918,6 @@
         </p:txBody>
       </p:sp>
     </p:spTree>
-    <p:extLst>
-      <p:ext uri="{BB962C8B-B14F-4D97-AF65-F5344CB8AC3E}">
-        <p14:creationId xmlns:p14="http://schemas.microsoft.com/office/powerpoint/2010/main" val="251427986"/>
-      </p:ext>
-    </p:extLst>
   </p:cSld>
   <p:clrMapOvr>
     <a:masterClrMapping/>
@@ -869,7 +970,46 @@
           <a:lstStyle/>
           <a:p>
             <a:r>
-              <a:t>Source: outputs/metrics/bci_table1_comparison.csv at 2a8d20b; means calculated across nine subjects per dataset.</a:t>
+              <a:t>PRESENTER PREPARATION — B01 discrepancy</a:t>
+            </a:r>
+          </a:p>
+          <a:p>
+            <a:endParaRPr/>
+          </a:p>
+          <a:p>
+            <a:r>
+              <a:t>Suggested explanation (30–60 seconds):</a:t>
+            </a:r>
+          </a:p>
+          <a:p>
+            <a:r>
+              <a:t>Two committed files agree on 17 warnings but disagree on validated totals, five versus zero. This is why result provenance matters. I cannot infer that one run supersedes the other from these tables alone.</a:t>
+            </a:r>
+          </a:p>
+          <a:p>
+            <a:endParaRPr/>
+          </a:p>
+          <a:p>
+            <a:r>
+              <a:t>Likely question and answer:</a:t>
+            </a:r>
+          </a:p>
+          <a:p>
+            <a:r>
+              <a:t>What caused the difference? Not established by the saved CSVs. Check validation mode, windows, covariance, input representation and generating configuration.</a:t>
+            </a:r>
+          </a:p>
+          <a:p>
+            <a:endParaRPr/>
+          </a:p>
+          <a:p>
+            <a:r>
+              <a:t>Evidence and cautions:</a:t>
+            </a:r>
+          </a:p>
+          <a:p>
+            <a:r>
+              <a:t>outputs/metrics/bci_2b_table1_results.csv and bci_table1_comparison.csv.</a:t>
             </a:r>
           </a:p>
         </p:txBody>
@@ -894,6 +1034,11 @@
         </p:txBody>
       </p:sp>
     </p:spTree>
+    <p:extLst>
+      <p:ext uri="{BB962C8B-B14F-4D97-AF65-F5344CB8AC3E}">
+        <p14:creationId xmlns:p14="http://schemas.microsoft.com/office/powerpoint/2010/main" val="251427986"/>
+      </p:ext>
+    </p:extLst>
   </p:cSld>
   <p:clrMapOvr>
     <a:masterClrMapping/>
@@ -946,7 +1091,46 @@
           <a:lstStyle/>
           <a:p>
             <a:r>
-              <a:t>Source: current runners and stored result files at 2a8d20b. Evaluation data do not fit the feature representation.</a:t>
+              <a:t>PRESENTER PREPARATION — Reproduction boundary</a:t>
+            </a:r>
+          </a:p>
+          <a:p>
+            <a:endParaRPr/>
+          </a:p>
+          <a:p>
+            <a:r>
+              <a:t>Suggested explanation (30–60 seconds):</a:t>
+            </a:r>
+          </a:p>
+          <a:p>
+            <a:r>
+              <a:t>The combined results remain far below published validation counts. I can claim an executable reconstruction with measured discrepancies, but cannot claim numerical reproduction.</a:t>
+            </a:r>
+          </a:p>
+          <a:p>
+            <a:endParaRPr/>
+          </a:p>
+          <a:p>
+            <a:r>
+              <a:t>Likely question and answer:</a:t>
+            </a:r>
+          </a:p>
+          <a:p>
+            <a:r>
+              <a:t>Should parameters be tuned to match published test counts? That would risk fitting to the evaluation target. Select on development data and report sensitivity separately.</a:t>
+            </a:r>
+          </a:p>
+          <a:p>
+            <a:endParaRPr/>
+          </a:p>
+          <a:p>
+            <a:r>
+              <a:t>Evidence and cautions:</a:t>
+            </a:r>
+          </a:p>
+          <a:p>
+            <a:r>
+              <a:t>Combined Table-I file; means across nine subjects in each dataset. Not the standalone B01 result.</a:t>
             </a:r>
           </a:p>
         </p:txBody>
@@ -971,11 +1155,6 @@
         </p:txBody>
       </p:sp>
     </p:spTree>
-    <p:extLst>
-      <p:ext uri="{BB962C8B-B14F-4D97-AF65-F5344CB8AC3E}">
-        <p14:creationId xmlns:p14="http://schemas.microsoft.com/office/powerpoint/2010/main" val="1771693600"/>
-      </p:ext>
-    </p:extLst>
   </p:cSld>
   <p:clrMapOvr>
     <a:masterClrMapping/>
@@ -1007,7 +1186,7 @@
             <a:spLocks noGrp="1" noRot="1" noChangeAspect="1"/>
           </p:cNvSpPr>
           <p:nvPr>
-            <p:ph type="sldImg" idx="2"/>
+            <p:ph type="sldImg"/>
           </p:nvPr>
         </p:nvSpPr>
         <p:spPr/>
@@ -1019,7 +1198,7 @@
             <a:spLocks noGrp="1"/>
           </p:cNvSpPr>
           <p:nvPr>
-            <p:ph type="body" sz="quarter" idx="3"/>
+            <p:ph type="body" idx="1"/>
           </p:nvPr>
         </p:nvSpPr>
         <p:spPr/>
@@ -1028,7 +1207,46 @@
           <a:lstStyle/>
           <a:p>
             <a:r>
-              <a:t>Sources: Diethe et al. (2019), §§3–5; docs/diethe_experiments.md; src/adaptation/experiments/diethe.py.</a:t>
+              <a:t>PRESENTER PREPARATION — Dataset roles</a:t>
+            </a:r>
+          </a:p>
+          <a:p>
+            <a:endParaRPr/>
+          </a:p>
+          <a:p>
+            <a:r>
+              <a:t>Suggested explanation (30–60 seconds):</a:t>
+            </a:r>
+          </a:p>
+          <a:p>
+            <a:r>
+              <a:t>Read this as a protocol map. For complementary 2B, I–II fit the representation, III calibrates thresholds, and IV–V evaluate. That differs from the classifier benchmark and Table-I path.</a:t>
+            </a:r>
+          </a:p>
+          <a:p>
+            <a:endParaRPr/>
+          </a:p>
+          <a:p>
+            <a:r>
+              <a:t>Likely question and answer:</a:t>
+            </a:r>
+          </a:p>
+          <a:p>
+            <a:r>
+              <a:t>Are real EEG warnings true detections? They are descriptive alarms unless independently annotated or experimentally injected shifts provide ground truth.</a:t>
+            </a:r>
+          </a:p>
+          <a:p>
+            <a:endParaRPr/>
+          </a:p>
+          <a:p>
+            <a:r>
+              <a:t>Evidence and cautions:</a:t>
+            </a:r>
+          </a:p>
+          <a:p>
+            <a:r>
+              <a:t>scripts/run_complementary_bci.py. Prepared Diethe arrays require the caller to enforce non-overlapping splits.</a:t>
             </a:r>
           </a:p>
         </p:txBody>
@@ -1040,12 +1258,24 @@
             <a:spLocks noGrp="1"/>
           </p:cNvSpPr>
           <p:nvPr>
-            <p:ph type="sldNum" sz="quarter" idx="5"/>
+            <p:ph type="sldNum" idx="5"/>
           </p:nvPr>
         </p:nvSpPr>
         <p:spPr/>
+        <p:txBody>
+          <a:bodyPr/>
+          <a:lstStyle/>
+          <a:p>
+            <a:endParaRPr/>
+          </a:p>
+        </p:txBody>
       </p:sp>
     </p:spTree>
+    <p:extLst>
+      <p:ext uri="{BB962C8B-B14F-4D97-AF65-F5344CB8AC3E}">
+        <p14:creationId xmlns:p14="http://schemas.microsoft.com/office/powerpoint/2010/main" val="1771693600"/>
+      </p:ext>
+    </p:extLst>
   </p:cSld>
   <p:clrMapOvr>
     <a:masterClrMapping/>
@@ -1098,7 +1328,46 @@
           <a:lstStyle/>
           <a:p>
             <a:r>
-              <a:t>Source: docs/diethe_experiments.md and current CLI. Defaults: 240 trials, 20-trial interval, 30-trial performance window.</a:t>
+              <a:t>PRESENTER PREPARATION — Diethe architecture</a:t>
+            </a:r>
+          </a:p>
+          <a:p>
+            <a:endParaRPr/>
+          </a:p>
+          <a:p>
+            <a:r>
+              <a:t>Suggested explanation (30–60 seconds):</a:t>
+            </a:r>
+          </a:p>
+          <a:p>
+            <a:r>
+              <a:t>Diethe separates data monitoring, prediction monitoring and update policy. My implementation operationalises part of this architecture using five explicit rules and saved evidence.</a:t>
+            </a:r>
+          </a:p>
+          <a:p>
+            <a:endParaRPr/>
+          </a:p>
+          <a:p>
+            <a:r>
+              <a:t>Likely question and answer:</a:t>
+            </a:r>
+          </a:p>
+          <a:p>
+            <a:r>
+              <a:t>Have you implemented Diethe completely? No. The paper discusses much broader state, actions, provenance and policy learning. My rules do not implement rollback, learned policy optimisation or energy accounting.</a:t>
+            </a:r>
+          </a:p>
+          <a:p>
+            <a:endParaRPr/>
+          </a:p>
+          <a:p>
+            <a:r>
+              <a:t>Evidence and cautions:</a:t>
+            </a:r>
+          </a:p>
+          <a:p>
+            <a:r>
+              <a:t>Supplied Diethe PDF: §4.1–4.2 and §5 p4; §5.2 p5; §3.3 p3. First run now saved.</a:t>
             </a:r>
           </a:p>
         </p:txBody>
@@ -1168,7 +1437,46 @@
           <a:lstStyle/>
           <a:p>
             <a:r>
-              <a:t>Source: scripts/run_diethe_experiment.py and export_experiment(). No committed Diethe run outputs in reviewed tree.</a:t>
+              <a:t>PRESENTER PREPARATION — Controlled scenarios</a:t>
+            </a:r>
+          </a:p>
+          <a:p>
+            <a:endParaRPr/>
+          </a:p>
+          <a:p>
+            <a:r>
+              <a:t>Suggested explanation (30–60 seconds):</a:t>
+            </a:r>
+          </a:p>
+          <a:p>
+            <a:r>
+              <a:t>No shift measures baseline burden. Feature shift changes inputs while preserving the label rule. Relationship shift changes the label rule with the same input stream, so input monitoring can miss performance deterioration.</a:t>
+            </a:r>
+          </a:p>
+          <a:p>
+            <a:endParaRPr/>
+          </a:p>
+          <a:p>
+            <a:r>
+              <a:t>Likely question and answer:</a:t>
+            </a:r>
+          </a:p>
+          <a:p>
+            <a:r>
+              <a:t>When are labels available? Immediately after prediction, before any update. The validated policy waits for validation_time, not the earlier warning time.</a:t>
+            </a:r>
+          </a:p>
+          <a:p>
+            <a:endParaRPr/>
+          </a:p>
+          <a:p>
+            <a:r>
+              <a:t>Evidence and cautions:</a:t>
+            </a:r>
+          </a:p>
+          <a:p>
+            <a:r>
+              <a:t>DietheConfig: 120 training, 80 validation, 240 evaluation observations by default. These are feature vectors, not raw EEG.</a:t>
             </a:r>
           </a:p>
         </p:txBody>
@@ -1217,7 +1525,7 @@
             <a:spLocks noGrp="1" noRot="1" noChangeAspect="1"/>
           </p:cNvSpPr>
           <p:nvPr>
-            <p:ph type="sldImg"/>
+            <p:ph type="sldImg" idx="2"/>
           </p:nvPr>
         </p:nvSpPr>
         <p:spPr/>
@@ -1229,7 +1537,7 @@
             <a:spLocks noGrp="1"/>
           </p:cNvSpPr>
           <p:nvPr>
-            <p:ph type="body" idx="1"/>
+            <p:ph type="body" sz="quarter" idx="3"/>
           </p:nvPr>
         </p:nvSpPr>
         <p:spPr/>
@@ -1238,7 +1546,7 @@
           <a:lstStyle/>
           <a:p>
             <a:r>
-              <a:t>The twelve-month work-package schedule remains a proposed research plan. It does not claim that CUSUM, BOCPD, density-ratio methods, digital twins or photonic maintenance evaluation are already implemented. Current repository outputs form an initial EWMA, hierarchical-detection and classifier baseline. The immediate October emphasis is configuration provenance, Stage-II discrepancy analysis and real EEG complementary export.</a:t>
+              <a:t>PRESENTER PREPARATION — First Diethe result</a:t>
             </a:r>
           </a:p>
           <a:p>
@@ -1246,11 +1554,39 @@
           </a:p>
           <a:p>
             <a:r>
-              <a:t>Repository snapshot: a3271c2, 30 September 2026.</a:t>
+              <a:t>Suggested explanation (30–60 seconds):</a:t>
+            </a:r>
+          </a:p>
+          <a:p>
+            <a:r>
+              <a:t>The unchanged model gets 235 of 240 predictions correct. Periodic updating gets 236 with 12 updates. Warning and validated policies get 234; performance-drop matches never with zero updates. This illustrates why detection and update utility should be assessed separately.</a:t>
             </a:r>
           </a:p>
           <a:p>
             <a:endParaRPr/>
+          </a:p>
+          <a:p>
+            <a:r>
+              <a:t>Likely question and answer:</a:t>
+            </a:r>
+          </a:p>
+          <a:p>
+            <a:r>
+              <a:t>Is periodic best? Not established from one seed. Post-change accuracy is 99.17% for never and performance-drop versus 98.33% for the other three. The one-prediction overall advantage does not establish post-shift benefit.</a:t>
+            </a:r>
+          </a:p>
+          <a:p>
+            <a:endParaRPr/>
+          </a:p>
+          <a:p>
+            <a:r>
+              <a:t>Evidence and cautions:</a:t>
+            </a:r>
+          </a:p>
+          <a:p>
+            <a:r>
+              <a:t>Run 20261004T111759599003Z: feature_shift seed42 magnitude2; source commit2a8d20b. Three warnings; two rejected and one confirmed. Warning116 validates136, spanning true change120: do not label it an advance detection. Shared detector time≈29.71ms; retraining≈12.53ms periodic,3.12ms warning,1.21ms validated. Timing is one-machine wall time, not energy. Final periodic update239 cannot improve another prediction in this run.</a:t>
+            </a:r>
           </a:p>
         </p:txBody>
       </p:sp>
@@ -1261,17 +1597,10 @@
             <a:spLocks noGrp="1"/>
           </p:cNvSpPr>
           <p:nvPr>
-            <p:ph type="sldNum" idx="5"/>
+            <p:ph type="sldNum" sz="quarter" idx="5"/>
           </p:nvPr>
         </p:nvSpPr>
         <p:spPr/>
-        <p:txBody>
-          <a:bodyPr/>
-          <a:lstStyle/>
-          <a:p>
-            <a:endParaRPr/>
-          </a:p>
-        </p:txBody>
       </p:sp>
     </p:spTree>
   </p:cSld>
@@ -1326,7 +1655,46 @@
           <a:lstStyle/>
           <a:p>
             <a:r>
-              <a:t>Repository evidence: 2a8d20b. Implemented capabilities and stored results are distinguished.</a:t>
+              <a:t>PRESENTER PREPARATION — Implemented achievements</a:t>
+            </a:r>
+          </a:p>
+          <a:p>
+            <a:endParaRPr/>
+          </a:p>
+          <a:p>
+            <a:r>
+              <a:t>Suggested explanation (30–60 seconds):</a:t>
+            </a:r>
+          </a:p>
+          <a:p>
+            <a:r>
+              <a:t>The main engineering milestone is the separation of representation, detection, validation and adaptation. Supervised updates use revealed labels; the transductive path uses confidence-gated pseudo-labels. Neither is yet the full dynamic CSE-UAEL ensemble.</a:t>
+            </a:r>
+          </a:p>
+          <a:p>
+            <a:endParaRPr/>
+          </a:p>
+          <a:p>
+            <a:r>
+              <a:t>Likely question and answer:</a:t>
+            </a:r>
+          </a:p>
+          <a:p>
+            <a:r>
+              <a:t>Does implemented mean validated? No. Code and tests support behaviour; experiments must establish scientific benefit.</a:t>
+            </a:r>
+          </a:p>
+          <a:p>
+            <a:endParaRPr/>
+          </a:p>
+          <a:p>
+            <a:r>
+              <a:t>Evidence and cautions:</a:t>
+            </a:r>
+          </a:p>
+          <a:p>
+            <a:r>
+              <a:t>Repository README and src/adaptation/transductive.py; inspected at f3ef2e8.</a:t>
             </a:r>
           </a:p>
         </p:txBody>
@@ -1403,7 +1771,162 @@
           <a:lstStyle/>
           <a:p>
             <a:r>
-              <a:t>Repository evidence: 2a8d20b. Implemented capabilities and stored results are distinguished.</a:t>
+              <a:t>PRESENTER PREPARATION — Timeline</a:t>
+            </a:r>
+          </a:p>
+          <a:p>
+            <a:endParaRPr/>
+          </a:p>
+          <a:p>
+            <a:r>
+              <a:t>Suggested explanation (30–60 seconds):</a:t>
+            </a:r>
+          </a:p>
+          <a:p>
+            <a:r>
+              <a:t>This is a proposed first-year plan. The current reconstruction and pilot experiments provide starting evidence for early work packages; the digital twin, sustainability and cross-domain work are future objectives.</a:t>
+            </a:r>
+          </a:p>
+          <a:p>
+            <a:endParaRPr/>
+          </a:p>
+          <a:p>
+            <a:r>
+              <a:t>Likely question and answer:</a:t>
+            </a:r>
+          </a:p>
+          <a:p>
+            <a:r>
+              <a:t>Are these packages already completed? No. Distinguish the existing benchmark foundation from planned research outcomes.</a:t>
+            </a:r>
+          </a:p>
+          <a:p>
+            <a:endParaRPr/>
+          </a:p>
+          <a:p>
+            <a:r>
+              <a:t>Evidence and cautions:</a:t>
+            </a:r>
+          </a:p>
+          <a:p>
+            <a:r>
+              <a:t>Proposed October2026–September2027 timeline retained from the source deck.</a:t>
+            </a:r>
+          </a:p>
+        </p:txBody>
+      </p:sp>
+      <p:sp>
+        <p:nvSpPr>
+          <p:cNvPr id="4" name="Slide Number Placeholder 3"/>
+          <p:cNvSpPr>
+            <a:spLocks noGrp="1"/>
+          </p:cNvSpPr>
+          <p:nvPr>
+            <p:ph type="sldNum" idx="5"/>
+          </p:nvPr>
+        </p:nvSpPr>
+        <p:spPr/>
+        <p:txBody>
+          <a:bodyPr/>
+          <a:lstStyle/>
+          <a:p>
+            <a:endParaRPr/>
+          </a:p>
+        </p:txBody>
+      </p:sp>
+    </p:spTree>
+  </p:cSld>
+  <p:clrMapOvr>
+    <a:masterClrMapping/>
+  </p:clrMapOvr>
+</p:notes>
+</file>
+
+<file path=ppt/notesSlides/notesSlide21.xml><?xml version="1.0" encoding="utf-8"?>
+<p:notes xmlns:a="http://schemas.openxmlformats.org/drawingml/2006/main" xmlns:r="http://schemas.openxmlformats.org/officeDocument/2006/relationships" xmlns:p="http://schemas.openxmlformats.org/presentationml/2006/main">
+  <p:cSld>
+    <p:spTree>
+      <p:nvGrpSpPr>
+        <p:cNvPr id="1" name=""/>
+        <p:cNvGrpSpPr/>
+        <p:nvPr/>
+      </p:nvGrpSpPr>
+      <p:grpSpPr>
+        <a:xfrm>
+          <a:off x="0" y="0"/>
+          <a:ext cx="0" cy="0"/>
+          <a:chOff x="0" y="0"/>
+          <a:chExt cx="0" cy="0"/>
+        </a:xfrm>
+      </p:grpSpPr>
+      <p:sp>
+        <p:nvSpPr>
+          <p:cNvPr id="2" name="Slide Image Placeholder 1"/>
+          <p:cNvSpPr>
+            <a:spLocks noGrp="1" noRot="1" noChangeAspect="1"/>
+          </p:cNvSpPr>
+          <p:nvPr>
+            <p:ph type="sldImg"/>
+          </p:nvPr>
+        </p:nvSpPr>
+        <p:spPr/>
+      </p:sp>
+      <p:sp>
+        <p:nvSpPr>
+          <p:cNvPr id="3" name="Notes Placeholder 2"/>
+          <p:cNvSpPr>
+            <a:spLocks noGrp="1"/>
+          </p:cNvSpPr>
+          <p:nvPr>
+            <p:ph type="body" idx="1"/>
+          </p:nvPr>
+        </p:nvSpPr>
+        <p:spPr/>
+        <p:txBody>
+          <a:bodyPr/>
+          <a:lstStyle/>
+          <a:p>
+            <a:r>
+              <a:t>PRESENTER PREPARATION — Closing</a:t>
+            </a:r>
+          </a:p>
+          <a:p>
+            <a:endParaRPr/>
+          </a:p>
+          <a:p>
+            <a:r>
+              <a:t>Suggested explanation (30–60 seconds):</a:t>
+            </a:r>
+          </a:p>
+          <a:p>
+            <a:r>
+              <a:t>The next milestone is a reproducible evidence package: reconcile detector runs, repeat the policy experiment across scenarios and seeds, and generate real EEG complementary traces. Then judge benefit alongside update burden and uncertainty.</a:t>
+            </a:r>
+          </a:p>
+          <a:p>
+            <a:endParaRPr/>
+          </a:p>
+          <a:p>
+            <a:r>
+              <a:t>Likely question and answer:</a:t>
+            </a:r>
+          </a:p>
+          <a:p>
+            <a:r>
+              <a:t>What would count as success? Traceable configurations, repeated results with variability, a clear failure analysis, and evidence supporting a specific update policy under stated assumptions.</a:t>
+            </a:r>
+          </a:p>
+          <a:p>
+            <a:endParaRPr/>
+          </a:p>
+          <a:p>
+            <a:r>
+              <a:t>Evidence and cautions:</a:t>
+            </a:r>
+          </a:p>
+          <a:p>
+            <a:r>
+              <a:t>Closing question: when does a detected change justify updating the model? Return to this rather than claiming the full problem is solved.</a:t>
             </a:r>
           </a:p>
         </p:txBody>
@@ -1480,7 +2003,7 @@
           <a:lstStyle/>
           <a:p>
             <a:r>
-              <a:t>Literature chain: Raza et al. (2015), EWMA model based shift-detection methods; Chowdhury et al. (2018), Online Covariate Shift Detection-Based Adaptive Brain–Computer Interface to Trigger Hand Exoskeleton Feedback for Neuro-Rehabilitation; Raza et al. (2019), Covariate shift estimation based adaptive ensemble learning; Rao (2013), Brain–Computer Interfacing; Heyden et al. (2024), ABCD; Alippi et al. (2017), Hierarchical Change-Detection Tests. Chowdhury uses CSP features from μ/β bands and linear SVM. It should not be conflated with the 2019 ten-band FBCSP implementation. HCDT is related literature, not an assertion that the ICI-CDT baseline is the same algorithm.</a:t>
+              <a:t>PRESENTER PREPARATION — Research lineage</a:t>
             </a:r>
           </a:p>
           <a:p>
@@ -1488,17 +2011,38 @@
           </a:p>
           <a:p>
             <a:r>
-              <a:t>Repository snapshot: a3271c2, 30 September 2026.</a:t>
-            </a:r>
-          </a:p>
-          <a:p>
-            <a:r>
-              <a:t>https://github.com/hlin863/ewma_covariate_shift_demo/blob/a3271c24b2aefebeaa45ca805536a6a76c17d0e6/README.md</a:t>
-            </a:r>
-          </a:p>
-          <a:p>
-            <a:r>
-              <a:t>https://github.com/hlin863/ewma_covariate_shift_demo/blob/a3271c24b2aefebeaa45ca805536a6a76c17d0e6/src/detection/stage1/complementary.py</a:t>
+              <a:t>Suggested explanation (30–60 seconds):</a:t>
+            </a:r>
+          </a:p>
+          <a:p>
+            <a:r>
+              <a:t>Raza motivates detector reconstruction. Chowdhury demonstrates online supervised BCI adaptation. The later CSE-UAEL work motivates transductive updates and ensembles. Rao and Heyden motivate the subspace question. Diethe provides a maintenance architecture.</a:t>
+            </a:r>
+          </a:p>
+          <a:p>
+            <a:endParaRPr/>
+          </a:p>
+          <a:p>
+            <a:r>
+              <a:t>Likely question and answer:</a:t>
+            </a:r>
+          </a:p>
+          <a:p>
+            <a:r>
+              <a:t>Why Diethe 2019 when Notion says 2018? The supplied PDF identifies a 2018 workshop and arXiv v2 dated March 2019. State the version being cited consistently.</a:t>
+            </a:r>
+          </a:p>
+          <a:p>
+            <a:endParaRPr/>
+          </a:p>
+          <a:p>
+            <a:r>
+              <a:t>Evidence and cautions:</a:t>
+            </a:r>
+          </a:p>
+          <a:p>
+            <a:r>
+              <a:t>Transition: first explain what the clinical BCI paper established.</a:t>
             </a:r>
           </a:p>
         </p:txBody>
@@ -1575,12 +2119,46 @@
           <a:lstStyle/>
           <a:p>
             <a:r>
-              <a:t>Source: Chowdhury, A., Raza, H., Meena, Y. K., Dutta, A., &amp; Prasad, G. (2018). Online Covariate Shift Detection-Based Adaptive Brain–Computer Interface to Trigger Hand Exoskeleton Feedback for Neuro-Rehabilitation. IEEE Transactions on Cognitive and Developmental Systems, 10(4), 1070–1080.</a:t>
-            </a:r>
-          </a:p>
-          <a:p>
-            <a:r>
-              <a:t>Protocol: two calibration runs of 40 trials and one online feedback run of 40 trials per participant. Ten healthy and ten hemiplegic participants. EEG-CSAC alone ran online, with EEG-NAC applied afterwards offline to the same data (§II.E, p. 1073). Classifier predicts left/right hand motor imagery, not healthy/patient status. Stage-I uses PC1 of four CSP features. Stage-II compares multivariate feature sets. Validated shifts trigger appending labelled data and SVM retraining (§II.E.3, pp. 1074–1075).</a:t>
+              <a:t>PRESENTER PREPARATION — Chowdhury protocol</a:t>
+            </a:r>
+          </a:p>
+          <a:p>
+            <a:endParaRPr/>
+          </a:p>
+          <a:p>
+            <a:r>
+              <a:t>Suggested explanation (30–60 seconds):</a:t>
+            </a:r>
+          </a:p>
+          <a:p>
+            <a:r>
+              <a:t>Each participant completed 80 calibration trials and 40 online trials. The classifier distinguishes left versus right imagery, not healthy versus stroke participants. The adaptive system ran online; the nonadaptive comparator replayed the recorded data offline.</a:t>
+            </a:r>
+          </a:p>
+          <a:p>
+            <a:endParaRPr/>
+          </a:p>
+          <a:p>
+            <a:r>
+              <a:t>Likely question and answer:</a:t>
+            </a:r>
+          </a:p>
+          <a:p>
+            <a:r>
+              <a:t>Did your repository reproduce the clinical system? No. It uses BCI Competition data and a different feature pipeline; the paper provides methodological context.</a:t>
+            </a:r>
+          </a:p>
+          <a:p>
+            <a:endParaRPr/>
+          </a:p>
+          <a:p>
+            <a:r>
+              <a:t>Evidence and cautions:</a:t>
+            </a:r>
+          </a:p>
+          <a:p>
+            <a:r>
+              <a:t>Chowdhury II.B p1072; II.D–E p1073; II.E.3 pp1074–1075.</a:t>
             </a:r>
           </a:p>
         </p:txBody>
@@ -1657,12 +2235,46 @@
           <a:lstStyle/>
           <a:p>
             <a:r>
-              <a:t>Source: Chowdhury, A., Raza, H., Meena, Y. K., Dutta, A., &amp; Prasad, G. (2018). Online Covariate Shift Detection-Based Adaptive Brain–Computer Interface to Trigger Hand Exoskeleton Feedback for Neuro-Rehabilitation. IEEE Transactions on Cognitive and Developmental Systems, 10(4), 1070–1080.</a:t>
-            </a:r>
-          </a:p>
-          <a:p>
-            <a:r>
-              <a:t>Accuracy values are reported means ± SD. Both paired comparisons are significant at p &lt; 0.01 using the Wilcoxon signed-rank test (§II.E.4, p. 1075). Gains of 6.25 and 5.50 percentage points are calculated by subtracting published group means. Kappa also improves significantly (Table IV). All participants could trigger the hand exoskeleton (§IV, p. 1078). These are paper results, not repository reproduction results.</a:t>
+              <a:t>PRESENTER PREPARATION — Published accuracy</a:t>
+            </a:r>
+          </a:p>
+          <a:p>
+            <a:endParaRPr/>
+          </a:p>
+          <a:p>
+            <a:r>
+              <a:t>Suggested explanation (30–60 seconds):</a:t>
+            </a:r>
+          </a:p>
+          <a:p>
+            <a:r>
+              <a:t>The reported healthy-group gain is 6.25 percentage points and stroke-group gain is 5.50 points. Both paired comparisons were significant. These are paper results, not my repository results.</a:t>
+            </a:r>
+          </a:p>
+          <a:p>
+            <a:endParaRPr/>
+          </a:p>
+          <a:p>
+            <a:r>
+              <a:t>Likely question and answer:</a:t>
+            </a:r>
+          </a:p>
+          <a:p>
+            <a:r>
+              <a:t>Does this prove recovery? No. It demonstrates better decoding and online feasibility, without longitudinal motor-recovery outcomes.</a:t>
+            </a:r>
+          </a:p>
+          <a:p>
+            <a:endParaRPr/>
+          </a:p>
+          <a:p>
+            <a:r>
+              <a:t>Evidence and cautions:</a:t>
+            </a:r>
+          </a:p>
+          <a:p>
+            <a:r>
+              <a:t>Chowdhury III p1076 Tables II–IV. Mean ± SD; paired Wilcoxon significance.</a:t>
             </a:r>
           </a:p>
         </p:txBody>
@@ -1739,12 +2351,46 @@
           <a:lstStyle/>
           <a:p>
             <a:r>
-              <a:t>Source: Chowdhury, A., Raza, H., Meena, Y. K., Dutta, A., &amp; Prasad, G. (2018). Online Covariate Shift Detection-Based Adaptive Brain–Computer Interface to Trigger Hand Exoskeleton Feedback for Neuro-Rehabilitation. IEEE Transactions on Cognitive and Developmental Systems, 10(4), 1070–1080.</a:t>
-            </a:r>
-          </a:p>
-          <a:p>
-            <a:r>
-              <a:t>CSW and CSV are percentages of all trials, defined in Eqs. (10)–(11). Reported mean ± SD: healthy CSW 15.75 ± 5.65%, CSV 9.25 ± 3.54%; stroke CSW 16.75 ± 2.89%, CSV 9.00 ± 2.10%. Reductions significant at p &lt; 0.01. CSV and accuracy gain correlate at r = 0.853, p &lt; 0.01. Critical interpretation: this association does not prove each detected event is a true distributional shift. Rejected warnings alone cannot identify false positives without independent ground truth.</a:t>
+              <a:t>PRESENTER PREPARATION — Validation evidence</a:t>
+            </a:r>
+          </a:p>
+          <a:p>
+            <a:endParaRPr/>
+          </a:p>
+          <a:p>
+            <a:r>
+              <a:t>Suggested explanation (30–60 seconds):</a:t>
+            </a:r>
+          </a:p>
+          <a:p>
+            <a:r>
+              <a:t>CSW and CSV here are percentages of trials. Validation reduces the fraction triggering retraining. The correlation with accuracy gain is an association, not an isolated causal effect of the detector.</a:t>
+            </a:r>
+          </a:p>
+          <a:p>
+            <a:endParaRPr/>
+          </a:p>
+          <a:p>
+            <a:r>
+              <a:t>Likely question and answer:</a:t>
+            </a:r>
+          </a:p>
+          <a:p>
+            <a:r>
+              <a:t>Were rejected warnings false alarms? We cannot determine that without independent shift truth. Rejection is a statistical outcome, not a ground-truth label.</a:t>
+            </a:r>
+          </a:p>
+          <a:p>
+            <a:endParaRPr/>
+          </a:p>
+          <a:p>
+            <a:r>
+              <a:t>Evidence and cautions:</a:t>
+            </a:r>
+          </a:p>
+          <a:p>
+            <a:r>
+              <a:t>Chowdhury II.E.4 Eqs10–11 p1075; III p1077 Tables VI–VIII and Fig7.</a:t>
             </a:r>
           </a:p>
         </p:txBody>
@@ -1821,12 +2467,46 @@
           <a:lstStyle/>
           <a:p>
             <a:r>
-              <a:t>Source: Chowdhury, A., Raza, H., Meena, Y. K., Dutta, A., &amp; Prasad, G. (2018). Online Covariate Shift Detection-Based Adaptive Brain–Computer Interface to Trigger Hand Exoskeleton Feedback for Neuro-Rehabilitation. IEEE Transactions on Cognitive and Developmental Systems, 10(4), 1070–1080.</a:t>
-            </a:r>
-          </a:p>
-          <a:p>
-            <a:r>
-              <a:t>All limitations on this slide are explicit in the Discussion. Binary classification and fixed frequency bands, plus inability to make direct comparisons with other adaptive BCI systems: p. 1078 right column. Artefacts/noise and preprocessing trade-off: p. 1078 right column. Feedback once per trial: p. 1078 left column. Known labels and assumed cue compliance, proposed partially supervised adaptation and future continuous/asynchronous operation: p. 1079 left column.</a:t>
+              <a:t>PRESENTER PREPARATION — Author-stated limitations</a:t>
+            </a:r>
+          </a:p>
+          <a:p>
+            <a:endParaRPr/>
+          </a:p>
+          <a:p>
+            <a:r>
+              <a:t>Suggested explanation (30–60 seconds):</a:t>
+            </a:r>
+          </a:p>
+          <a:p>
+            <a:r>
+              <a:t>Fixed bands, binary tasks and known cue labels constrain transfer to other settings. The authors also discuss continuous and asynchronous operation as extensions.</a:t>
+            </a:r>
+          </a:p>
+          <a:p>
+            <a:endParaRPr/>
+          </a:p>
+          <a:p>
+            <a:r>
+              <a:t>Likely question and answer:</a:t>
+            </a:r>
+          </a:p>
+          <a:p>
+            <a:r>
+              <a:t>Why are cue labels imperfect? The intended task is known, but actual participant compliance is assumed.</a:t>
+            </a:r>
+          </a:p>
+          <a:p>
+            <a:endParaRPr/>
+          </a:p>
+          <a:p>
+            <a:r>
+              <a:t>Evidence and cautions:</a:t>
+            </a:r>
+          </a:p>
+          <a:p>
+            <a:r>
+              <a:t>Chowdhury IV pp1078–1079. Transition: distinguish these statements from my design-derived critique.</a:t>
             </a:r>
           </a:p>
         </p:txBody>
@@ -1903,12 +2583,46 @@
           <a:lstStyle/>
           <a:p>
             <a:r>
-              <a:t>Source: Chowdhury, A., Raza, H., Meena, Y. K., Dutta, A., &amp; Prasad, G. (2018). Online Covariate Shift Detection-Based Adaptive Brain–Computer Interface to Trigger Hand Exoskeleton Feedback for Neuro-Rehabilitation. IEEE Transactions on Cognitive and Developmental Systems, 10(4), 1070–1080.</a:t>
-            </a:r>
-          </a:p>
-          <a:p>
-            <a:r>
-              <a:t>These are critical interpretations of the reported design, not a list explicitly stated by the authors. Cohort size n = 10 per group limits subgroup/generalisation evidence (§II.D). One 40-trial feedback run does not establish reliability over repeated sessions (§II.B). EEG-NAC was applied offline to data generated in the adaptive condition (§II.E), so this was not a separate randomised online comparison. The outcomes concern decoding, kappa, ITR and detector rates, not longitudinal clinical recovery (§III). This supports online feasibility and decoding benefit, while leaving durable rehabilitation efficacy unresolved.</a:t>
+              <a:t>PRESENTER PREPARATION — Design-derived limitations</a:t>
+            </a:r>
+          </a:p>
+          <a:p>
+            <a:endParaRPr/>
+          </a:p>
+          <a:p>
+            <a:r>
+              <a:t>Suggested explanation (30–60 seconds):</a:t>
+            </a:r>
+          </a:p>
+          <a:p>
+            <a:r>
+              <a:t>My critical interpretation concerns small cohorts, a short feedback run and the offline baseline. The study supports short-term feasibility; it leaves generalisation and therapeutic efficacy unresolved.</a:t>
+            </a:r>
+          </a:p>
+          <a:p>
+            <a:endParaRPr/>
+          </a:p>
+          <a:p>
+            <a:r>
+              <a:t>Likely question and answer:</a:t>
+            </a:r>
+          </a:p>
+          <a:p>
+            <a:r>
+              <a:t>Are these author admissions? These are inferences from the protocol and outcome measures, not all direct limitations stated by the authors.</a:t>
+            </a:r>
+          </a:p>
+          <a:p>
+            <a:endParaRPr/>
+          </a:p>
+          <a:p>
+            <a:r>
+              <a:t>Evidence and cautions:</a:t>
+            </a:r>
+          </a:p>
+          <a:p>
+            <a:r>
+              <a:t>Chowdhury II.B p1072; II.D–E p1073; III pp1075–1077. Notion limitations page reviewed.</a:t>
             </a:r>
           </a:p>
         </p:txBody>
@@ -1985,12 +2699,46 @@
           <a:lstStyle/>
           <a:p>
             <a:r>
-              <a:t>Source: Chowdhury, A., Raza, H., Meena, Y. K., Dutta, A., &amp; Prasad, G. (2018). Online Covariate Shift Detection-Based Adaptive Brain–Computer Interface to Trigger Hand Exoskeleton Feedback for Neuro-Rehabilitation. IEEE Transactions on Cognitive and Developmental Systems, 10(4), 1070–1080.</a:t>
-            </a:r>
-          </a:p>
-          <a:p>
-            <a:r>
-              <a:t>Project mapping uses only the supplied presentation snapshot. It is not a fresh repository audit. Paper: two fixed bands, four CSP features, PC1 for Stage-I, multivariate Hotelling validation, supervised SVM adaptation, online exoskeleton feedback. Deck: ten-band FBCSP pipeline on BCI Competition IV 2A/2B, reproduction/discrepancy audit, separate classifier benchmark, complementary score/residual monitoring. Proposed priorities retain the deck’s configuration-locked rerun, Stage-II diagnostics and synthetic false-alarm/delay evaluation. No claim of clinical deployment or numerical reproduction is added.</a:t>
+              <a:t>PRESENTER PREPARATION — Paper-to-project bridge</a:t>
+            </a:r>
+          </a:p>
+          <a:p>
+            <a:endParaRPr/>
+          </a:p>
+          <a:p>
+            <a:r>
+              <a:t>Suggested explanation (30–60 seconds):</a:t>
+            </a:r>
+          </a:p>
+          <a:p>
+            <a:r>
+              <a:t>The shared mechanism is warning, validation and selective adaptation. The paper uses two bands and four CSP features; the repository uses ten-band FBCSP for its Competition protocols. I preserve those distinctions when interpreting reproduction.</a:t>
+            </a:r>
+          </a:p>
+          <a:p>
+            <a:endParaRPr/>
+          </a:p>
+          <a:p>
+            <a:r>
+              <a:t>Likely question and answer:</a:t>
+            </a:r>
+          </a:p>
+          <a:p>
+            <a:r>
+              <a:t>Why not copy every paper detail? Some temporal sample and update-batch choices are underspecified; alternatives should be named and tested.</a:t>
+            </a:r>
+          </a:p>
+          <a:p>
+            <a:endParaRPr/>
+          </a:p>
+          <a:p>
+            <a:r>
+              <a:t>Evidence and cautions:</a:t>
+            </a:r>
+          </a:p>
+          <a:p>
+            <a:r>
+              <a:t>Notion Methods &amp; equation evidence audit; PhD questions &amp; repository connections.</a:t>
             </a:r>
           </a:p>
         </p:txBody>
@@ -6178,7 +6926,7 @@
                 </a:solidFill>
                 <a:latin typeface="Aptos"/>
               </a:rPr>
-              <a:t>Stage-I and Stage-II equations</a:t>
+              <a:t>Detector equations and the selected validation mode</a:t>
             </a:r>
           </a:p>
         </p:txBody>
@@ -6248,7 +6996,7 @@
                 </a:solidFill>
                 <a:latin typeface="Aptos"/>
               </a:rPr>
-              <a:t>A compact equation view of how PCA scores become warnings, and how warnings become validated shifts.</a:t>
+              <a:t>Stage I follows the EWMA lineage. Stage II below is the repository’s paper_two_sample mode.</a:t>
             </a:r>
           </a:p>
         </p:txBody>
@@ -6345,7 +7093,7 @@
           <p:nvPr/>
         </p:nvPicPr>
         <p:blipFill>
-          <a:blip r:embed="rId2"/>
+          <a:blip r:embed="rId3"/>
           <a:stretch>
             <a:fillRect/>
           </a:stretch>
@@ -6658,65 +7406,6 @@
           <p:nvPr/>
         </p:nvPicPr>
         <p:blipFill>
-          <a:blip r:embed="rId3"/>
-          <a:stretch>
-            <a:fillRect/>
-          </a:stretch>
-        </p:blipFill>
-        <p:spPr>
-          <a:xfrm>
-            <a:off x="1100000" y="3540000"/>
-            <a:ext cx="2052239" cy="250000"/>
-          </a:xfrm>
-          <a:prstGeom prst="rect">
-            <a:avLst/>
-          </a:prstGeom>
-        </p:spPr>
-      </p:pic>
-      <p:sp>
-        <p:nvSpPr>
-          <p:cNvPr id="17" name="TextBox 16"/>
-          <p:cNvSpPr txBox="1"/>
-          <p:nvPr/>
-        </p:nvSpPr>
-        <p:spPr>
-          <a:xfrm>
-            <a:off x="1100000" y="3890000"/>
-            <a:ext cx="3200000" cy="150000"/>
-          </a:xfrm>
-          <a:prstGeom prst="rect">
-            <a:avLst/>
-          </a:prstGeom>
-          <a:noFill/>
-        </p:spPr>
-        <p:txBody>
-          <a:bodyPr wrap="square" lIns="0" tIns="0" rIns="0" bIns="0">
-            <a:spAutoFit/>
-          </a:bodyPr>
-          <a:lstStyle/>
-          <a:p>
-            <a:pPr algn="l"/>
-            <a:r>
-              <a:rPr sz="1300" b="1">
-                <a:solidFill>
-                  <a:srgbClr val="3FEEE0"/>
-                </a:solidFill>
-                <a:latin typeface="Aptos"/>
-              </a:rPr>
-              <a:t>One-step-ahead prediction error</a:t>
-            </a:r>
-          </a:p>
-        </p:txBody>
-      </p:sp>
-      <p:pic>
-        <p:nvPicPr>
-          <p:cNvPr id="18" name="Picture 17" descr="image.png"/>
-          <p:cNvPicPr>
-            <a:picLocks noChangeAspect="1"/>
-          </p:cNvPicPr>
-          <p:nvPr/>
-        </p:nvPicPr>
-        <p:blipFill>
           <a:blip r:embed="rId4"/>
           <a:stretch>
             <a:fillRect/>
@@ -6724,8 +7413,8 @@
         </p:blipFill>
         <p:spPr>
           <a:xfrm>
-            <a:off x="1100000" y="4060000"/>
-            <a:ext cx="1253130" cy="240000"/>
+            <a:off x="1100000" y="3540000"/>
+            <a:ext cx="2052239" cy="250000"/>
           </a:xfrm>
           <a:prstGeom prst="rect">
             <a:avLst/>
@@ -6734,13 +7423,13 @@
       </p:pic>
       <p:sp>
         <p:nvSpPr>
-          <p:cNvPr id="19" name="TextBox 18"/>
+          <p:cNvPr id="17" name="TextBox 16"/>
           <p:cNvSpPr txBox="1"/>
           <p:nvPr/>
         </p:nvSpPr>
         <p:spPr>
           <a:xfrm>
-            <a:off x="1100000" y="4390000"/>
+            <a:off x="1100000" y="3890000"/>
             <a:ext cx="3200000" cy="150000"/>
           </a:xfrm>
           <a:prstGeom prst="rect">
@@ -6762,14 +7451,14 @@
                 </a:solidFill>
                 <a:latin typeface="Aptos"/>
               </a:rPr>
-              <a:t>Warning boundaries</a:t>
+              <a:t>One-step-ahead prediction error</a:t>
             </a:r>
           </a:p>
         </p:txBody>
       </p:sp>
       <p:pic>
         <p:nvPicPr>
-          <p:cNvPr id="20" name="Picture 19" descr="image.png"/>
+          <p:cNvPr id="18" name="Picture 17" descr="image.png"/>
           <p:cNvPicPr>
             <a:picLocks noChangeAspect="1"/>
           </p:cNvPicPr>
@@ -6783,6 +7472,65 @@
         </p:blipFill>
         <p:spPr>
           <a:xfrm>
+            <a:off x="1100000" y="4060000"/>
+            <a:ext cx="1253130" cy="240000"/>
+          </a:xfrm>
+          <a:prstGeom prst="rect">
+            <a:avLst/>
+          </a:prstGeom>
+        </p:spPr>
+      </p:pic>
+      <p:sp>
+        <p:nvSpPr>
+          <p:cNvPr id="19" name="TextBox 18"/>
+          <p:cNvSpPr txBox="1"/>
+          <p:nvPr/>
+        </p:nvSpPr>
+        <p:spPr>
+          <a:xfrm>
+            <a:off x="1100000" y="4390000"/>
+            <a:ext cx="3200000" cy="150000"/>
+          </a:xfrm>
+          <a:prstGeom prst="rect">
+            <a:avLst/>
+          </a:prstGeom>
+          <a:noFill/>
+        </p:spPr>
+        <p:txBody>
+          <a:bodyPr wrap="square" lIns="0" tIns="0" rIns="0" bIns="0">
+            <a:spAutoFit/>
+          </a:bodyPr>
+          <a:lstStyle/>
+          <a:p>
+            <a:pPr algn="l"/>
+            <a:r>
+              <a:rPr sz="1300" b="1">
+                <a:solidFill>
+                  <a:srgbClr val="3FEEE0"/>
+                </a:solidFill>
+                <a:latin typeface="Aptos"/>
+              </a:rPr>
+              <a:t>Warning boundaries</a:t>
+            </a:r>
+          </a:p>
+        </p:txBody>
+      </p:sp>
+      <p:pic>
+        <p:nvPicPr>
+          <p:cNvPr id="20" name="Picture 19" descr="image.png"/>
+          <p:cNvPicPr>
+            <a:picLocks noChangeAspect="1"/>
+          </p:cNvPicPr>
+          <p:nvPr/>
+        </p:nvPicPr>
+        <p:blipFill>
+          <a:blip r:embed="rId6"/>
+          <a:stretch>
+            <a:fillRect/>
+          </a:stretch>
+        </p:blipFill>
+        <p:spPr>
+          <a:xfrm>
             <a:off x="1100000" y="4560000"/>
             <a:ext cx="3219847" cy="185000"/>
           </a:xfrm>
@@ -6800,100 +7548,6 @@
           <p:nvPr/>
         </p:nvPicPr>
         <p:blipFill>
-          <a:blip r:embed="rId6"/>
-          <a:stretch>
-            <a:fillRect/>
-          </a:stretch>
-        </p:blipFill>
-        <p:spPr>
-          <a:xfrm>
-            <a:off x="1100000" y="4935000"/>
-            <a:ext cx="2252240" cy="235000"/>
-          </a:xfrm>
-          <a:prstGeom prst="rect">
-            <a:avLst/>
-          </a:prstGeom>
-        </p:spPr>
-      </p:pic>
-      <p:sp>
-        <p:nvSpPr>
-          <p:cNvPr id="22" name="TextBox 21"/>
-          <p:cNvSpPr txBox="1"/>
-          <p:nvPr/>
-        </p:nvSpPr>
-        <p:spPr>
-          <a:xfrm>
-            <a:off x="6050000" y="2990000"/>
-            <a:ext cx="4550000" cy="250000"/>
-          </a:xfrm>
-          <a:prstGeom prst="rect">
-            <a:avLst/>
-          </a:prstGeom>
-          <a:noFill/>
-        </p:spPr>
-        <p:txBody>
-          <a:bodyPr wrap="square" lIns="0" tIns="0" rIns="0" bIns="0">
-            <a:spAutoFit/>
-          </a:bodyPr>
-          <a:lstStyle/>
-          <a:p>
-            <a:pPr algn="l"/>
-            <a:r>
-              <a:rPr sz="2000" b="1">
-                <a:solidFill>
-                  <a:srgbClr val="EAF0F6"/>
-                </a:solidFill>
-                <a:latin typeface="Aptos"/>
-              </a:rPr>
-              <a:t>Stage II: Hotelling validation</a:t>
-            </a:r>
-          </a:p>
-        </p:txBody>
-      </p:sp>
-      <p:sp>
-        <p:nvSpPr>
-          <p:cNvPr id="23" name="TextBox 22"/>
-          <p:cNvSpPr txBox="1"/>
-          <p:nvPr/>
-        </p:nvSpPr>
-        <p:spPr>
-          <a:xfrm>
-            <a:off x="6050000" y="3450000"/>
-            <a:ext cx="3400000" cy="150000"/>
-          </a:xfrm>
-          <a:prstGeom prst="rect">
-            <a:avLst/>
-          </a:prstGeom>
-          <a:noFill/>
-        </p:spPr>
-        <p:txBody>
-          <a:bodyPr wrap="square" lIns="0" tIns="0" rIns="0" bIns="0">
-            <a:spAutoFit/>
-          </a:bodyPr>
-          <a:lstStyle/>
-          <a:p>
-            <a:pPr algn="l"/>
-            <a:r>
-              <a:rPr sz="1300" b="1">
-                <a:solidFill>
-                  <a:srgbClr val="F5BF42"/>
-                </a:solidFill>
-                <a:latin typeface="Aptos"/>
-              </a:rPr>
-              <a:t>Two-sample validation statistic</a:t>
-            </a:r>
-          </a:p>
-        </p:txBody>
-      </p:sp>
-      <p:pic>
-        <p:nvPicPr>
-          <p:cNvPr id="24" name="Picture 23" descr="image.png"/>
-          <p:cNvPicPr>
-            <a:picLocks noChangeAspect="1"/>
-          </p:cNvPicPr>
-          <p:nvPr/>
-        </p:nvPicPr>
-        <p:blipFill>
           <a:blip r:embed="rId7"/>
           <a:stretch>
             <a:fillRect/>
@@ -6901,8 +7555,8 @@
         </p:blipFill>
         <p:spPr>
           <a:xfrm>
-            <a:off x="6050000" y="3650000"/>
-            <a:ext cx="2656667" cy="285000"/>
+            <a:off x="1100000" y="4935000"/>
+            <a:ext cx="2252240" cy="235000"/>
           </a:xfrm>
           <a:prstGeom prst="rect">
             <a:avLst/>
@@ -6911,14 +7565,14 @@
       </p:pic>
       <p:sp>
         <p:nvSpPr>
-          <p:cNvPr id="25" name="TextBox 24"/>
+          <p:cNvPr id="22" name="TextBox 21"/>
           <p:cNvSpPr txBox="1"/>
           <p:nvPr/>
         </p:nvSpPr>
         <p:spPr>
           <a:xfrm>
-            <a:off x="6050000" y="4230000"/>
-            <a:ext cx="3300000" cy="150000"/>
+            <a:off x="6050000" y="2990000"/>
+            <a:ext cx="4550000" cy="250000"/>
           </a:xfrm>
           <a:prstGeom prst="rect">
             <a:avLst/>
@@ -6933,20 +7587,55 @@
           <a:p>
             <a:pPr algn="l"/>
             <a:r>
-              <a:rPr sz="1300" b="1">
-                <a:solidFill>
-                  <a:srgbClr val="F5BF42"/>
+              <a:rPr sz="2000" b="1">
+                <a:solidFill>
+                  <a:srgbClr val="EAF0F6"/>
                 </a:solidFill>
                 <a:latin typeface="Aptos"/>
               </a:rPr>
-              <a:t>Decision rule</a:t>
+              <a:t>Stage II: Hotelling validation</a:t>
+            </a:r>
+          </a:p>
+        </p:txBody>
+      </p:sp>
+      <p:sp>
+        <p:nvSpPr>
+          <p:cNvPr id="23" name="TextBox 22"/>
+          <p:cNvSpPr txBox="1"/>
+          <p:nvPr/>
+        </p:nvSpPr>
+        <p:spPr>
+          <a:xfrm>
+            <a:off x="6050000" y="3450000"/>
+            <a:ext cx="3400000" cy="150000"/>
+          </a:xfrm>
+          <a:prstGeom prst="rect">
+            <a:avLst/>
+          </a:prstGeom>
+          <a:noFill/>
+        </p:spPr>
+        <p:txBody>
+          <a:bodyPr wrap="square" lIns="0" tIns="0" rIns="0" bIns="0">
+            <a:spAutoFit/>
+          </a:bodyPr>
+          <a:lstStyle/>
+          <a:p>
+            <a:pPr algn="l"/>
+            <a:r>
+              <a:rPr sz="1300" b="1">
+                <a:solidFill>
+                  <a:srgbClr val="F5BF42"/>
+                </a:solidFill>
+                <a:latin typeface="Aptos"/>
+              </a:rPr>
+              <a:t>Two-sample validation statistic</a:t>
             </a:r>
           </a:p>
         </p:txBody>
       </p:sp>
       <p:pic>
         <p:nvPicPr>
-          <p:cNvPr id="26" name="Picture 25" descr="image.png"/>
+          <p:cNvPr id="24" name="Picture 23" descr="image.png"/>
           <p:cNvPicPr>
             <a:picLocks noChangeAspect="1"/>
           </p:cNvPicPr>
@@ -6960,8 +7649,8 @@
         </p:blipFill>
         <p:spPr>
           <a:xfrm>
-            <a:off x="6050000" y="4410000"/>
-            <a:ext cx="1173134" cy="240000"/>
+            <a:off x="6050000" y="3650000"/>
+            <a:ext cx="2656667" cy="285000"/>
           </a:xfrm>
           <a:prstGeom prst="rect">
             <a:avLst/>
@@ -6970,13 +7659,13 @@
       </p:pic>
       <p:sp>
         <p:nvSpPr>
-          <p:cNvPr id="27" name="TextBox 26"/>
+          <p:cNvPr id="25" name="TextBox 24"/>
           <p:cNvSpPr txBox="1"/>
           <p:nvPr/>
         </p:nvSpPr>
         <p:spPr>
           <a:xfrm>
-            <a:off x="6050000" y="4740000"/>
+            <a:off x="6050000" y="4230000"/>
             <a:ext cx="3300000" cy="150000"/>
           </a:xfrm>
           <a:prstGeom prst="rect">
@@ -6998,14 +7687,14 @@
                 </a:solidFill>
                 <a:latin typeface="Aptos"/>
               </a:rPr>
-              <a:t>Stage-II admissibility</a:t>
+              <a:t>Decision rule</a:t>
             </a:r>
           </a:p>
         </p:txBody>
       </p:sp>
       <p:pic>
         <p:nvPicPr>
-          <p:cNvPr id="28" name="Picture 27" descr="image.png"/>
+          <p:cNvPr id="26" name="Picture 25" descr="image.png"/>
           <p:cNvPicPr>
             <a:picLocks noChangeAspect="1"/>
           </p:cNvPicPr>
@@ -7019,6 +7708,65 @@
         </p:blipFill>
         <p:spPr>
           <a:xfrm>
+            <a:off x="6050000" y="4410000"/>
+            <a:ext cx="1173134" cy="240000"/>
+          </a:xfrm>
+          <a:prstGeom prst="rect">
+            <a:avLst/>
+          </a:prstGeom>
+        </p:spPr>
+      </p:pic>
+      <p:sp>
+        <p:nvSpPr>
+          <p:cNvPr id="27" name="TextBox 26"/>
+          <p:cNvSpPr txBox="1"/>
+          <p:nvPr/>
+        </p:nvSpPr>
+        <p:spPr>
+          <a:xfrm>
+            <a:off x="6050000" y="4740000"/>
+            <a:ext cx="3300000" cy="150000"/>
+          </a:xfrm>
+          <a:prstGeom prst="rect">
+            <a:avLst/>
+          </a:prstGeom>
+          <a:noFill/>
+        </p:spPr>
+        <p:txBody>
+          <a:bodyPr wrap="square" lIns="0" tIns="0" rIns="0" bIns="0">
+            <a:spAutoFit/>
+          </a:bodyPr>
+          <a:lstStyle/>
+          <a:p>
+            <a:pPr algn="l"/>
+            <a:r>
+              <a:rPr sz="1300" b="1">
+                <a:solidFill>
+                  <a:srgbClr val="F5BF42"/>
+                </a:solidFill>
+                <a:latin typeface="Aptos"/>
+              </a:rPr>
+              <a:t>Stage-II admissibility</a:t>
+            </a:r>
+          </a:p>
+        </p:txBody>
+      </p:sp>
+      <p:pic>
+        <p:nvPicPr>
+          <p:cNvPr id="28" name="Picture 27" descr="image.png"/>
+          <p:cNvPicPr>
+            <a:picLocks noChangeAspect="1"/>
+          </p:cNvPicPr>
+          <p:nvPr/>
+        </p:nvPicPr>
+        <p:blipFill>
+          <a:blip r:embed="rId10"/>
+          <a:stretch>
+            <a:fillRect/>
+          </a:stretch>
+        </p:blipFill>
+        <p:spPr>
+          <a:xfrm>
             <a:off x="6050000" y="4920000"/>
             <a:ext cx="1351908" cy="230000"/>
           </a:xfrm>
@@ -7122,6 +7870,61 @@
           <a:p>
             <a:r>
               <a:t>11</a:t>
+            </a:r>
+          </a:p>
+        </p:txBody>
+      </p:sp>
+      <p:sp>
+        <p:nvSpPr>
+          <p:cNvPr id="32" name="TextBox 31"/>
+          <p:cNvSpPr txBox="1"/>
+          <p:nvPr/>
+        </p:nvSpPr>
+        <p:spPr>
+          <a:xfrm>
+            <a:off x="685800" y="5605272"/>
+            <a:ext cx="10789920" cy="548640"/>
+          </a:xfrm>
+          <a:prstGeom prst="rect">
+            <a:avLst/>
+          </a:prstGeom>
+          <a:noFill/>
+        </p:spPr>
+        <p:txBody>
+          <a:bodyPr wrap="square" lIns="0" rIns="0">
+            <a:spAutoFit/>
+          </a:bodyPr>
+          <a:lstStyle/>
+          <a:p>
+            <a:pPr>
+              <a:spcAft>
+                <a:spcPts val="800"/>
+              </a:spcAft>
+              <a:defRPr sz="1200" b="0">
+                <a:solidFill>
+                  <a:srgbClr val="9CB0C3"/>
+                </a:solidFill>
+                <a:latin typeface="DejaVu Sans"/>
+              </a:defRPr>
+            </a:pPr>
+            <a:r>
+              <a:t>Chowdhury §II.E.3, Eqs. (3)–(9): Eq. (9) uses separate covariance terms.</a:t>
+            </a:r>
+          </a:p>
+          <a:p>
+            <a:pPr>
+              <a:spcAft>
+                <a:spcPts val="800"/>
+              </a:spcAft>
+              <a:defRPr sz="1200" b="0">
+                <a:solidFill>
+                  <a:srgbClr val="9CB0C3"/>
+                </a:solidFill>
+                <a:latin typeface="DejaVu Sans"/>
+              </a:defRPr>
+            </a:pPr>
+            <a:r>
+              <a:t>The pooled statistic and equal-window rule here are implementation choices, not a direct transcription.</a:t>
             </a:r>
           </a:p>
         </p:txBody>
@@ -11348,7 +12151,7 @@
               </a:defRPr>
             </a:pPr>
             <a:r>
-              <a:t>Saved real EEG and Diethe outputs</a:t>
+              <a:t>Real EEG traces and repeated Diethe runs</a:t>
             </a:r>
           </a:p>
         </p:txBody>
@@ -12697,7 +13500,7 @@
               </a:defRPr>
             </a:pPr>
             <a:r>
-              <a:t>Implemented experiment framework; comparative results still need to be generated and saved.</a:t>
+              <a:t>First five-policy run is saved. Repeated comparisons across scenarios and seeds remain pending.</a:t>
             </a:r>
           </a:p>
           <a:p>
@@ -13411,7 +14214,7 @@
         <p:spPr>
           <a:xfrm>
             <a:off x="612648" y="292608"/>
-            <a:ext cx="10972800" cy="292608"/>
+            <a:ext cx="10972800" cy="320040"/>
           </a:xfrm>
           <a:prstGeom prst="rect">
             <a:avLst/>
@@ -13426,7 +14229,7 @@
           <a:p>
             <a:pPr>
               <a:spcAft>
-                <a:spcPts val="900"/>
+                <a:spcPts val="800"/>
               </a:spcAft>
               <a:defRPr sz="1300" b="1">
                 <a:solidFill>
@@ -13436,7 +14239,7 @@
               </a:defRPr>
             </a:pPr>
             <a:r>
-              <a:t>DIETHE OUTPUT PLAN</a:t>
+              <a:t>DIETHE PILOT RESULT</a:t>
             </a:r>
           </a:p>
         </p:txBody>
@@ -13465,9 +14268,9 @@
           <a:p>
             <a:pPr>
               <a:spcAft>
-                <a:spcPts val="900"/>
+                <a:spcPts val="800"/>
               </a:spcAft>
-              <a:defRPr sz="2700" b="1">
+              <a:defRPr sz="2600" b="1">
                 <a:solidFill>
                   <a:srgbClr val="EAF2F8"/>
                 </a:solidFill>
@@ -13475,7 +14278,7 @@
               </a:defRPr>
             </a:pPr>
             <a:r>
-              <a:t>The next Diethe result is an accuracy–cost comparison</a:t>
+              <a:t>A detected shift does not guarantee a useful update</a:t>
             </a:r>
           </a:p>
         </p:txBody>
@@ -13488,8 +14291,8 @@
         </p:nvSpPr>
         <p:spPr>
           <a:xfrm>
-            <a:off x="612648" y="6053328"/>
-            <a:ext cx="10972800" cy="329184"/>
+            <a:off x="685800" y="1554480"/>
+            <a:ext cx="10789920" cy="457200"/>
           </a:xfrm>
           <a:prstGeom prst="rect">
             <a:avLst/>
@@ -13504,155 +14307,32 @@
           <a:p>
             <a:pPr>
               <a:spcAft>
-                <a:spcPts val="900"/>
+                <a:spcPts val="800"/>
               </a:spcAft>
-              <a:defRPr sz="1100" b="0">
-                <a:solidFill>
-                  <a:srgbClr val="9CB0C3"/>
+              <a:defRPr sz="1800" b="0">
+                <a:solidFill>
+                  <a:srgbClr val="EAF2F8"/>
                 </a:solidFill>
                 <a:latin typeface="DejaVu Sans"/>
               </a:defRPr>
             </a:pPr>
             <a:r>
-              <a:t>Source: scripts/run_diethe_experiment.py and export_experiment(). No committed Diethe run outputs in reviewed tree.</a:t>
-            </a:r>
-          </a:p>
-        </p:txBody>
-      </p:sp>
-      <p:sp>
-        <p:nvSpPr>
-          <p:cNvPr id="5" name="TextBox 4"/>
-          <p:cNvSpPr txBox="1"/>
-          <p:nvPr/>
-        </p:nvSpPr>
-        <p:spPr>
-          <a:xfrm>
-            <a:off x="612648" y="6510528"/>
-            <a:ext cx="9144000" cy="182880"/>
-          </a:xfrm>
-          <a:prstGeom prst="rect">
-            <a:avLst/>
-          </a:prstGeom>
-          <a:noFill/>
-        </p:spPr>
-        <p:txBody>
-          <a:bodyPr wrap="square" lIns="0" rIns="0">
-            <a:spAutoFit/>
-          </a:bodyPr>
-          <a:lstStyle/>
-          <a:p>
-            <a:pPr>
-              <a:spcAft>
-                <a:spcPts val="900"/>
-              </a:spcAft>
-              <a:defRPr sz="800" b="0">
-                <a:solidFill>
-                  <a:srgbClr val="9CB0C3"/>
-                </a:solidFill>
-                <a:latin typeface="DejaVu Sans"/>
-              </a:defRPr>
-            </a:pPr>
-            <a:r>
-              <a:t>hlin863/ewma_covariate_shift_demo</a:t>
-            </a:r>
-          </a:p>
-        </p:txBody>
-      </p:sp>
-      <p:sp>
-        <p:nvSpPr>
-          <p:cNvPr id="6" name="TextBox 5"/>
-          <p:cNvSpPr txBox="1"/>
-          <p:nvPr/>
-        </p:nvSpPr>
-        <p:spPr>
-          <a:xfrm>
-            <a:off x="685800" y="1691640"/>
-            <a:ext cx="10789920" cy="457200"/>
-          </a:xfrm>
-          <a:prstGeom prst="rect">
-            <a:avLst/>
-          </a:prstGeom>
-          <a:noFill/>
-        </p:spPr>
-        <p:txBody>
-          <a:bodyPr wrap="square" lIns="0" rIns="0">
-            <a:spAutoFit/>
-          </a:bodyPr>
-          <a:lstStyle/>
-          <a:p>
-            <a:pPr>
-              <a:spcAft>
-                <a:spcPts val="900"/>
-              </a:spcAft>
-              <a:defRPr sz="2400" b="1">
-                <a:solidFill>
-                  <a:srgbClr val="78D8CC"/>
-                </a:solidFill>
-                <a:latin typeface="DejaVu Sans"/>
-              </a:defRPr>
-            </a:pPr>
-            <a:r>
-              <a:t>Run each scenario across the same 20 seeds</a:t>
-            </a:r>
-          </a:p>
-        </p:txBody>
-      </p:sp>
-      <p:sp>
-        <p:nvSpPr>
-          <p:cNvPr id="7" name="TextBox 6"/>
-          <p:cNvSpPr txBox="1"/>
-          <p:nvPr/>
-        </p:nvSpPr>
-        <p:spPr>
-          <a:xfrm>
-            <a:off x="685800" y="2313432"/>
-            <a:ext cx="10789920" cy="731520"/>
-          </a:xfrm>
-          <a:prstGeom prst="rect">
-            <a:avLst/>
-          </a:prstGeom>
-          <a:noFill/>
-        </p:spPr>
-        <p:txBody>
-          <a:bodyPr wrap="square" lIns="0" rIns="0">
-            <a:spAutoFit/>
-          </a:bodyPr>
-          <a:lstStyle/>
-          <a:p>
-            <a:pPr>
-              <a:spcAft>
-                <a:spcPts val="900"/>
-              </a:spcAft>
-              <a:defRPr sz="2100" b="0">
-                <a:solidFill>
-                  <a:srgbClr val="EAF2F8"/>
-                </a:solidFill>
-                <a:latin typeface="DejaVu Sans"/>
-              </a:defRPr>
-            </a:pPr>
-            <a:r>
-              <a:t>Each run compares all five policies. Keep detector settings, label availability and update scope fixed.</a:t>
+              <a:t>Synthetic feature shift; seed 42; 240 trials; shift starts at index 120.</a:t>
             </a:r>
           </a:p>
         </p:txBody>
       </p:sp>
       <p:graphicFrame>
         <p:nvGraphicFramePr>
-          <p:cNvPr id="8" name="Table 7"/>
+          <p:cNvPr id="5" name="Table 4"/>
           <p:cNvGraphicFramePr>
             <a:graphicFrameLocks noGrp="1"/>
           </p:cNvGraphicFramePr>
-          <p:nvPr>
-            <p:extLst>
-              <p:ext uri="{D42A27DB-BD31-4B8C-83A1-F6EECF244321}">
-                <p14:modId xmlns:p14="http://schemas.microsoft.com/office/powerpoint/2010/main" val="1262304696"/>
-              </p:ext>
-            </p:extLst>
-          </p:nvPr>
+          <p:nvPr/>
         </p:nvGraphicFramePr>
         <p:xfrm>
-          <a:off x="685800" y="3139440"/>
-          <a:ext cx="10789920" cy="2319528"/>
+          <a:off x="685800" y="2148840"/>
+          <a:ext cx="10789920" cy="2423160"/>
         </p:xfrm>
         <a:graphic>
           <a:graphicData uri="http://schemas.openxmlformats.org/drawingml/2006/table">
@@ -13661,29 +14341,43 @@
                 <a:tableStyleId>{5C22544A-7EE6-4342-B048-85BDC9FD1C3A}</a:tableStyleId>
               </a:tblPr>
               <a:tblGrid>
-                <a:gridCol w="3931920">
+                <a:gridCol w="4023360">
                   <a:extLst>
                     <a:ext uri="{9D8B030D-6E8A-4147-A177-3AD203B41FA5}">
                       <a16:colId xmlns:a16="http://schemas.microsoft.com/office/drawing/2014/main" val="20000"/>
                     </a:ext>
                   </a:extLst>
                 </a:gridCol>
-                <a:gridCol w="6858000">
+                <a:gridCol w="2194560">
                   <a:extLst>
                     <a:ext uri="{9D8B030D-6E8A-4147-A177-3AD203B41FA5}">
                       <a16:colId xmlns:a16="http://schemas.microsoft.com/office/drawing/2014/main" val="20001"/>
                     </a:ext>
                   </a:extLst>
                 </a:gridCol>
+                <a:gridCol w="2011680">
+                  <a:extLst>
+                    <a:ext uri="{9D8B030D-6E8A-4147-A177-3AD203B41FA5}">
+                      <a16:colId xmlns:a16="http://schemas.microsoft.com/office/drawing/2014/main" val="20002"/>
+                    </a:ext>
+                  </a:extLst>
+                </a:gridCol>
+                <a:gridCol w="2560320">
+                  <a:extLst>
+                    <a:ext uri="{9D8B030D-6E8A-4147-A177-3AD203B41FA5}">
+                      <a16:colId xmlns:a16="http://schemas.microsoft.com/office/drawing/2014/main" val="20003"/>
+                    </a:ext>
+                  </a:extLst>
+                </a:gridCol>
               </a:tblGrid>
-              <a:tr h="420624">
+              <a:tr h="403860">
                 <a:tc>
                   <a:txBody>
                     <a:bodyPr/>
                     <a:lstStyle/>
                     <a:p>
                       <a:pPr>
-                        <a:defRPr sz="1700" b="1">
+                        <a:defRPr sz="1800" b="1">
                           <a:solidFill>
                             <a:srgbClr val="78D8CC"/>
                           </a:solidFill>
@@ -13691,11 +14385,11 @@
                         </a:defRPr>
                       </a:pPr>
                       <a:r>
-                        <a:t>Saved evidence</a:t>
+                        <a:t>Policy</a:t>
                       </a:r>
                     </a:p>
                   </a:txBody>
-                  <a:tcPr marL="109728" marT="73152">
+                  <a:tcPr marL="109728">
                     <a:solidFill>
                       <a:srgbClr val="142838"/>
                     </a:solidFill>
@@ -13707,7 +14401,7 @@
                     <a:lstStyle/>
                     <a:p>
                       <a:pPr>
-                        <a:defRPr sz="1700" b="1">
+                        <a:defRPr sz="1800" b="1">
                           <a:solidFill>
                             <a:srgbClr val="78D8CC"/>
                           </a:solidFill>
@@ -13715,11 +14409,59 @@
                         </a:defRPr>
                       </a:pPr>
                       <a:r>
-                        <a:t>Purpose</a:t>
+                        <a:t>Accuracy</a:t>
                       </a:r>
                     </a:p>
                   </a:txBody>
-                  <a:tcPr marL="109728" marT="73152">
+                  <a:tcPr marL="109728">
+                    <a:solidFill>
+                      <a:srgbClr val="142838"/>
+                    </a:solidFill>
+                  </a:tcPr>
+                </a:tc>
+                <a:tc>
+                  <a:txBody>
+                    <a:bodyPr/>
+                    <a:lstStyle/>
+                    <a:p>
+                      <a:pPr>
+                        <a:defRPr sz="1800" b="1">
+                          <a:solidFill>
+                            <a:srgbClr val="78D8CC"/>
+                          </a:solidFill>
+                          <a:latin typeface="DejaVu Sans"/>
+                        </a:defRPr>
+                      </a:pPr>
+                      <a:r>
+                        <a:t>Updates</a:t>
+                      </a:r>
+                    </a:p>
+                  </a:txBody>
+                  <a:tcPr marL="109728">
+                    <a:solidFill>
+                      <a:srgbClr val="142838"/>
+                    </a:solidFill>
+                  </a:tcPr>
+                </a:tc>
+                <a:tc>
+                  <a:txBody>
+                    <a:bodyPr/>
+                    <a:lstStyle/>
+                    <a:p>
+                      <a:pPr>
+                        <a:defRPr sz="1800" b="1">
+                          <a:solidFill>
+                            <a:srgbClr val="78D8CC"/>
+                          </a:solidFill>
+                          <a:latin typeface="DejaVu Sans"/>
+                        </a:defRPr>
+                      </a:pPr>
+                      <a:r>
+                        <a:t>Gain vs never</a:t>
+                      </a:r>
+                    </a:p>
+                  </a:txBody>
+                  <a:tcPr marL="109728">
                     <a:solidFill>
                       <a:srgbClr val="142838"/>
                     </a:solidFill>
@@ -13731,14 +14473,14 @@
                   </a:ext>
                 </a:extLst>
               </a:tr>
-              <a:tr h="420624">
+              <a:tr h="403860">
                 <a:tc>
                   <a:txBody>
                     <a:bodyPr/>
                     <a:lstStyle/>
                     <a:p>
                       <a:pPr>
-                        <a:defRPr sz="1700" b="0">
+                        <a:defRPr sz="1800" b="0">
                           <a:solidFill>
                             <a:srgbClr val="EAF2F8"/>
                           </a:solidFill>
@@ -13746,11 +14488,11 @@
                         </a:defRPr>
                       </a:pPr>
                       <a:r>
-                        <a:t>summary.csv</a:t>
+                        <a:t>Never</a:t>
                       </a:r>
                     </a:p>
                   </a:txBody>
-                  <a:tcPr marL="109728" marT="73152">
+                  <a:tcPr marL="109728">
                     <a:solidFill>
                       <a:srgbClr val="101D2A"/>
                     </a:solidFill>
@@ -13762,7 +14504,7 @@
                     <a:lstStyle/>
                     <a:p>
                       <a:pPr>
-                        <a:defRPr sz="1700" b="0">
+                        <a:defRPr sz="1800" b="0">
                           <a:solidFill>
                             <a:srgbClr val="EAF2F8"/>
                           </a:solidFill>
@@ -13770,11 +14512,59 @@
                         </a:defRPr>
                       </a:pPr>
                       <a:r>
-                        <a:t>Accuracy, gain versus never, updates, runtime and training size</a:t>
+                        <a:t>97.92%</a:t>
                       </a:r>
                     </a:p>
                   </a:txBody>
-                  <a:tcPr marL="109728" marT="73152">
+                  <a:tcPr marL="109728">
+                    <a:solidFill>
+                      <a:srgbClr val="101D2A"/>
+                    </a:solidFill>
+                  </a:tcPr>
+                </a:tc>
+                <a:tc>
+                  <a:txBody>
+                    <a:bodyPr/>
+                    <a:lstStyle/>
+                    <a:p>
+                      <a:pPr>
+                        <a:defRPr sz="1800" b="0">
+                          <a:solidFill>
+                            <a:srgbClr val="EAF2F8"/>
+                          </a:solidFill>
+                          <a:latin typeface="DejaVu Sans"/>
+                        </a:defRPr>
+                      </a:pPr>
+                      <a:r>
+                        <a:t>0</a:t>
+                      </a:r>
+                    </a:p>
+                  </a:txBody>
+                  <a:tcPr marL="109728">
+                    <a:solidFill>
+                      <a:srgbClr val="101D2A"/>
+                    </a:solidFill>
+                  </a:tcPr>
+                </a:tc>
+                <a:tc>
+                  <a:txBody>
+                    <a:bodyPr/>
+                    <a:lstStyle/>
+                    <a:p>
+                      <a:pPr>
+                        <a:defRPr sz="1800" b="0">
+                          <a:solidFill>
+                            <a:srgbClr val="EAF2F8"/>
+                          </a:solidFill>
+                          <a:latin typeface="DejaVu Sans"/>
+                        </a:defRPr>
+                      </a:pPr>
+                      <a:r>
+                        <a:t>0.00 pp</a:t>
+                      </a:r>
+                    </a:p>
+                  </a:txBody>
+                  <a:tcPr marL="109728">
                     <a:solidFill>
                       <a:srgbClr val="101D2A"/>
                     </a:solidFill>
@@ -13786,14 +14576,14 @@
                   </a:ext>
                 </a:extLst>
               </a:tr>
-              <a:tr h="420624">
+              <a:tr h="403860">
                 <a:tc>
                   <a:txBody>
                     <a:bodyPr/>
                     <a:lstStyle/>
                     <a:p>
                       <a:pPr>
-                        <a:defRPr sz="1700" b="0">
+                        <a:defRPr sz="1800" b="0">
                           <a:solidFill>
                             <a:srgbClr val="EAF2F8"/>
                           </a:solidFill>
@@ -13801,11 +14591,11 @@
                         </a:defRPr>
                       </a:pPr>
                       <a:r>
-                        <a:t>warnings.csv / validations.csv</a:t>
+                        <a:t>Periodic</a:t>
                       </a:r>
                     </a:p>
                   </a:txBody>
-                  <a:tcPr marL="109728" marT="73152">
+                  <a:tcPr marL="109728">
                     <a:solidFill>
                       <a:srgbClr val="101D2A"/>
                     </a:solidFill>
@@ -13817,7 +14607,7 @@
                     <a:lstStyle/>
                     <a:p>
                       <a:pPr>
-                        <a:defRPr sz="1700" b="0">
+                        <a:defRPr sz="1800" b="0">
                           <a:solidFill>
                             <a:srgbClr val="EAF2F8"/>
                           </a:solidFill>
@@ -13825,11 +14615,59 @@
                         </a:defRPr>
                       </a:pPr>
                       <a:r>
-                        <a:t>Audit detector decisions and confirmation timing</a:t>
+                        <a:t>98.33%</a:t>
                       </a:r>
                     </a:p>
                   </a:txBody>
-                  <a:tcPr marL="109728" marT="73152">
+                  <a:tcPr marL="109728">
+                    <a:solidFill>
+                      <a:srgbClr val="101D2A"/>
+                    </a:solidFill>
+                  </a:tcPr>
+                </a:tc>
+                <a:tc>
+                  <a:txBody>
+                    <a:bodyPr/>
+                    <a:lstStyle/>
+                    <a:p>
+                      <a:pPr>
+                        <a:defRPr sz="1800" b="0">
+                          <a:solidFill>
+                            <a:srgbClr val="EAF2F8"/>
+                          </a:solidFill>
+                          <a:latin typeface="DejaVu Sans"/>
+                        </a:defRPr>
+                      </a:pPr>
+                      <a:r>
+                        <a:t>12</a:t>
+                      </a:r>
+                    </a:p>
+                  </a:txBody>
+                  <a:tcPr marL="109728">
+                    <a:solidFill>
+                      <a:srgbClr val="101D2A"/>
+                    </a:solidFill>
+                  </a:tcPr>
+                </a:tc>
+                <a:tc>
+                  <a:txBody>
+                    <a:bodyPr/>
+                    <a:lstStyle/>
+                    <a:p>
+                      <a:pPr>
+                        <a:defRPr sz="1800" b="0">
+                          <a:solidFill>
+                            <a:srgbClr val="EAF2F8"/>
+                          </a:solidFill>
+                          <a:latin typeface="DejaVu Sans"/>
+                        </a:defRPr>
+                      </a:pPr>
+                      <a:r>
+                        <a:t>+0.42 pp</a:t>
+                      </a:r>
+                    </a:p>
+                  </a:txBody>
+                  <a:tcPr marL="109728">
                     <a:solidFill>
                       <a:srgbClr val="101D2A"/>
                     </a:solidFill>
@@ -13841,14 +14679,14 @@
                   </a:ext>
                 </a:extLst>
               </a:tr>
-              <a:tr h="420624">
+              <a:tr h="403860">
                 <a:tc>
                   <a:txBody>
                     <a:bodyPr/>
                     <a:lstStyle/>
                     <a:p>
                       <a:pPr>
-                        <a:defRPr sz="1700" b="0">
+                        <a:defRPr sz="1800" b="0">
                           <a:solidFill>
                             <a:srgbClr val="EAF2F8"/>
                           </a:solidFill>
@@ -13856,11 +14694,11 @@
                         </a:defRPr>
                       </a:pPr>
                       <a:r>
-                        <a:t>Policy trials / updates CSVs</a:t>
+                        <a:t>Warning</a:t>
                       </a:r>
                     </a:p>
                   </a:txBody>
-                  <a:tcPr marL="109728" marT="73152">
+                  <a:tcPr marL="109728">
                     <a:solidFill>
                       <a:srgbClr val="101D2A"/>
                     </a:solidFill>
@@ -13872,7 +14710,7 @@
                     <a:lstStyle/>
                     <a:p>
                       <a:pPr>
-                        <a:defRPr sz="1700" b="0">
+                        <a:defRPr sz="1800" b="0">
                           <a:solidFill>
                             <a:srgbClr val="EAF2F8"/>
                           </a:solidFill>
@@ -13880,11 +14718,59 @@
                         </a:defRPr>
                       </a:pPr>
                       <a:r>
-                        <a:t>Trace prediction quality and each retraining event</a:t>
+                        <a:t>97.50%</a:t>
                       </a:r>
                     </a:p>
                   </a:txBody>
-                  <a:tcPr marL="109728" marT="73152">
+                  <a:tcPr marL="109728">
+                    <a:solidFill>
+                      <a:srgbClr val="101D2A"/>
+                    </a:solidFill>
+                  </a:tcPr>
+                </a:tc>
+                <a:tc>
+                  <a:txBody>
+                    <a:bodyPr/>
+                    <a:lstStyle/>
+                    <a:p>
+                      <a:pPr>
+                        <a:defRPr sz="1800" b="0">
+                          <a:solidFill>
+                            <a:srgbClr val="EAF2F8"/>
+                          </a:solidFill>
+                          <a:latin typeface="DejaVu Sans"/>
+                        </a:defRPr>
+                      </a:pPr>
+                      <a:r>
+                        <a:t>3</a:t>
+                      </a:r>
+                    </a:p>
+                  </a:txBody>
+                  <a:tcPr marL="109728">
+                    <a:solidFill>
+                      <a:srgbClr val="101D2A"/>
+                    </a:solidFill>
+                  </a:tcPr>
+                </a:tc>
+                <a:tc>
+                  <a:txBody>
+                    <a:bodyPr/>
+                    <a:lstStyle/>
+                    <a:p>
+                      <a:pPr>
+                        <a:defRPr sz="1800" b="0">
+                          <a:solidFill>
+                            <a:srgbClr val="EAF2F8"/>
+                          </a:solidFill>
+                          <a:latin typeface="DejaVu Sans"/>
+                        </a:defRPr>
+                      </a:pPr>
+                      <a:r>
+                        <a:t>−0.42 pp</a:t>
+                      </a:r>
+                    </a:p>
+                  </a:txBody>
+                  <a:tcPr marL="109728">
                     <a:solidFill>
                       <a:srgbClr val="101D2A"/>
                     </a:solidFill>
@@ -13896,14 +14782,14 @@
                   </a:ext>
                 </a:extLst>
               </a:tr>
-              <a:tr h="420624">
+              <a:tr h="403860">
                 <a:tc>
                   <a:txBody>
                     <a:bodyPr/>
                     <a:lstStyle/>
                     <a:p>
                       <a:pPr>
-                        <a:defRPr sz="1700" b="0">
+                        <a:defRPr sz="1800" b="0">
                           <a:solidFill>
                             <a:srgbClr val="EAF2F8"/>
                           </a:solidFill>
@@ -13911,11 +14797,11 @@
                         </a:defRPr>
                       </a:pPr>
                       <a:r>
-                        <a:t>experiment.json</a:t>
+                        <a:t>Validated</a:t>
                       </a:r>
                     </a:p>
                   </a:txBody>
-                  <a:tcPr marL="109728" marT="73152">
+                  <a:tcPr marL="109728">
                     <a:solidFill>
                       <a:srgbClr val="101D2A"/>
                     </a:solidFill>
@@ -13927,7 +14813,7 @@
                     <a:lstStyle/>
                     <a:p>
                       <a:pPr>
-                        <a:defRPr sz="1700" b="0">
+                        <a:defRPr sz="1800" b="0">
                           <a:solidFill>
                             <a:srgbClr val="EAF2F8"/>
                           </a:solidFill>
@@ -13935,12 +14821,59 @@
                         </a:defRPr>
                       </a:pPr>
                       <a:r>
-                        <a:rPr dirty="0"/>
-                        <a:t>Preserve settings, provenance and complete run evidence</a:t>
+                        <a:t>97.50%</a:t>
                       </a:r>
                     </a:p>
                   </a:txBody>
-                  <a:tcPr marL="109728" marT="73152">
+                  <a:tcPr marL="109728">
+                    <a:solidFill>
+                      <a:srgbClr val="101D2A"/>
+                    </a:solidFill>
+                  </a:tcPr>
+                </a:tc>
+                <a:tc>
+                  <a:txBody>
+                    <a:bodyPr/>
+                    <a:lstStyle/>
+                    <a:p>
+                      <a:pPr>
+                        <a:defRPr sz="1800" b="0">
+                          <a:solidFill>
+                            <a:srgbClr val="EAF2F8"/>
+                          </a:solidFill>
+                          <a:latin typeface="DejaVu Sans"/>
+                        </a:defRPr>
+                      </a:pPr>
+                      <a:r>
+                        <a:t>1</a:t>
+                      </a:r>
+                    </a:p>
+                  </a:txBody>
+                  <a:tcPr marL="109728">
+                    <a:solidFill>
+                      <a:srgbClr val="101D2A"/>
+                    </a:solidFill>
+                  </a:tcPr>
+                </a:tc>
+                <a:tc>
+                  <a:txBody>
+                    <a:bodyPr/>
+                    <a:lstStyle/>
+                    <a:p>
+                      <a:pPr>
+                        <a:defRPr sz="1800" b="0">
+                          <a:solidFill>
+                            <a:srgbClr val="EAF2F8"/>
+                          </a:solidFill>
+                          <a:latin typeface="DejaVu Sans"/>
+                        </a:defRPr>
+                      </a:pPr>
+                      <a:r>
+                        <a:t>−0.42 pp</a:t>
+                      </a:r>
+                    </a:p>
+                  </a:txBody>
+                  <a:tcPr marL="109728">
                     <a:solidFill>
                       <a:srgbClr val="101D2A"/>
                     </a:solidFill>
@@ -13952,20 +14885,123 @@
                   </a:ext>
                 </a:extLst>
               </a:tr>
+              <a:tr h="403860">
+                <a:tc>
+                  <a:txBody>
+                    <a:bodyPr/>
+                    <a:lstStyle/>
+                    <a:p>
+                      <a:pPr>
+                        <a:defRPr sz="1800" b="0">
+                          <a:solidFill>
+                            <a:srgbClr val="EAF2F8"/>
+                          </a:solidFill>
+                          <a:latin typeface="DejaVu Sans"/>
+                        </a:defRPr>
+                      </a:pPr>
+                      <a:r>
+                        <a:t>Performance drop</a:t>
+                      </a:r>
+                    </a:p>
+                  </a:txBody>
+                  <a:tcPr marL="109728">
+                    <a:solidFill>
+                      <a:srgbClr val="101D2A"/>
+                    </a:solidFill>
+                  </a:tcPr>
+                </a:tc>
+                <a:tc>
+                  <a:txBody>
+                    <a:bodyPr/>
+                    <a:lstStyle/>
+                    <a:p>
+                      <a:pPr>
+                        <a:defRPr sz="1800" b="0">
+                          <a:solidFill>
+                            <a:srgbClr val="EAF2F8"/>
+                          </a:solidFill>
+                          <a:latin typeface="DejaVu Sans"/>
+                        </a:defRPr>
+                      </a:pPr>
+                      <a:r>
+                        <a:t>97.92%</a:t>
+                      </a:r>
+                    </a:p>
+                  </a:txBody>
+                  <a:tcPr marL="109728">
+                    <a:solidFill>
+                      <a:srgbClr val="101D2A"/>
+                    </a:solidFill>
+                  </a:tcPr>
+                </a:tc>
+                <a:tc>
+                  <a:txBody>
+                    <a:bodyPr/>
+                    <a:lstStyle/>
+                    <a:p>
+                      <a:pPr>
+                        <a:defRPr sz="1800" b="0">
+                          <a:solidFill>
+                            <a:srgbClr val="EAF2F8"/>
+                          </a:solidFill>
+                          <a:latin typeface="DejaVu Sans"/>
+                        </a:defRPr>
+                      </a:pPr>
+                      <a:r>
+                        <a:t>0</a:t>
+                      </a:r>
+                    </a:p>
+                  </a:txBody>
+                  <a:tcPr marL="109728">
+                    <a:solidFill>
+                      <a:srgbClr val="101D2A"/>
+                    </a:solidFill>
+                  </a:tcPr>
+                </a:tc>
+                <a:tc>
+                  <a:txBody>
+                    <a:bodyPr/>
+                    <a:lstStyle/>
+                    <a:p>
+                      <a:pPr>
+                        <a:defRPr sz="1800" b="0">
+                          <a:solidFill>
+                            <a:srgbClr val="EAF2F8"/>
+                          </a:solidFill>
+                          <a:latin typeface="DejaVu Sans"/>
+                        </a:defRPr>
+                      </a:pPr>
+                      <a:r>
+                        <a:t>0.00 pp</a:t>
+                      </a:r>
+                    </a:p>
+                  </a:txBody>
+                  <a:tcPr marL="109728">
+                    <a:solidFill>
+                      <a:srgbClr val="101D2A"/>
+                    </a:solidFill>
+                  </a:tcPr>
+                </a:tc>
+                <a:extLst>
+                  <a:ext uri="{0D108BD9-81ED-4DB2-BD59-A6C34878D82A}">
+                    <a16:rowId xmlns:a16="http://schemas.microsoft.com/office/drawing/2014/main" val="10005"/>
+                  </a:ext>
+                </a:extLst>
+              </a:tr>
             </a:tbl>
           </a:graphicData>
         </a:graphic>
       </p:graphicFrame>
       <p:sp>
         <p:nvSpPr>
-          <p:cNvPr id="9" name="TextBox 8"/>
+          <p:cNvPr id="6" name="TextBox 5"/>
           <p:cNvSpPr txBox="1"/>
           <p:nvPr/>
         </p:nvSpPr>
         <p:spPr>
           <a:xfrm>
-            <a:off x="685800" y="5550408"/>
-            <a:ext cx="10789920" cy="411480"/>
+            <a:off x="685800" y="4846320"/>
+            <a:ext cx="10789920" cy="685800"/>
           </a:xfrm>
           <a:prstGeom prst="rect">
             <a:avLst/>
@@ -13980,9 +15016,9 @@
           <a:p>
             <a:pPr>
               <a:spcAft>
-                <a:spcPts val="900"/>
+                <a:spcPts val="800"/>
               </a:spcAft>
-              <a:defRPr sz="1700" b="0">
+              <a:defRPr sz="1900" b="0">
                 <a:solidFill>
                   <a:srgbClr val="78D8CC"/>
                 </a:solidFill>
@@ -13990,7 +15026,140 @@
               </a:defRPr>
             </a:pPr>
             <a:r>
-              <a:t>Report differences across seeds, including variability. Keep these synthetic results separate from EEG.</a:t>
+              <a:t>Periodic updating gains one correct prediction overall for 12 updates.</a:t>
+            </a:r>
+          </a:p>
+          <a:p>
+            <a:pPr>
+              <a:spcAft>
+                <a:spcPts val="800"/>
+              </a:spcAft>
+              <a:defRPr sz="1900" b="0">
+                <a:solidFill>
+                  <a:srgbClr val="78D8CC"/>
+                </a:solidFill>
+                <a:latin typeface="DejaVu Sans"/>
+              </a:defRPr>
+            </a:pPr>
+            <a:r>
+              <a:t>Validated updating finishes one prediction below never-update.</a:t>
+            </a:r>
+          </a:p>
+        </p:txBody>
+      </p:sp>
+      <p:sp>
+        <p:nvSpPr>
+          <p:cNvPr id="7" name="TextBox 6"/>
+          <p:cNvSpPr txBox="1"/>
+          <p:nvPr/>
+        </p:nvSpPr>
+        <p:spPr>
+          <a:xfrm>
+            <a:off x="685800" y="5641848"/>
+            <a:ext cx="10789920" cy="365760"/>
+          </a:xfrm>
+          <a:prstGeom prst="rect">
+            <a:avLst/>
+          </a:prstGeom>
+          <a:noFill/>
+        </p:spPr>
+        <p:txBody>
+          <a:bodyPr wrap="square" lIns="0" rIns="0">
+            <a:spAutoFit/>
+          </a:bodyPr>
+          <a:lstStyle/>
+          <a:p>
+            <a:pPr>
+              <a:spcAft>
+                <a:spcPts val="800"/>
+              </a:spcAft>
+              <a:defRPr sz="1400" b="0">
+                <a:solidFill>
+                  <a:srgbClr val="9CB0C3"/>
+                </a:solidFill>
+                <a:latin typeface="DejaVu Sans"/>
+              </a:defRPr>
+            </a:pPr>
+            <a:r>
+              <a:t>One-run illustration, not a policy ranking. Next: matched comparisons across scenarios and seeds.</a:t>
+            </a:r>
+          </a:p>
+        </p:txBody>
+      </p:sp>
+      <p:sp>
+        <p:nvSpPr>
+          <p:cNvPr id="8" name="TextBox 7"/>
+          <p:cNvSpPr txBox="1"/>
+          <p:nvPr/>
+        </p:nvSpPr>
+        <p:spPr>
+          <a:xfrm>
+            <a:off x="685800" y="6099048"/>
+            <a:ext cx="10789920" cy="292608"/>
+          </a:xfrm>
+          <a:prstGeom prst="rect">
+            <a:avLst/>
+          </a:prstGeom>
+          <a:noFill/>
+        </p:spPr>
+        <p:txBody>
+          <a:bodyPr wrap="square" lIns="0" rIns="0">
+            <a:spAutoFit/>
+          </a:bodyPr>
+          <a:lstStyle/>
+          <a:p>
+            <a:pPr>
+              <a:spcAft>
+                <a:spcPts val="800"/>
+              </a:spcAft>
+              <a:defRPr sz="1100" b="0">
+                <a:solidFill>
+                  <a:srgbClr val="9CB0C3"/>
+                </a:solidFill>
+                <a:latin typeface="DejaVu Sans"/>
+              </a:defRPr>
+            </a:pPr>
+            <a:r>
+              <a:t>Source: outputs/diethe/20261004T111759599003Z/summary.csv; generating commit 2a8d20b.</a:t>
+            </a:r>
+          </a:p>
+        </p:txBody>
+      </p:sp>
+      <p:sp>
+        <p:nvSpPr>
+          <p:cNvPr id="9" name="TextBox 8"/>
+          <p:cNvSpPr txBox="1"/>
+          <p:nvPr/>
+        </p:nvSpPr>
+        <p:spPr>
+          <a:xfrm>
+            <a:off x="612648" y="6510528"/>
+            <a:ext cx="9144000" cy="182880"/>
+          </a:xfrm>
+          <a:prstGeom prst="rect">
+            <a:avLst/>
+          </a:prstGeom>
+          <a:noFill/>
+        </p:spPr>
+        <p:txBody>
+          <a:bodyPr wrap="square" lIns="0" rIns="0">
+            <a:spAutoFit/>
+          </a:bodyPr>
+          <a:lstStyle/>
+          <a:p>
+            <a:pPr>
+              <a:spcAft>
+                <a:spcPts val="800"/>
+              </a:spcAft>
+              <a:defRPr sz="800" b="0">
+                <a:solidFill>
+                  <a:srgbClr val="9CB0C3"/>
+                </a:solidFill>
+                <a:latin typeface="DejaVu Sans"/>
+              </a:defRPr>
+            </a:pPr>
+            <a:r>
+              <a:t>hlin863/ewma_covariate_shift_demo</a:t>
             </a:r>
           </a:p>
         </p:txBody>
@@ -14019,7 +15188,7 @@
           <a:p>
             <a:pPr>
               <a:spcAft>
-                <a:spcPts val="900"/>
+                <a:spcPts val="800"/>
               </a:spcAft>
               <a:defRPr sz="800" b="0">
                 <a:solidFill>
@@ -14141,45 +15310,6 @@
             </a:pPr>
             <a:r>
               <a:t>Detection and adaptation are implemented</a:t>
-            </a:r>
-          </a:p>
-        </p:txBody>
-      </p:sp>
-      <p:sp>
-        <p:nvSpPr>
-          <p:cNvPr id="4" name="TextBox 3"/>
-          <p:cNvSpPr txBox="1"/>
-          <p:nvPr/>
-        </p:nvSpPr>
-        <p:spPr>
-          <a:xfrm>
-            <a:off x="612648" y="6053328"/>
-            <a:ext cx="10972800" cy="329184"/>
-          </a:xfrm>
-          <a:prstGeom prst="rect">
-            <a:avLst/>
-          </a:prstGeom>
-          <a:noFill/>
-        </p:spPr>
-        <p:txBody>
-          <a:bodyPr wrap="square" lIns="0" rIns="0">
-            <a:spAutoFit/>
-          </a:bodyPr>
-          <a:lstStyle/>
-          <a:p>
-            <a:pPr>
-              <a:spcAft>
-                <a:spcPts val="900"/>
-              </a:spcAft>
-              <a:defRPr sz="1100" b="0">
-                <a:solidFill>
-                  <a:srgbClr val="9CB0C3"/>
-                </a:solidFill>
-                <a:latin typeface="DejaVu Sans"/>
-              </a:defRPr>
-            </a:pPr>
-            <a:r>
-              <a:t>Repository evidence: 2a8d20b. Implemented capabilities and stored results are distinguished.</a:t>
             </a:r>
           </a:p>
         </p:txBody>
@@ -17289,7 +18419,7 @@
               </a:defRPr>
             </a:pPr>
             <a:r>
-              <a:t>Save the three-scenario Diethe comparison across seeds. Export 2A/2B complementary traces.</a:t>
+              <a:t>Extend the saved Diethe pilot across three scenarios and 20 seeds. Export 2A/2B complementary traces.</a:t>
             </a:r>
           </a:p>
         </p:txBody>
@@ -23093,7 +24223,7 @@
                 <a:ea typeface="DejaVu Sans"/>
                 <a:cs typeface="DejaVu Sans"/>
               </a:rPr>
-              <a:t>Sources: Chowdhury et al. (2018), §II.E and §III–IV · supplied deck: pipeline, results and next-milestone slides</a:t>
+              <a:t>Sources: Chowdhury et al. (2018), §II.E and §III–IV; repository review at f3ef2e8.</a:t>
             </a:r>
           </a:p>
         </p:txBody>

</xml_diff>

<commit_message>
Update progress review presentation assets
Adds the PDF export and refreshes the PPTX for the EWMA covariate shift progress review. This update incorporates the latest presentation content and generated deck assets for sharing and review.
</commit_message>
<xml_diff>
--- a/presentations/EWMA_Covariate_Shift_Progress_Review_Haocheng_Lin.pptx
+++ b/presentations/EWMA_Covariate_Shift_Progress_Review_Haocheng_Lin.pptx
@@ -2133,45 +2133,84 @@
           <a:lstStyle/>
           <a:p>
             <a:r>
+              <a:rPr dirty="0"/>
               <a:t>PRESENTER PREPARATION — Research lineage</a:t>
             </a:r>
           </a:p>
           <a:p>
-            <a:endParaRPr/>
-          </a:p>
-          <a:p>
-            <a:r>
+            <a:endParaRPr dirty="0"/>
+          </a:p>
+          <a:p>
+            <a:r>
+              <a:rPr dirty="0"/>
               <a:t>Suggested explanation (30–60 seconds):</a:t>
             </a:r>
           </a:p>
           <a:p>
             <a:r>
-              <a:t>Raza motivates detector reconstruction. Chowdhury demonstrates online supervised BCI adaptation. The later CSE-UAEL work motivates transductive updates and ensembles. Rao and Heyden motivate the subspace question. Diethe provides a maintenance architecture.</a:t>
-            </a:r>
-          </a:p>
-          <a:p>
-            <a:endParaRPr/>
-          </a:p>
-          <a:p>
-            <a:r>
+              <a:rPr dirty="0"/>
+              <a:t>Raza motivates detector reconstruction. Chowdhury demonstrates online supervised BCI adaptation. The later CSE-UAEL work motivates transductive updates and ensembles. Rao and </a:t>
+            </a:r>
+            <a:r>
+              <a:rPr dirty="0" err="1"/>
+              <a:t>Heyden</a:t>
+            </a:r>
+            <a:r>
+              <a:rPr dirty="0"/>
+              <a:t> motivate the subspace question. </a:t>
+            </a:r>
+            <a:r>
+              <a:rPr dirty="0" err="1"/>
+              <a:t>Diethe</a:t>
+            </a:r>
+            <a:r>
+              <a:rPr dirty="0"/>
+              <a:t> provides a maintenance architecture.</a:t>
+            </a:r>
+          </a:p>
+          <a:p>
+            <a:endParaRPr dirty="0"/>
+          </a:p>
+          <a:p>
+            <a:r>
+              <a:rPr dirty="0"/>
               <a:t>Likely question and answer:</a:t>
             </a:r>
           </a:p>
           <a:p>
             <a:r>
-              <a:t>Why Diethe 2019 when Notion says 2018? The supplied PDF identifies a 2018 workshop and arXiv v2 dated March 2019. State the version being cited consistently.</a:t>
-            </a:r>
-          </a:p>
-          <a:p>
-            <a:endParaRPr/>
-          </a:p>
-          <a:p>
-            <a:r>
+              <a:rPr dirty="0"/>
+              <a:t>Why </a:t>
+            </a:r>
+            <a:r>
+              <a:rPr dirty="0" err="1"/>
+              <a:t>Diethe</a:t>
+            </a:r>
+            <a:r>
+              <a:rPr dirty="0"/>
+              <a:t> 2019 when Notion says 2018? The supplied PDF identifies a 2018 workshop and </a:t>
+            </a:r>
+            <a:r>
+              <a:rPr dirty="0" err="1"/>
+              <a:t>arXiv</a:t>
+            </a:r>
+            <a:r>
+              <a:rPr dirty="0"/>
+              <a:t> v2 dated March 2019. State the version being cited consistently.</a:t>
+            </a:r>
+          </a:p>
+          <a:p>
+            <a:endParaRPr dirty="0"/>
+          </a:p>
+          <a:p>
+            <a:r>
+              <a:rPr dirty="0"/>
               <a:t>Evidence and cautions:</a:t>
             </a:r>
           </a:p>
           <a:p>
             <a:r>
+              <a:rPr dirty="0"/>
               <a:t>Transition: first explain what the clinical BCI paper established.</a:t>
             </a:r>
           </a:p>
@@ -5656,7 +5695,7 @@
         <p:spPr>
           <a:xfrm>
             <a:off x="1066800" y="5086350"/>
-            <a:ext cx="3238500" cy="285750"/>
+            <a:ext cx="3238500" cy="533400"/>
           </a:xfrm>
           <a:prstGeom prst="rect">
             <a:avLst/>
@@ -5693,6 +5732,52 @@
                 <a:cs typeface="DejaVu Sans"/>
               </a:rPr>
               <a:t>Haocheng Lin</a:t>
+            </a:r>
+          </a:p>
+          <a:p>
+            <a:pPr algn="l">
+              <a:buNone/>
+              <a:defRPr sz="1200" b="1">
+                <a:solidFill>
+                  <a:srgbClr val="EAF2F8"/>
+                </a:solidFill>
+                <a:latin typeface="DejaVu Sans"/>
+                <a:ea typeface="DejaVu Sans"/>
+                <a:cs typeface="DejaVu Sans"/>
+              </a:defRPr>
+            </a:pPr>
+            <a:r>
+              <a:rPr lang="en-US" sz="1200" b="1" dirty="0">
+                <a:solidFill>
+                  <a:srgbClr val="EAF2F8"/>
+                </a:solidFill>
+                <a:latin typeface="DejaVu Sans"/>
+                <a:ea typeface="DejaVu Sans"/>
+                <a:cs typeface="DejaVu Sans"/>
+              </a:rPr>
+              <a:t>5</a:t>
+            </a:r>
+            <a:r>
+              <a:rPr lang="en-US" sz="1200" b="1" baseline="30000" dirty="0">
+                <a:solidFill>
+                  <a:srgbClr val="EAF2F8"/>
+                </a:solidFill>
+                <a:latin typeface="DejaVu Sans"/>
+                <a:ea typeface="DejaVu Sans"/>
+                <a:cs typeface="DejaVu Sans"/>
+              </a:rPr>
+              <a:t>th</a:t>
+            </a:r>
+            <a:r>
+              <a:rPr lang="en-US" sz="1200" b="1" dirty="0">
+                <a:solidFill>
+                  <a:srgbClr val="EAF2F8"/>
+                </a:solidFill>
+                <a:latin typeface="DejaVu Sans"/>
+                <a:ea typeface="DejaVu Sans"/>
+                <a:cs typeface="DejaVu Sans"/>
+              </a:rPr>
+              <a:t> October 2026</a:t>
             </a:r>
           </a:p>
         </p:txBody>
@@ -11334,7 +11419,7 @@
         </p:nvGraphicFramePr>
         <p:xfrm>
           <a:off x="685800" y="1783080"/>
-          <a:ext cx="10789920" cy="2286000"/>
+          <a:ext cx="10789920" cy="2442972"/>
         </p:xfrm>
         <a:graphic>
           <a:graphicData uri="http://schemas.openxmlformats.org/drawingml/2006/table">
@@ -12780,7 +12865,7 @@
         </p:nvGraphicFramePr>
         <p:xfrm>
           <a:off x="685800" y="1691640"/>
-          <a:ext cx="10789920" cy="3566160"/>
+          <a:ext cx="10789920" cy="3749040"/>
         </p:xfrm>
         <a:graphic>
           <a:graphicData uri="http://schemas.openxmlformats.org/drawingml/2006/table">
@@ -13544,7 +13629,7 @@
         </p:nvGraphicFramePr>
         <p:xfrm>
           <a:off x="685800" y="1783080"/>
-          <a:ext cx="10789920" cy="2926080"/>
+          <a:ext cx="10789920" cy="3264408"/>
         </p:xfrm>
         <a:graphic>
           <a:graphicData uri="http://schemas.openxmlformats.org/drawingml/2006/table">

</xml_diff>

<commit_message>
Update progress review presentation
Refresh the EWMA covariate shift progress review deck by updating the PowerPoint presentation file for the latest review materials and presentation content.
</commit_message>
<xml_diff>
--- a/presentations/EWMA_Covariate_Shift_Progress_Review_Haocheng_Lin.pptx
+++ b/presentations/EWMA_Covariate_Shift_Progress_Review_Haocheng_Lin.pptx
@@ -2174,37 +2174,6 @@
           <a:p>
             <a:r>
               <a:rPr dirty="0"/>
-              <a:t>Likely question and answer:</a:t>
-            </a:r>
-          </a:p>
-          <a:p>
-            <a:r>
-              <a:rPr dirty="0"/>
-              <a:t>Why </a:t>
-            </a:r>
-            <a:r>
-              <a:rPr dirty="0" err="1"/>
-              <a:t>Diethe</a:t>
-            </a:r>
-            <a:r>
-              <a:rPr dirty="0"/>
-              <a:t> 2019 when Notion says 2018? The supplied PDF identifies a 2018 workshop and </a:t>
-            </a:r>
-            <a:r>
-              <a:rPr dirty="0" err="1"/>
-              <a:t>arXiv</a:t>
-            </a:r>
-            <a:r>
-              <a:rPr dirty="0"/>
-              <a:t> v2 dated March 2019. State the version being cited consistently.</a:t>
-            </a:r>
-          </a:p>
-          <a:p>
-            <a:endParaRPr dirty="0"/>
-          </a:p>
-          <a:p>
-            <a:r>
-              <a:rPr dirty="0"/>
               <a:t>Evidence and cautions:</a:t>
             </a:r>
           </a:p>
@@ -2411,45 +2380,56 @@
           <a:lstStyle/>
           <a:p>
             <a:r>
+              <a:rPr dirty="0"/>
               <a:t>PRESENTER PREPARATION — Published accuracy</a:t>
             </a:r>
           </a:p>
           <a:p>
-            <a:endParaRPr/>
-          </a:p>
-          <a:p>
-            <a:r>
+            <a:endParaRPr dirty="0"/>
+          </a:p>
+          <a:p>
+            <a:r>
+              <a:rPr dirty="0"/>
               <a:t>Suggested explanation (30–60 seconds):</a:t>
             </a:r>
           </a:p>
           <a:p>
             <a:r>
-              <a:t>The reported healthy-group gain is 6.25 percentage points and stroke-group gain is 5.50 points. Both paired comparisons were significant. These are paper results, not my repository results.</a:t>
-            </a:r>
-          </a:p>
-          <a:p>
-            <a:endParaRPr/>
-          </a:p>
-          <a:p>
-            <a:r>
-              <a:t>Likely question and answer:</a:t>
-            </a:r>
-          </a:p>
-          <a:p>
-            <a:r>
+              <a:rPr dirty="0"/>
+              <a:t>The reported healthy-group gain is 6.25 percentage points and stroke-group gain is 5.50 points. Both paired comparisons were significant. </a:t>
+            </a:r>
+            <a:endParaRPr lang="en-US" dirty="0"/>
+          </a:p>
+          <a:p>
+            <a:endParaRPr lang="en-GB"/>
+          </a:p>
+          <a:p>
+            <a:r>
+              <a:t>Likely </a:t>
+            </a:r>
+            <a:r>
+              <a:rPr dirty="0"/>
+              <a:t>question and answer:</a:t>
+            </a:r>
+          </a:p>
+          <a:p>
+            <a:r>
+              <a:rPr dirty="0"/>
               <a:t>Does this prove recovery? No. It demonstrates better decoding and online feasibility, without longitudinal motor-recovery outcomes.</a:t>
             </a:r>
           </a:p>
           <a:p>
-            <a:endParaRPr/>
-          </a:p>
-          <a:p>
-            <a:r>
+            <a:endParaRPr dirty="0"/>
+          </a:p>
+          <a:p>
+            <a:r>
+              <a:rPr dirty="0"/>
               <a:t>Evidence and cautions:</a:t>
             </a:r>
           </a:p>
           <a:p>
             <a:r>
+              <a:rPr dirty="0"/>
               <a:t>Chowdhury III p1076 Tables II–IV. Mean ± SD; paired Wilcoxon significance.</a:t>
             </a:r>
           </a:p>
@@ -2875,45 +2855,52 @@
           <a:lstStyle/>
           <a:p>
             <a:r>
+              <a:rPr dirty="0"/>
               <a:t>PRESENTER PREPARATION — Paper-to-project bridge</a:t>
             </a:r>
           </a:p>
           <a:p>
-            <a:endParaRPr/>
-          </a:p>
-          <a:p>
-            <a:r>
+            <a:endParaRPr dirty="0"/>
+          </a:p>
+          <a:p>
+            <a:r>
+              <a:rPr dirty="0"/>
               <a:t>Suggested explanation (30–60 seconds):</a:t>
             </a:r>
           </a:p>
           <a:p>
             <a:r>
+              <a:rPr dirty="0"/>
               <a:t>The shared mechanism is warning, validation and selective adaptation. The paper uses two bands and four CSP features; the repository uses ten-band FBCSP for its Competition protocols. I preserve those distinctions when interpreting reproduction.</a:t>
             </a:r>
           </a:p>
           <a:p>
-            <a:endParaRPr/>
-          </a:p>
-          <a:p>
-            <a:r>
+            <a:endParaRPr dirty="0"/>
+          </a:p>
+          <a:p>
+            <a:r>
+              <a:rPr dirty="0"/>
               <a:t>Likely question and answer:</a:t>
             </a:r>
           </a:p>
           <a:p>
             <a:r>
+              <a:rPr dirty="0"/>
               <a:t>Why not copy every paper detail? Some temporal sample and update-batch choices are underspecified; alternatives should be named and tested.</a:t>
             </a:r>
           </a:p>
           <a:p>
-            <a:endParaRPr/>
-          </a:p>
-          <a:p>
-            <a:r>
+            <a:endParaRPr dirty="0"/>
+          </a:p>
+          <a:p>
+            <a:r>
+              <a:rPr dirty="0"/>
               <a:t>Evidence and cautions:</a:t>
             </a:r>
           </a:p>
           <a:p>
             <a:r>
+              <a:rPr dirty="0"/>
               <a:t>Notion Methods &amp; equation evidence audit; PhD questions &amp; repository connections.</a:t>
             </a:r>
           </a:p>

</xml_diff>

<commit_message>
Update EWMA progress review deck
Refresh the EWMA covariate shift progress review presentation with the latest slide revisions. This update keeps the PowerPoint aligned with the current project status and review materials for sharing with stakeholders.
</commit_message>
<xml_diff>
--- a/presentations/EWMA_Covariate_Shift_Progress_Review_Haocheng_Lin.pptx
+++ b/presentations/EWMA_Covariate_Shift_Progress_Review_Haocheng_Lin.pptx
@@ -5373,6 +5373,109 @@
           <a:chExt cx="0" cy="0"/>
         </a:xfrm>
       </p:grpSpPr>
+      <p:sp>
+        <p:nvSpPr>
+          <p:cNvPr id="2" name="Title 1">
+            <a:extLst>
+              <a:ext uri="{FF2B5EF4-FFF2-40B4-BE49-F238E27FC236}">
+                <a16:creationId xmlns:a16="http://schemas.microsoft.com/office/drawing/2014/main" id="{837C18D0-CB59-4C60-A037-E3E6E0D5805D}"/>
+              </a:ext>
+            </a:extLst>
+          </p:cNvPr>
+          <p:cNvSpPr>
+            <a:spLocks noGrp="1"/>
+          </p:cNvSpPr>
+          <p:nvPr>
+            <p:ph type="title"/>
+          </p:nvPr>
+        </p:nvSpPr>
+        <p:spPr>
+          <a:xfrm>
+            <a:off x="838200" y="365125"/>
+            <a:ext cx="10515600" cy="1325563"/>
+          </a:xfrm>
+          <a:prstGeom prst="rect">
+            <a:avLst/>
+          </a:prstGeom>
+        </p:spPr>
+        <p:txBody>
+          <a:bodyPr/>
+          <a:lstStyle/>
+          <a:p>
+            <a:r>
+              <a:rPr lang="en-US"/>
+              <a:t>Click to edit Master title style</a:t>
+            </a:r>
+            <a:endParaRPr lang="en-GB"/>
+          </a:p>
+        </p:txBody>
+      </p:sp>
+      <p:sp>
+        <p:nvSpPr>
+          <p:cNvPr id="3" name="Text Placeholder 2">
+            <a:extLst>
+              <a:ext uri="{FF2B5EF4-FFF2-40B4-BE49-F238E27FC236}">
+                <a16:creationId xmlns:a16="http://schemas.microsoft.com/office/drawing/2014/main" id="{DEDE194A-AA1B-FE58-2794-728DD084D76A}"/>
+              </a:ext>
+            </a:extLst>
+          </p:cNvPr>
+          <p:cNvSpPr>
+            <a:spLocks noGrp="1"/>
+          </p:cNvSpPr>
+          <p:nvPr>
+            <p:ph type="body" idx="1"/>
+          </p:nvPr>
+        </p:nvSpPr>
+        <p:spPr>
+          <a:xfrm>
+            <a:off x="838200" y="1825625"/>
+            <a:ext cx="10515600" cy="4351338"/>
+          </a:xfrm>
+          <a:prstGeom prst="rect">
+            <a:avLst/>
+          </a:prstGeom>
+        </p:spPr>
+        <p:txBody>
+          <a:bodyPr/>
+          <a:lstStyle/>
+          <a:p>
+            <a:pPr lvl="0"/>
+            <a:r>
+              <a:rPr lang="en-US"/>
+              <a:t>Click to edit Master text styles</a:t>
+            </a:r>
+          </a:p>
+          <a:p>
+            <a:pPr lvl="1"/>
+            <a:r>
+              <a:rPr lang="en-US"/>
+              <a:t>Second level</a:t>
+            </a:r>
+          </a:p>
+          <a:p>
+            <a:pPr lvl="2"/>
+            <a:r>
+              <a:rPr lang="en-US"/>
+              <a:t>Third level</a:t>
+            </a:r>
+          </a:p>
+          <a:p>
+            <a:pPr lvl="3"/>
+            <a:r>
+              <a:rPr lang="en-US"/>
+              <a:t>Fourth level</a:t>
+            </a:r>
+          </a:p>
+          <a:p>
+            <a:pPr lvl="4"/>
+            <a:r>
+              <a:rPr lang="en-US"/>
+              <a:t>Fifth level</a:t>
+            </a:r>
+            <a:endParaRPr lang="en-GB"/>
+          </a:p>
+        </p:txBody>
+      </p:sp>
     </p:spTree>
   </p:cSld>
   <p:clrMapOvr>

</xml_diff>

<commit_message>
Refresh EWMA covariate shift review deck
Update the progress review presentation for the EWMA covariate shift work with revised slides and refreshed project status material.
</commit_message>
<xml_diff>
--- a/presentations/EWMA_Covariate_Shift_Progress_Review_Haocheng_Lin.pptx
+++ b/presentations/EWMA_Covariate_Shift_Progress_Review_Haocheng_Lin.pptx
@@ -6,7 +6,7 @@
     <p:sldMasterId id="2147483656" r:id="rId2"/>
   </p:sldMasterIdLst>
   <p:notesMasterIdLst>
-    <p:notesMasterId r:id="rId44"/>
+    <p:notesMasterId r:id="rId45"/>
   </p:notesMasterIdLst>
   <p:sldIdLst>
     <p:sldId id="256" r:id="rId3"/>
@@ -31,25 +31,26 @@
     <p:sldId id="2006" r:id="rId22"/>
     <p:sldId id="266" r:id="rId23"/>
     <p:sldId id="2018" r:id="rId24"/>
-    <p:sldId id="2019" r:id="rId25"/>
-    <p:sldId id="2022" r:id="rId26"/>
-    <p:sldId id="259" r:id="rId27"/>
-    <p:sldId id="260" r:id="rId28"/>
-    <p:sldId id="265" r:id="rId29"/>
-    <p:sldId id="2000" r:id="rId30"/>
-    <p:sldId id="2007" r:id="rId31"/>
-    <p:sldId id="2001" r:id="rId32"/>
-    <p:sldId id="2011" r:id="rId33"/>
-    <p:sldId id="2004" r:id="rId34"/>
-    <p:sldId id="2002" r:id="rId35"/>
-    <p:sldId id="261" r:id="rId36"/>
-    <p:sldId id="267" r:id="rId37"/>
-    <p:sldId id="262" r:id="rId38"/>
-    <p:sldId id="257" r:id="rId39"/>
-    <p:sldId id="263" r:id="rId40"/>
-    <p:sldId id="264" r:id="rId41"/>
-    <p:sldId id="2020" r:id="rId42"/>
-    <p:sldId id="2012" r:id="rId43"/>
+    <p:sldId id="2023" r:id="rId25"/>
+    <p:sldId id="2019" r:id="rId26"/>
+    <p:sldId id="2022" r:id="rId27"/>
+    <p:sldId id="259" r:id="rId28"/>
+    <p:sldId id="260" r:id="rId29"/>
+    <p:sldId id="265" r:id="rId30"/>
+    <p:sldId id="2000" r:id="rId31"/>
+    <p:sldId id="2007" r:id="rId32"/>
+    <p:sldId id="2001" r:id="rId33"/>
+    <p:sldId id="2011" r:id="rId34"/>
+    <p:sldId id="2004" r:id="rId35"/>
+    <p:sldId id="2002" r:id="rId36"/>
+    <p:sldId id="261" r:id="rId37"/>
+    <p:sldId id="267" r:id="rId38"/>
+    <p:sldId id="262" r:id="rId39"/>
+    <p:sldId id="257" r:id="rId40"/>
+    <p:sldId id="263" r:id="rId41"/>
+    <p:sldId id="264" r:id="rId42"/>
+    <p:sldId id="2020" r:id="rId43"/>
+    <p:sldId id="2012" r:id="rId44"/>
   </p:sldIdLst>
   <p:sldSz cx="12192000" cy="6858000"/>
   <p:notesSz cx="6858000" cy="9144000"/>
@@ -168,7 +169,7 @@
 <file path=ppt/revisionInfo.xml><?xml version="1.0" encoding="utf-8"?>
 <p1510:revInfo xmlns:a="http://schemas.openxmlformats.org/drawingml/2006/main" xmlns:r="http://schemas.openxmlformats.org/officeDocument/2006/relationships" xmlns:p1510="http://schemas.microsoft.com/office/powerpoint/2015/10/main">
   <p1510:revLst>
-    <p1510:client id="{FF0B0085-1191-4CD2-BB45-4C736C8A399D}" v="289" dt="2026-10-04T17:48:46.325"/>
+    <p1510:client id="{D12FD3ED-16D1-43BC-838C-0295E8DA5E05}" v="3" dt="2026-10-14T21:24:36.674"/>
   </p1510:revLst>
 </p1510:revInfo>
 </file>
@@ -177,8 +178,8 @@
 <pc:chgInfo xmlns:a="http://schemas.openxmlformats.org/drawingml/2006/main" xmlns:r="http://schemas.openxmlformats.org/officeDocument/2006/relationships" xmlns:ac="http://schemas.microsoft.com/office/drawing/2013/main/command" xmlns:pc="http://schemas.microsoft.com/office/powerpoint/2013/main/command">
   <pc:docChgLst>
     <pc:chgData name="Haocheng Lin" userId="3c9af17cd41df8cf" providerId="LiveId" clId="{E85DCD58-ED75-4D29-A2F4-F018EE94DF03}"/>
-    <pc:docChg chg="undo custSel addSld modSld">
-      <pc:chgData name="Haocheng Lin" userId="3c9af17cd41df8cf" providerId="LiveId" clId="{E85DCD58-ED75-4D29-A2F4-F018EE94DF03}" dt="2026-10-04T17:49:26.227" v="827" actId="33524"/>
+    <pc:docChg chg="undo custSel addSld modSld sldOrd">
+      <pc:chgData name="Haocheng Lin" userId="3c9af17cd41df8cf" providerId="LiveId" clId="{E85DCD58-ED75-4D29-A2F4-F018EE94DF03}" dt="2026-10-14T21:27:23.270" v="889" actId="1076"/>
       <pc:docMkLst>
         <pc:docMk/>
       </pc:docMkLst>
@@ -188,14 +189,6 @@
           <pc:docMk/>
           <pc:sldMk cId="382100174" sldId="257"/>
         </pc:sldMkLst>
-        <pc:spChg chg="del">
-          <ac:chgData name="Haocheng Lin" userId="3c9af17cd41df8cf" providerId="LiveId" clId="{E85DCD58-ED75-4D29-A2F4-F018EE94DF03}" dt="2026-10-04T12:43:25.747" v="0" actId="21"/>
-          <ac:spMkLst>
-            <pc:docMk/>
-            <pc:sldMk cId="382100174" sldId="257"/>
-            <ac:spMk id="4" creationId="{00000000-0000-0000-0000-000000000000}"/>
-          </ac:spMkLst>
-        </pc:spChg>
       </pc:sldChg>
       <pc:sldChg chg="addSp delSp modSp new mod">
         <pc:chgData name="Haocheng Lin" userId="3c9af17cd41df8cf" providerId="LiveId" clId="{E85DCD58-ED75-4D29-A2F4-F018EE94DF03}" dt="2026-10-04T17:49:26.227" v="827" actId="33524"/>
@@ -203,62 +196,140 @@
           <pc:docMk/>
           <pc:sldMk cId="3893839795" sldId="2003"/>
         </pc:sldMkLst>
+      </pc:sldChg>
+      <pc:sldChg chg="addSp delSp modSp mod">
+        <pc:chgData name="Haocheng Lin" userId="3c9af17cd41df8cf" providerId="LiveId" clId="{E85DCD58-ED75-4D29-A2F4-F018EE94DF03}" dt="2026-10-14T21:24:36.673" v="875" actId="165"/>
+        <pc:sldMkLst>
+          <pc:docMk/>
+          <pc:sldMk cId="0" sldId="2019"/>
+        </pc:sldMkLst>
         <pc:spChg chg="mod">
-          <ac:chgData name="Haocheng Lin" userId="3c9af17cd41df8cf" providerId="LiveId" clId="{E85DCD58-ED75-4D29-A2F4-F018EE94DF03}" dt="2026-10-04T17:17:05.578" v="21" actId="20577"/>
+          <ac:chgData name="Haocheng Lin" userId="3c9af17cd41df8cf" providerId="LiveId" clId="{E85DCD58-ED75-4D29-A2F4-F018EE94DF03}" dt="2026-10-14T19:47:57.382" v="855" actId="1076"/>
           <ac:spMkLst>
             <pc:docMk/>
-            <pc:sldMk cId="3893839795" sldId="2003"/>
-            <ac:spMk id="2" creationId="{774A74E3-97CE-6A4C-ACD3-DD7D9D617C63}"/>
+            <pc:sldMk cId="0" sldId="2019"/>
+            <ac:spMk id="2" creationId="{00000000-0000-0000-0000-000000000000}"/>
           </ac:spMkLst>
         </pc:spChg>
         <pc:spChg chg="mod">
-          <ac:chgData name="Haocheng Lin" userId="3c9af17cd41df8cf" providerId="LiveId" clId="{E85DCD58-ED75-4D29-A2F4-F018EE94DF03}" dt="2026-10-04T17:42:18.710" v="590" actId="1076"/>
+          <ac:chgData name="Haocheng Lin" userId="3c9af17cd41df8cf" providerId="LiveId" clId="{E85DCD58-ED75-4D29-A2F4-F018EE94DF03}" dt="2026-10-14T19:48:00.234" v="856" actId="1076"/>
           <ac:spMkLst>
             <pc:docMk/>
-            <pc:sldMk cId="3893839795" sldId="2003"/>
-            <ac:spMk id="3" creationId="{5CD58622-BD35-E6E5-B3D3-619E58466186}"/>
+            <pc:sldMk cId="0" sldId="2019"/>
+            <ac:spMk id="3" creationId="{00000000-0000-0000-0000-000000000000}"/>
+          </ac:spMkLst>
+        </pc:spChg>
+        <pc:spChg chg="mod">
+          <ac:chgData name="Haocheng Lin" userId="3c9af17cd41df8cf" providerId="LiveId" clId="{E85DCD58-ED75-4D29-A2F4-F018EE94DF03}" dt="2026-10-14T19:48:02.804" v="857" actId="1076"/>
+          <ac:spMkLst>
+            <pc:docMk/>
+            <pc:sldMk cId="0" sldId="2019"/>
+            <ac:spMk id="4" creationId="{00000000-0000-0000-0000-000000000000}"/>
+          </ac:spMkLst>
+        </pc:spChg>
+        <pc:spChg chg="mod">
+          <ac:chgData name="Haocheng Lin" userId="3c9af17cd41df8cf" providerId="LiveId" clId="{E85DCD58-ED75-4D29-A2F4-F018EE94DF03}" dt="2026-10-14T19:48:26.295" v="860" actId="1076"/>
+          <ac:spMkLst>
+            <pc:docMk/>
+            <pc:sldMk cId="0" sldId="2019"/>
+            <ac:spMk id="5" creationId="{00000000-0000-0000-0000-000000000000}"/>
           </ac:spMkLst>
         </pc:spChg>
         <pc:spChg chg="add mod">
-          <ac:chgData name="Haocheng Lin" userId="3c9af17cd41df8cf" providerId="LiveId" clId="{E85DCD58-ED75-4D29-A2F4-F018EE94DF03}" dt="2026-10-04T17:45:06.677" v="631" actId="20577"/>
+          <ac:chgData name="Haocheng Lin" userId="3c9af17cd41df8cf" providerId="LiveId" clId="{E85DCD58-ED75-4D29-A2F4-F018EE94DF03}" dt="2026-10-14T21:20:44.687" v="869"/>
           <ac:spMkLst>
             <pc:docMk/>
-            <pc:sldMk cId="3893839795" sldId="2003"/>
-            <ac:spMk id="4" creationId="{752A63EC-D83F-813E-17DC-BBBE3E8DA5E9}"/>
+            <pc:sldMk cId="0" sldId="2019"/>
+            <ac:spMk id="13" creationId="{CF1264DA-1C2B-2111-7C35-134145E7BB60}"/>
           </ac:spMkLst>
         </pc:spChg>
         <pc:spChg chg="add mod">
-          <ac:chgData name="Haocheng Lin" userId="3c9af17cd41df8cf" providerId="LiveId" clId="{E85DCD58-ED75-4D29-A2F4-F018EE94DF03}" dt="2026-10-04T17:42:20.353" v="591" actId="1076"/>
+          <ac:chgData name="Haocheng Lin" userId="3c9af17cd41df8cf" providerId="LiveId" clId="{E85DCD58-ED75-4D29-A2F4-F018EE94DF03}" dt="2026-10-14T21:21:11.763" v="874" actId="1076"/>
           <ac:spMkLst>
             <pc:docMk/>
-            <pc:sldMk cId="3893839795" sldId="2003"/>
-            <ac:spMk id="5" creationId="{B038B561-5D0A-3A3B-745F-0091ABFE0DE3}"/>
+            <pc:sldMk cId="0" sldId="2019"/>
+            <ac:spMk id="15" creationId="{97443EED-4670-231B-BAEF-6E83C20CDB1D}"/>
           </ac:spMkLst>
         </pc:spChg>
-        <pc:spChg chg="add mod">
-          <ac:chgData name="Haocheng Lin" userId="3c9af17cd41df8cf" providerId="LiveId" clId="{E85DCD58-ED75-4D29-A2F4-F018EE94DF03}" dt="2026-10-04T17:48:35.327" v="701" actId="20577"/>
+        <pc:grpChg chg="add del mod">
+          <ac:chgData name="Haocheng Lin" userId="3c9af17cd41df8cf" providerId="LiveId" clId="{E85DCD58-ED75-4D29-A2F4-F018EE94DF03}" dt="2026-10-14T21:24:36.673" v="875" actId="165"/>
+          <ac:grpSpMkLst>
+            <pc:docMk/>
+            <pc:sldMk cId="0" sldId="2019"/>
+            <ac:grpSpMk id="11" creationId="{016BC880-81E3-CF96-6F6A-2DF633888080}"/>
+          </ac:grpSpMkLst>
+        </pc:grpChg>
+        <pc:picChg chg="add mod topLvl">
+          <ac:chgData name="Haocheng Lin" userId="3c9af17cd41df8cf" providerId="LiveId" clId="{E85DCD58-ED75-4D29-A2F4-F018EE94DF03}" dt="2026-10-14T21:24:36.673" v="875" actId="165"/>
+          <ac:picMkLst>
+            <pc:docMk/>
+            <pc:sldMk cId="0" sldId="2019"/>
+            <ac:picMk id="7" creationId="{E789E289-557F-BD8B-1BE3-522242889EDF}"/>
+          </ac:picMkLst>
+        </pc:picChg>
+        <pc:picChg chg="add mod topLvl">
+          <ac:chgData name="Haocheng Lin" userId="3c9af17cd41df8cf" providerId="LiveId" clId="{E85DCD58-ED75-4D29-A2F4-F018EE94DF03}" dt="2026-10-14T21:24:36.673" v="875" actId="165"/>
+          <ac:picMkLst>
+            <pc:docMk/>
+            <pc:sldMk cId="0" sldId="2019"/>
+            <ac:picMk id="9" creationId="{CC8EFED8-B9CE-3033-A10F-2CC5696B5A3A}"/>
+          </ac:picMkLst>
+        </pc:picChg>
+        <pc:picChg chg="mod topLvl">
+          <ac:chgData name="Haocheng Lin" userId="3c9af17cd41df8cf" providerId="LiveId" clId="{E85DCD58-ED75-4D29-A2F4-F018EE94DF03}" dt="2026-10-14T21:24:36.673" v="875" actId="165"/>
+          <ac:picMkLst>
+            <pc:docMk/>
+            <pc:sldMk cId="0" sldId="2019"/>
+            <ac:picMk id="10" creationId="{354B7A09-1E07-4180-B52D-402295125511}"/>
+          </ac:picMkLst>
+        </pc:picChg>
+      </pc:sldChg>
+      <pc:sldChg chg="delSp modSp add mod ord">
+        <pc:chgData name="Haocheng Lin" userId="3c9af17cd41df8cf" providerId="LiveId" clId="{E85DCD58-ED75-4D29-A2F4-F018EE94DF03}" dt="2026-10-14T21:27:23.270" v="889" actId="1076"/>
+        <pc:sldMkLst>
+          <pc:docMk/>
+          <pc:sldMk cId="937479140" sldId="2023"/>
+        </pc:sldMkLst>
+        <pc:spChg chg="del">
+          <ac:chgData name="Haocheng Lin" userId="3c9af17cd41df8cf" providerId="LiveId" clId="{E85DCD58-ED75-4D29-A2F4-F018EE94DF03}" dt="2026-10-14T21:27:11.987" v="885" actId="21"/>
           <ac:spMkLst>
             <pc:docMk/>
-            <pc:sldMk cId="3893839795" sldId="2003"/>
-            <ac:spMk id="6" creationId="{402F12F1-7434-BEB9-97B4-080C2A95E2CA}"/>
+            <pc:sldMk cId="937479140" sldId="2023"/>
+            <ac:spMk id="13" creationId="{7DD78DB3-8C7C-D845-0E9F-6806742D73BF}"/>
           </ac:spMkLst>
         </pc:spChg>
-        <pc:spChg chg="add mod">
-          <ac:chgData name="Haocheng Lin" userId="3c9af17cd41df8cf" providerId="LiveId" clId="{E85DCD58-ED75-4D29-A2F4-F018EE94DF03}" dt="2026-10-04T17:49:26.227" v="827" actId="33524"/>
+        <pc:spChg chg="del">
+          <ac:chgData name="Haocheng Lin" userId="3c9af17cd41df8cf" providerId="LiveId" clId="{E85DCD58-ED75-4D29-A2F4-F018EE94DF03}" dt="2026-10-14T21:27:14.229" v="886" actId="21"/>
           <ac:spMkLst>
             <pc:docMk/>
-            <pc:sldMk cId="3893839795" sldId="2003"/>
-            <ac:spMk id="7" creationId="{CAAE5F16-4F44-3150-AE3E-F4F76B9681F5}"/>
+            <pc:sldMk cId="937479140" sldId="2023"/>
+            <ac:spMk id="15" creationId="{ECC2749A-4767-7A22-9C0A-7C09EF8F14FA}"/>
           </ac:spMkLst>
         </pc:spChg>
-        <pc:graphicFrameChg chg="add del">
-          <ac:chgData name="Haocheng Lin" userId="3c9af17cd41df8cf" providerId="LiveId" clId="{E85DCD58-ED75-4D29-A2F4-F018EE94DF03}" dt="2026-10-04T17:17:39.454" v="32" actId="3680"/>
-          <ac:graphicFrameMkLst>
+        <pc:picChg chg="mod">
+          <ac:chgData name="Haocheng Lin" userId="3c9af17cd41df8cf" providerId="LiveId" clId="{E85DCD58-ED75-4D29-A2F4-F018EE94DF03}" dt="2026-10-14T21:27:23.270" v="889" actId="1076"/>
+          <ac:picMkLst>
             <pc:docMk/>
-            <pc:sldMk cId="3893839795" sldId="2003"/>
-            <ac:graphicFrameMk id="4" creationId="{D378B802-4C4F-5D1D-025E-1D99D4086F8B}"/>
-          </ac:graphicFrameMkLst>
-        </pc:graphicFrameChg>
+            <pc:sldMk cId="937479140" sldId="2023"/>
+            <ac:picMk id="7" creationId="{157D2653-FAA5-57E0-59EC-75C28649CE38}"/>
+          </ac:picMkLst>
+        </pc:picChg>
+        <pc:picChg chg="del">
+          <ac:chgData name="Haocheng Lin" userId="3c9af17cd41df8cf" providerId="LiveId" clId="{E85DCD58-ED75-4D29-A2F4-F018EE94DF03}" dt="2026-10-14T21:24:53.092" v="879" actId="21"/>
+          <ac:picMkLst>
+            <pc:docMk/>
+            <pc:sldMk cId="937479140" sldId="2023"/>
+            <ac:picMk id="9" creationId="{425A36B3-36C1-0D2A-C89A-37F534C4E786}"/>
+          </ac:picMkLst>
+        </pc:picChg>
+        <pc:picChg chg="del">
+          <ac:chgData name="Haocheng Lin" userId="3c9af17cd41df8cf" providerId="LiveId" clId="{E85DCD58-ED75-4D29-A2F4-F018EE94DF03}" dt="2026-10-14T21:24:53.092" v="879" actId="21"/>
+          <ac:picMkLst>
+            <pc:docMk/>
+            <pc:sldMk cId="937479140" sldId="2023"/>
+            <ac:picMk id="10" creationId="{75AA3339-59BA-507D-43C6-03B983CAEF37}"/>
+          </ac:picMkLst>
+        </pc:picChg>
       </pc:sldChg>
     </pc:docChg>
   </pc:docChgLst>
@@ -1490,7 +1561,13 @@
   <p:cSld>
     <p:spTree>
       <p:nvGrpSpPr>
-        <p:cNvPr id="1" name=""/>
+        <p:cNvPr id="1" name="">
+          <a:extLst>
+            <a:ext uri="{FF2B5EF4-FFF2-40B4-BE49-F238E27FC236}">
+              <a16:creationId xmlns:a16="http://schemas.microsoft.com/office/drawing/2014/main" id="{3F04429E-C6AD-7ED5-0E8A-5AA2B4729453}"/>
+            </a:ext>
+          </a:extLst>
+        </p:cNvPr>
         <p:cNvGrpSpPr/>
         <p:nvPr/>
       </p:nvGrpSpPr>
@@ -1504,7 +1581,13 @@
       </p:grpSpPr>
       <p:sp>
         <p:nvSpPr>
-          <p:cNvPr id="2" name="Slide Image Placeholder 1"/>
+          <p:cNvPr id="2" name="Slide Image Placeholder 1">
+            <a:extLst>
+              <a:ext uri="{FF2B5EF4-FFF2-40B4-BE49-F238E27FC236}">
+                <a16:creationId xmlns:a16="http://schemas.microsoft.com/office/drawing/2014/main" id="{947E0E8F-4EFA-095E-5536-5A6E4FE1E20D}"/>
+              </a:ext>
+            </a:extLst>
+          </p:cNvPr>
           <p:cNvSpPr>
             <a:spLocks noGrp="1" noRot="1" noChangeAspect="1"/>
           </p:cNvSpPr>
@@ -1516,7 +1599,13 @@
       </p:sp>
       <p:sp>
         <p:nvSpPr>
-          <p:cNvPr id="3" name="Notes Placeholder 2"/>
+          <p:cNvPr id="3" name="Notes Placeholder 2">
+            <a:extLst>
+              <a:ext uri="{FF2B5EF4-FFF2-40B4-BE49-F238E27FC236}">
+                <a16:creationId xmlns:a16="http://schemas.microsoft.com/office/drawing/2014/main" id="{28F2A413-B30F-7D92-9522-54EC50FF585E}"/>
+              </a:ext>
+            </a:extLst>
+          </p:cNvPr>
           <p:cNvSpPr>
             <a:spLocks noGrp="1"/>
           </p:cNvSpPr>
@@ -1547,7 +1636,13 @@
       </p:sp>
       <p:sp>
         <p:nvSpPr>
-          <p:cNvPr id="4" name="Slide Number Placeholder 3"/>
+          <p:cNvPr id="4" name="Slide Number Placeholder 3">
+            <a:extLst>
+              <a:ext uri="{FF2B5EF4-FFF2-40B4-BE49-F238E27FC236}">
+                <a16:creationId xmlns:a16="http://schemas.microsoft.com/office/drawing/2014/main" id="{1BDFB686-6329-C126-3F51-19843DF81E6B}"/>
+              </a:ext>
+            </a:extLst>
+          </p:cNvPr>
           <p:cNvSpPr>
             <a:spLocks noGrp="1"/>
           </p:cNvSpPr>
@@ -1558,6 +1653,11 @@
         <p:spPr/>
       </p:sp>
     </p:spTree>
+    <p:extLst>
+      <p:ext uri="{BB962C8B-B14F-4D97-AF65-F5344CB8AC3E}">
+        <p14:creationId xmlns:p14="http://schemas.microsoft.com/office/powerpoint/2010/main" val="3286308089"/>
+      </p:ext>
+    </p:extLst>
   </p:cSld>
   <p:clrMapOvr>
     <a:masterClrMapping/>
@@ -1709,11 +1809,6 @@
         <p:spPr/>
       </p:sp>
     </p:spTree>
-    <p:extLst>
-      <p:ext uri="{BB962C8B-B14F-4D97-AF65-F5344CB8AC3E}">
-        <p14:creationId xmlns:p14="http://schemas.microsoft.com/office/powerpoint/2010/main" val="2335197144"/>
-      </p:ext>
-    </p:extLst>
   </p:cSld>
   <p:clrMapOvr>
     <a:masterClrMapping/>
@@ -1745,7 +1840,7 @@
             <a:spLocks noGrp="1" noRot="1" noChangeAspect="1"/>
           </p:cNvSpPr>
           <p:nvPr>
-            <p:ph type="sldImg"/>
+            <p:ph type="sldImg" idx="2"/>
           </p:nvPr>
         </p:nvSpPr>
         <p:spPr/>
@@ -1757,7 +1852,7 @@
             <a:spLocks noGrp="1"/>
           </p:cNvSpPr>
           <p:nvPr>
-            <p:ph type="body" idx="1"/>
+            <p:ph type="body" sz="quarter" idx="3"/>
           </p:nvPr>
         </p:nvSpPr>
         <p:spPr/>
@@ -1765,54 +1860,18 @@
           <a:bodyPr/>
           <a:lstStyle/>
           <a:p>
-            <a:r>
-              <a:rPr dirty="0"/>
-              <a:t>PRESENTER PREPARATION — Implementation responsibilities</a:t>
-            </a:r>
-          </a:p>
-          <a:p>
             <a:endParaRPr dirty="0"/>
           </a:p>
           <a:p>
             <a:r>
               <a:rPr dirty="0"/>
-              <a:t>Suggested explanation (30–60 seconds):</a:t>
-            </a:r>
-          </a:p>
-          <a:p>
-            <a:r>
-              <a:rPr dirty="0"/>
-              <a:t>The update policy consumes evidence. A warning, a confirmation and performance deterioration are different signals. Labels can be supervised or pseudo-labelled. The current Diethe experiment uses fixed CSE, not the complementary score/residual extension.</a:t>
-            </a:r>
-          </a:p>
-          <a:p>
-            <a:endParaRPr dirty="0"/>
-          </a:p>
-          <a:p>
-            <a:r>
-              <a:rPr dirty="0"/>
-              <a:t>Likely question and answer:</a:t>
-            </a:r>
-          </a:p>
-          <a:p>
-            <a:r>
-              <a:rPr dirty="0"/>
-              <a:t>Is the whole model continuously learning? The current loop appends data and retrains; representation and detector stay fixed in Diethe.</a:t>
-            </a:r>
-          </a:p>
-          <a:p>
-            <a:endParaRPr dirty="0"/>
-          </a:p>
-          <a:p>
-            <a:r>
-              <a:rPr dirty="0"/>
-              <a:t>Evidence and cautions:</a:t>
-            </a:r>
-          </a:p>
-          <a:p>
-            <a:r>
-              <a:rPr dirty="0"/>
-              <a:t>src/adaptation/experiments/diethe.py and docs/diethe_experiments.md.</a:t>
+              <a:t>Formula source (LaTeX): Q=(\bar{x}_1-\bar{x}_2)^{\mathsf{T}}\left(\frac{S_1}{n_1}+\frac{S_2}{n_2}\right)^{-1}(\bar{x}_1-\bar{x}_2)</a:t>
+            </a:r>
+          </a:p>
+          <a:p>
+            <a:r>
+              <a:rPr dirty="0"/>
+              <a:t>Updated 12 October 2026. Research discussion and current Park Notion notes provide the learning context. No fresh repository audit was performed. Existing numerical results retain their historical provenance. Park full-text retrieval was unavailable, so explanatory identities are not labelled as exact Park equations.</a:t>
             </a:r>
           </a:p>
         </p:txBody>
@@ -1824,19 +1883,17 @@
             <a:spLocks noGrp="1"/>
           </p:cNvSpPr>
           <p:nvPr>
-            <p:ph type="sldNum" idx="5"/>
+            <p:ph type="sldNum" sz="quarter" idx="5"/>
           </p:nvPr>
         </p:nvSpPr>
         <p:spPr/>
-        <p:txBody>
-          <a:bodyPr/>
-          <a:lstStyle/>
-          <a:p>
-            <a:endParaRPr dirty="0"/>
-          </a:p>
-        </p:txBody>
       </p:sp>
     </p:spTree>
+    <p:extLst>
+      <p:ext uri="{BB962C8B-B14F-4D97-AF65-F5344CB8AC3E}">
+        <p14:creationId xmlns:p14="http://schemas.microsoft.com/office/powerpoint/2010/main" val="2335197144"/>
+      </p:ext>
+    </p:extLst>
   </p:cSld>
   <p:clrMapOvr>
     <a:masterClrMapping/>
@@ -1890,7 +1947,7 @@
           <a:p>
             <a:r>
               <a:rPr dirty="0"/>
-              <a:t>PRESENTER PREPARATION — Protocol separation</a:t>
+              <a:t>PRESENTER PREPARATION — Implementation responsibilities</a:t>
             </a:r>
           </a:p>
           <a:p>
@@ -1905,7 +1962,7 @@
           <a:p>
             <a:r>
               <a:rPr dirty="0"/>
-              <a:t>Fit preprocessing only on development training data and reuse it for held-out evaluation. CSE reproduction and classifier benchmarking have distinct split contracts.</a:t>
+              <a:t>The update policy consumes evidence. A warning, a confirmation and performance deterioration are different signals. Labels can be supervised or pseudo-labelled. The current Diethe experiment uses fixed CSE, not the complementary score/residual extension.</a:t>
             </a:r>
           </a:p>
           <a:p>
@@ -1920,7 +1977,7 @@
           <a:p>
             <a:r>
               <a:rPr dirty="0"/>
-              <a:t>Why does 2B use different sessions in different slides? Different experiments answer different questions. Use the protocol table on slide16 to keep them explicit.</a:t>
+              <a:t>Is the whole model continuously learning? The current loop appends data and retrains; representation and detector stay fixed in Diethe.</a:t>
             </a:r>
           </a:p>
           <a:p>
@@ -1935,7 +1992,7 @@
           <a:p>
             <a:r>
               <a:rPr dirty="0"/>
-              <a:t>Repository dataset runners and stored bagging evaluation_scope fields.</a:t>
+              <a:t>src/adaptation/experiments/diethe.py and docs/diethe_experiments.md.</a:t>
             </a:r>
           </a:p>
         </p:txBody>
@@ -2013,7 +2070,7 @@
           <a:p>
             <a:r>
               <a:rPr dirty="0"/>
-              <a:t>PRESENTER PREPARATION — Dataset roles</a:t>
+              <a:t>PRESENTER PREPARATION — Protocol separation</a:t>
             </a:r>
           </a:p>
           <a:p>
@@ -2028,7 +2085,7 @@
           <a:p>
             <a:r>
               <a:rPr dirty="0"/>
-              <a:t>Read this as a protocol map. For complementary 2B, I–II fit the representation, III calibrates thresholds, and IV–V evaluate. That differs from the classifier benchmark and Table-I path.</a:t>
+              <a:t>Fit preprocessing only on development training data and reuse it for held-out evaluation. CSE reproduction and classifier benchmarking have distinct split contracts.</a:t>
             </a:r>
           </a:p>
           <a:p>
@@ -2043,7 +2100,7 @@
           <a:p>
             <a:r>
               <a:rPr dirty="0"/>
-              <a:t>Are real EEG warnings true detections? They are descriptive alarms unless independently annotated or experimentally injected shifts provide ground truth.</a:t>
+              <a:t>Why does 2B use different sessions in different slides? Different experiments answer different questions. Use the protocol table on slide16 to keep them explicit.</a:t>
             </a:r>
           </a:p>
           <a:p>
@@ -2058,7 +2115,7 @@
           <a:p>
             <a:r>
               <a:rPr dirty="0"/>
-              <a:t>scripts/run_complementary_bci.py. Prepared Diethe arrays require the caller to enforce non-overlapping splits.</a:t>
+              <a:t>Repository dataset runners and stored bagging evaluation_scope fields.</a:t>
             </a:r>
           </a:p>
         </p:txBody>
@@ -2083,11 +2140,6 @@
         </p:txBody>
       </p:sp>
     </p:spTree>
-    <p:extLst>
-      <p:ext uri="{BB962C8B-B14F-4D97-AF65-F5344CB8AC3E}">
-        <p14:creationId xmlns:p14="http://schemas.microsoft.com/office/powerpoint/2010/main" val="1771693600"/>
-      </p:ext>
-    </p:extLst>
   </p:cSld>
   <p:clrMapOvr>
     <a:masterClrMapping/>
@@ -2119,7 +2171,7 @@
             <a:spLocks noGrp="1" noRot="1" noChangeAspect="1"/>
           </p:cNvSpPr>
           <p:nvPr>
-            <p:ph type="sldImg" idx="2"/>
+            <p:ph type="sldImg"/>
           </p:nvPr>
         </p:nvSpPr>
         <p:spPr/>
@@ -2131,7 +2183,7 @@
             <a:spLocks noGrp="1"/>
           </p:cNvSpPr>
           <p:nvPr>
-            <p:ph type="body" sz="quarter" idx="3"/>
+            <p:ph type="body" idx="1"/>
           </p:nvPr>
         </p:nvSpPr>
         <p:spPr/>
@@ -2141,7 +2193,7 @@
           <a:p>
             <a:r>
               <a:rPr dirty="0"/>
-              <a:t>PRESENTER PREPARATION — Diethe architecture</a:t>
+              <a:t>PRESENTER PREPARATION — Dataset roles</a:t>
             </a:r>
           </a:p>
           <a:p>
@@ -2156,7 +2208,7 @@
           <a:p>
             <a:r>
               <a:rPr dirty="0"/>
-              <a:t>Diethe separates data monitoring, prediction monitoring and update policy. My implementation operationalises part of this architecture using five explicit rules and saved evidence.</a:t>
+              <a:t>Read this as a protocol map. For complementary 2B, I–II fit the representation, III calibrates thresholds, and IV–V evaluate. That differs from the classifier benchmark and Table-I path.</a:t>
             </a:r>
           </a:p>
           <a:p>
@@ -2171,7 +2223,7 @@
           <a:p>
             <a:r>
               <a:rPr dirty="0"/>
-              <a:t>Have you implemented Diethe completely? No. The paper discusses much broader state, actions, provenance and policy learning. My rules do not implement rollback, learned policy optimisation or energy accounting.</a:t>
+              <a:t>Are real EEG warnings true detections? They are descriptive alarms unless independently annotated or experimentally injected shifts provide ground truth.</a:t>
             </a:r>
           </a:p>
           <a:p>
@@ -2186,7 +2238,7 @@
           <a:p>
             <a:r>
               <a:rPr dirty="0"/>
-              <a:t>Supplied Diethe PDF: §4.1–4.2 and §5 p4; §5.2 p5; §3.3 p3. First run now saved.</a:t>
+              <a:t>scripts/run_complementary_bci.py. Prepared Diethe arrays require the caller to enforce non-overlapping splits.</a:t>
             </a:r>
           </a:p>
         </p:txBody>
@@ -2198,12 +2250,24 @@
             <a:spLocks noGrp="1"/>
           </p:cNvSpPr>
           <p:nvPr>
-            <p:ph type="sldNum" sz="quarter" idx="5"/>
+            <p:ph type="sldNum" idx="5"/>
           </p:nvPr>
         </p:nvSpPr>
         <p:spPr/>
+        <p:txBody>
+          <a:bodyPr/>
+          <a:lstStyle/>
+          <a:p>
+            <a:endParaRPr dirty="0"/>
+          </a:p>
+        </p:txBody>
       </p:sp>
     </p:spTree>
+    <p:extLst>
+      <p:ext uri="{BB962C8B-B14F-4D97-AF65-F5344CB8AC3E}">
+        <p14:creationId xmlns:p14="http://schemas.microsoft.com/office/powerpoint/2010/main" val="1771693600"/>
+      </p:ext>
+    </p:extLst>
   </p:cSld>
   <p:clrMapOvr>
     <a:masterClrMapping/>
@@ -2257,7 +2321,52 @@
           <a:p>
             <a:r>
               <a:rPr dirty="0"/>
-              <a:t>Synthetic feature vectors are provided directly to the Diethe policy comparison. PCA belongs to a detector branch; do not claim that the comparison passed through EEG or FBCSP. Clearly separate current repository implementation from the cited reference architecture.</a:t>
+              <a:t>PRESENTER PREPARATION — Diethe architecture</a:t>
+            </a:r>
+          </a:p>
+          <a:p>
+            <a:endParaRPr dirty="0"/>
+          </a:p>
+          <a:p>
+            <a:r>
+              <a:rPr dirty="0"/>
+              <a:t>Suggested explanation (30–60 seconds):</a:t>
+            </a:r>
+          </a:p>
+          <a:p>
+            <a:r>
+              <a:rPr dirty="0"/>
+              <a:t>Diethe separates data monitoring, prediction monitoring and update policy. My implementation operationalises part of this architecture using five explicit rules and saved evidence.</a:t>
+            </a:r>
+          </a:p>
+          <a:p>
+            <a:endParaRPr dirty="0"/>
+          </a:p>
+          <a:p>
+            <a:r>
+              <a:rPr dirty="0"/>
+              <a:t>Likely question and answer:</a:t>
+            </a:r>
+          </a:p>
+          <a:p>
+            <a:r>
+              <a:rPr dirty="0"/>
+              <a:t>Have you implemented Diethe completely? No. The paper discusses much broader state, actions, provenance and policy learning. My rules do not implement rollback, learned policy optimisation or energy accounting.</a:t>
+            </a:r>
+          </a:p>
+          <a:p>
+            <a:endParaRPr dirty="0"/>
+          </a:p>
+          <a:p>
+            <a:r>
+              <a:rPr dirty="0"/>
+              <a:t>Evidence and cautions:</a:t>
+            </a:r>
+          </a:p>
+          <a:p>
+            <a:r>
+              <a:rPr dirty="0"/>
+              <a:t>Supplied Diethe PDF: §4.1–4.2 and §5 p4; §5.2 p5; §3.3 p3. First run now saved.</a:t>
             </a:r>
           </a:p>
         </p:txBody>
@@ -2328,52 +2437,7 @@
           <a:p>
             <a:r>
               <a:rPr dirty="0"/>
-              <a:t>PRESENTER PREPARATION — Controlled scenarios</a:t>
-            </a:r>
-          </a:p>
-          <a:p>
-            <a:endParaRPr dirty="0"/>
-          </a:p>
-          <a:p>
-            <a:r>
-              <a:rPr dirty="0"/>
-              <a:t>Suggested explanation (30–60 seconds):</a:t>
-            </a:r>
-          </a:p>
-          <a:p>
-            <a:r>
-              <a:rPr dirty="0"/>
-              <a:t>No shift measures baseline burden. Feature shift changes inputs while preserving the label rule. Relationship shift changes the label rule with the same input stream, so input monitoring can miss performance deterioration.</a:t>
-            </a:r>
-          </a:p>
-          <a:p>
-            <a:endParaRPr dirty="0"/>
-          </a:p>
-          <a:p>
-            <a:r>
-              <a:rPr dirty="0"/>
-              <a:t>Likely question and answer:</a:t>
-            </a:r>
-          </a:p>
-          <a:p>
-            <a:r>
-              <a:rPr dirty="0"/>
-              <a:t>When are labels available? Immediately after prediction, before any update. The validated policy waits for validation_time, not the earlier warning time.</a:t>
-            </a:r>
-          </a:p>
-          <a:p>
-            <a:endParaRPr dirty="0"/>
-          </a:p>
-          <a:p>
-            <a:r>
-              <a:rPr dirty="0"/>
-              <a:t>Evidence and cautions:</a:t>
-            </a:r>
-          </a:p>
-          <a:p>
-            <a:r>
-              <a:rPr dirty="0"/>
-              <a:t>DietheConfig: 120 training, 80 validation, 240 evaluation observations by default. These are feature vectors, not raw EEG.</a:t>
+              <a:t>Synthetic feature vectors are provided directly to the Diethe policy comparison. PCA belongs to a detector branch; do not claim that the comparison passed through EEG or FBCSP. Clearly separate current repository implementation from the cited reference architecture.</a:t>
             </a:r>
           </a:p>
         </p:txBody>
@@ -2444,7 +2508,7 @@
           <a:p>
             <a:r>
               <a:rPr dirty="0"/>
-              <a:t>PRESENTER PREPARATION — First Diethe result</a:t>
+              <a:t>PRESENTER PREPARATION — Controlled scenarios</a:t>
             </a:r>
           </a:p>
           <a:p>
@@ -2459,7 +2523,7 @@
           <a:p>
             <a:r>
               <a:rPr dirty="0"/>
-              <a:t>The unchanged model gets 235 of 240 predictions correct. Periodic updating gets 236 with 12 updates. Warning and validated policies get 234; performance-drop matches never with zero updates. This illustrates why detection and update utility should be assessed separately.</a:t>
+              <a:t>No shift measures baseline burden. Feature shift changes inputs while preserving the label rule. Relationship shift changes the label rule with the same input stream, so input monitoring can miss performance deterioration.</a:t>
             </a:r>
           </a:p>
           <a:p>
@@ -2474,7 +2538,7 @@
           <a:p>
             <a:r>
               <a:rPr dirty="0"/>
-              <a:t>Is periodic best? Not established from one seed. Post-change accuracy is 99.17% for never and performance-drop versus 98.33% for the other three. The one-prediction overall advantage does not establish post-shift benefit.</a:t>
+              <a:t>When are labels available? Immediately after prediction, before any update. The validated policy waits for validation_time, not the earlier warning time.</a:t>
             </a:r>
           </a:p>
           <a:p>
@@ -2489,7 +2553,7 @@
           <a:p>
             <a:r>
               <a:rPr dirty="0"/>
-              <a:t>Run 20261004T111759599003Z: feature_shift seed42 magnitude2; source commit2a8d20b. Three warnings; two rejected and one confirmed. Warning116 validates136, spanning true change120: do not label it an advance detection. Shared detector time≈29.71ms; retraining≈12.53ms periodic,3.12ms warning,1.21ms validated. Timing is one-machine wall time, not energy. Final periodic update239 cannot improve another prediction in this run.</a:t>
+              <a:t>DietheConfig: 120 training, 80 validation, 240 evaluation observations by default. These are feature vectors, not raw EEG.</a:t>
             </a:r>
           </a:p>
         </p:txBody>
@@ -2538,7 +2602,7 @@
             <a:spLocks noGrp="1" noRot="1" noChangeAspect="1"/>
           </p:cNvSpPr>
           <p:nvPr>
-            <p:ph type="sldImg"/>
+            <p:ph type="sldImg" idx="2"/>
           </p:nvPr>
         </p:nvSpPr>
         <p:spPr/>
@@ -2550,7 +2614,7 @@
             <a:spLocks noGrp="1"/>
           </p:cNvSpPr>
           <p:nvPr>
-            <p:ph type="body" idx="1"/>
+            <p:ph type="body" sz="quarter" idx="3"/>
           </p:nvPr>
         </p:nvSpPr>
         <p:spPr/>
@@ -2560,7 +2624,7 @@
           <a:p>
             <a:r>
               <a:rPr dirty="0"/>
-              <a:t>PRESENTER PREPARATION — Stored benchmark evidence</a:t>
+              <a:t>PRESENTER PREPARATION — First Diethe result</a:t>
             </a:r>
           </a:p>
           <a:p>
@@ -2575,7 +2639,7 @@
           <a:p>
             <a:r>
               <a:rPr dirty="0"/>
-              <a:t>Bagging changes accuracy only slightly and inconsistently across datasets. In synthetic monitoring, residuals detect orthogonal shifts missed by PC1, but combination has sensitivity and alarm-burden trade-offs.</a:t>
+              <a:t>The unchanged model gets 235 of 240 predictions correct. Periodic updating gets 236 with 12 updates. Warning and validated policies get 234; performance-drop matches never with zero updates. This illustrates why detection and update utility should be assessed separately.</a:t>
             </a:r>
           </a:p>
           <a:p>
@@ -2590,7 +2654,7 @@
           <a:p>
             <a:r>
               <a:rPr dirty="0"/>
-              <a:t>Does 100% PC2 detection establish superiority? Only for the specified synthetic conditions. The no-change window alarm rate and PC1 trade-off must also be reported.</a:t>
+              <a:t>Is periodic best? Not established from one seed. Post-change accuracy is 99.17% for never and performance-drop versus 98.33% for the other three. The one-prediction overall advantage does not establish post-shift benefit.</a:t>
             </a:r>
           </a:p>
           <a:p>
@@ -2605,7 +2669,7 @@
           <a:p>
             <a:r>
               <a:rPr dirty="0"/>
-              <a:t>outputs/metrics/bagging_bci_real.csv; outputs/complementary_100/summary.csv; magnitude6 summary. CI numbers on slide are explicitly the 2a8d20b snapshot, not a new test run.</a:t>
+              <a:t>Run 20261004T111759599003Z: feature_shift seed42 magnitude2; source commit2a8d20b. Three warnings; two rejected and one confirmed. Warning116 validates136, spanning true change120: do not label it an advance detection. Shared detector time≈29.71ms; retraining≈12.53ms periodic,3.12ms warning,1.21ms validated. Timing is one-machine wall time, not energy. Final periodic update239 cannot improve another prediction in this run.</a:t>
             </a:r>
           </a:p>
         </p:txBody>
@@ -2617,17 +2681,10 @@
             <a:spLocks noGrp="1"/>
           </p:cNvSpPr>
           <p:nvPr>
-            <p:ph type="sldNum" idx="5"/>
+            <p:ph type="sldNum" sz="quarter" idx="5"/>
           </p:nvPr>
         </p:nvSpPr>
         <p:spPr/>
-        <p:txBody>
-          <a:bodyPr/>
-          <a:lstStyle/>
-          <a:p>
-            <a:endParaRPr dirty="0"/>
-          </a:p>
-        </p:txBody>
       </p:sp>
     </p:spTree>
   </p:cSld>
@@ -2683,7 +2740,7 @@
           <a:p>
             <a:r>
               <a:rPr dirty="0"/>
-              <a:t>PRESENTER PREPARATION — B01 discrepancy</a:t>
+              <a:t>PRESENTER PREPARATION — Stored benchmark evidence</a:t>
             </a:r>
           </a:p>
           <a:p>
@@ -2698,7 +2755,7 @@
           <a:p>
             <a:r>
               <a:rPr dirty="0"/>
-              <a:t>Two committed files agree on 17 warnings but disagree on validated totals, five versus zero. This is why result provenance matters. I cannot infer that one run supersedes the other from these tables alone.</a:t>
+              <a:t>Bagging changes accuracy only slightly and inconsistently across datasets. In synthetic monitoring, residuals detect orthogonal shifts missed by PC1, but combination has sensitivity and alarm-burden trade-offs.</a:t>
             </a:r>
           </a:p>
           <a:p>
@@ -2713,7 +2770,7 @@
           <a:p>
             <a:r>
               <a:rPr dirty="0"/>
-              <a:t>What caused the difference? Not established by the saved CSVs. Check validation mode, windows, covariance, input representation and generating configuration.</a:t>
+              <a:t>Does 100% PC2 detection establish superiority? Only for the specified synthetic conditions. The no-change window alarm rate and PC1 trade-off must also be reported.</a:t>
             </a:r>
           </a:p>
           <a:p>
@@ -2728,7 +2785,7 @@
           <a:p>
             <a:r>
               <a:rPr dirty="0"/>
-              <a:t>outputs/metrics/bci_2b_table1_results.csv and bci_table1_comparison.csv.</a:t>
+              <a:t>outputs/metrics/bagging_bci_real.csv; outputs/complementary_100/summary.csv; magnitude6 summary. CI numbers on slide are explicitly the 2a8d20b snapshot, not a new test run.</a:t>
             </a:r>
           </a:p>
         </p:txBody>
@@ -2753,11 +2810,6 @@
         </p:txBody>
       </p:sp>
     </p:spTree>
-    <p:extLst>
-      <p:ext uri="{BB962C8B-B14F-4D97-AF65-F5344CB8AC3E}">
-        <p14:creationId xmlns:p14="http://schemas.microsoft.com/office/powerpoint/2010/main" val="251427986"/>
-      </p:ext>
-    </p:extLst>
   </p:cSld>
   <p:clrMapOvr>
     <a:masterClrMapping/>
@@ -2934,7 +2986,7 @@
           <a:p>
             <a:r>
               <a:rPr dirty="0"/>
-              <a:t>PRESENTER PREPARATION — Reproduction boundary</a:t>
+              <a:t>PRESENTER PREPARATION — B01 discrepancy</a:t>
             </a:r>
           </a:p>
           <a:p>
@@ -2949,7 +3001,7 @@
           <a:p>
             <a:r>
               <a:rPr dirty="0"/>
-              <a:t>The combined results remain far below published validation counts. I can claim an executable reconstruction with measured discrepancies, but cannot claim numerical reproduction.</a:t>
+              <a:t>Two committed files agree on 17 warnings but disagree on validated totals, five versus zero. This is why result provenance matters. I cannot infer that one run supersedes the other from these tables alone.</a:t>
             </a:r>
           </a:p>
           <a:p>
@@ -2964,7 +3016,7 @@
           <a:p>
             <a:r>
               <a:rPr dirty="0"/>
-              <a:t>Should parameters be tuned to match published test counts? That would risk fitting to the evaluation target. Select on development data and report sensitivity separately.</a:t>
+              <a:t>What caused the difference? Not established by the saved CSVs. Check validation mode, windows, covariance, input representation and generating configuration.</a:t>
             </a:r>
           </a:p>
           <a:p>
@@ -2979,7 +3031,7 @@
           <a:p>
             <a:r>
               <a:rPr dirty="0"/>
-              <a:t>Combined Table-I file; means across nine subjects in each dataset. Not the standalone B01 result.</a:t>
+              <a:t>outputs/metrics/bci_2b_table1_results.csv and bci_table1_comparison.csv.</a:t>
             </a:r>
           </a:p>
         </p:txBody>
@@ -3004,6 +3056,11 @@
         </p:txBody>
       </p:sp>
     </p:spTree>
+    <p:extLst>
+      <p:ext uri="{BB962C8B-B14F-4D97-AF65-F5344CB8AC3E}">
+        <p14:creationId xmlns:p14="http://schemas.microsoft.com/office/powerpoint/2010/main" val="251427986"/>
+      </p:ext>
+    </p:extLst>
   </p:cSld>
   <p:clrMapOvr>
     <a:masterClrMapping/>
@@ -3057,7 +3114,7 @@
           <a:p>
             <a:r>
               <a:rPr dirty="0"/>
-              <a:t>PRESENTER PREPARATION — Implemented achievements</a:t>
+              <a:t>PRESENTER PREPARATION — Reproduction boundary</a:t>
             </a:r>
           </a:p>
           <a:p>
@@ -3072,7 +3129,7 @@
           <a:p>
             <a:r>
               <a:rPr dirty="0"/>
-              <a:t>The main engineering milestone is the separation of representation, detection, validation and adaptation. Supervised updates use revealed labels; the transductive path uses confidence-gated pseudo-labels. Neither is yet the full dynamic CSE-UAEL ensemble.</a:t>
+              <a:t>The combined results remain far below published validation counts. I can claim an executable reconstruction with measured discrepancies, but cannot claim numerical reproduction.</a:t>
             </a:r>
           </a:p>
           <a:p>
@@ -3087,7 +3144,7 @@
           <a:p>
             <a:r>
               <a:rPr dirty="0"/>
-              <a:t>Does implemented mean validated? No. Code and tests support behaviour; experiments must establish scientific benefit.</a:t>
+              <a:t>Should parameters be tuned to match published test counts? That would risk fitting to the evaluation target. Select on development data and report sensitivity separately.</a:t>
             </a:r>
           </a:p>
           <a:p>
@@ -3102,7 +3159,7 @@
           <a:p>
             <a:r>
               <a:rPr dirty="0"/>
-              <a:t>Repository README and src/adaptation/transductive.py; inspected at f3ef2e8.</a:t>
+              <a:t>Combined Table-I file; means across nine subjects in each dataset. Not the standalone B01 result.</a:t>
             </a:r>
           </a:p>
         </p:txBody>
@@ -3180,7 +3237,7 @@
           <a:p>
             <a:r>
               <a:rPr dirty="0"/>
-              <a:t>PRESENTER PREPARATION — Timeline</a:t>
+              <a:t>PRESENTER PREPARATION — Implemented achievements</a:t>
             </a:r>
           </a:p>
           <a:p>
@@ -3195,7 +3252,7 @@
           <a:p>
             <a:r>
               <a:rPr dirty="0"/>
-              <a:t>This is a proposed first-year plan. The current reconstruction and pilot experiments provide starting evidence for early work packages; the digital twin, sustainability and cross-domain work are future objectives.</a:t>
+              <a:t>The main engineering milestone is the separation of representation, detection, validation and adaptation. Supervised updates use revealed labels; the transductive path uses confidence-gated pseudo-labels. Neither is yet the full dynamic CSE-UAEL ensemble.</a:t>
             </a:r>
           </a:p>
           <a:p>
@@ -3210,7 +3267,7 @@
           <a:p>
             <a:r>
               <a:rPr dirty="0"/>
-              <a:t>Are these packages already completed? No. Distinguish the existing benchmark foundation from planned research outcomes.</a:t>
+              <a:t>Does implemented mean validated? No. Code and tests support behaviour; experiments must establish scientific benefit.</a:t>
             </a:r>
           </a:p>
           <a:p>
@@ -3225,7 +3282,7 @@
           <a:p>
             <a:r>
               <a:rPr dirty="0"/>
-              <a:t>Proposed October2026–September2027 timeline retained from the source deck.</a:t>
+              <a:t>Repository README and src/adaptation/transductive.py; inspected at f3ef2e8.</a:t>
             </a:r>
           </a:p>
         </p:txBody>
@@ -3303,7 +3360,7 @@
           <a:p>
             <a:r>
               <a:rPr dirty="0"/>
-              <a:t>PRESENTER PREPARATION — Closing</a:t>
+              <a:t>PRESENTER PREPARATION — Timeline</a:t>
             </a:r>
           </a:p>
           <a:p>
@@ -3318,7 +3375,7 @@
           <a:p>
             <a:r>
               <a:rPr dirty="0"/>
-              <a:t>The next milestone is a reproducible evidence package: reconcile detector runs, repeat the policy experiment across scenarios and seeds, and generate real EEG complementary traces. Then judge benefit alongside update burden and uncertainty.</a:t>
+              <a:t>This is a proposed first-year plan. The current reconstruction and pilot experiments provide starting evidence for early work packages; the digital twin, sustainability and cross-domain work are future objectives.</a:t>
             </a:r>
           </a:p>
           <a:p>
@@ -3333,7 +3390,7 @@
           <a:p>
             <a:r>
               <a:rPr dirty="0"/>
-              <a:t>What would count as success? Traceable configurations, repeated results with variability, a clear failure analysis, and evidence supporting a specific update policy under stated assumptions.</a:t>
+              <a:t>Are these packages already completed? No. Distinguish the existing benchmark foundation from planned research outcomes.</a:t>
             </a:r>
           </a:p>
           <a:p>
@@ -3348,7 +3405,7 @@
           <a:p>
             <a:r>
               <a:rPr dirty="0"/>
-              <a:t>Closing question: when does a detected change justify updating the model? Return to this rather than claiming the full problem is solved.</a:t>
+              <a:t>Proposed October2026–September2027 timeline retained from the source deck.</a:t>
             </a:r>
           </a:p>
         </p:txBody>
@@ -3381,6 +3438,129 @@
 </file>
 
 <file path=ppt/notesSlides/notesSlide34.xml><?xml version="1.0" encoding="utf-8"?>
+<p:notes xmlns:a="http://schemas.openxmlformats.org/drawingml/2006/main" xmlns:r="http://schemas.openxmlformats.org/officeDocument/2006/relationships" xmlns:p="http://schemas.openxmlformats.org/presentationml/2006/main">
+  <p:cSld>
+    <p:spTree>
+      <p:nvGrpSpPr>
+        <p:cNvPr id="1" name=""/>
+        <p:cNvGrpSpPr/>
+        <p:nvPr/>
+      </p:nvGrpSpPr>
+      <p:grpSpPr>
+        <a:xfrm>
+          <a:off x="0" y="0"/>
+          <a:ext cx="0" cy="0"/>
+          <a:chOff x="0" y="0"/>
+          <a:chExt cx="0" cy="0"/>
+        </a:xfrm>
+      </p:grpSpPr>
+      <p:sp>
+        <p:nvSpPr>
+          <p:cNvPr id="2" name="Slide Image Placeholder 1"/>
+          <p:cNvSpPr>
+            <a:spLocks noGrp="1" noRot="1" noChangeAspect="1"/>
+          </p:cNvSpPr>
+          <p:nvPr>
+            <p:ph type="sldImg"/>
+          </p:nvPr>
+        </p:nvSpPr>
+        <p:spPr/>
+      </p:sp>
+      <p:sp>
+        <p:nvSpPr>
+          <p:cNvPr id="3" name="Notes Placeholder 2"/>
+          <p:cNvSpPr>
+            <a:spLocks noGrp="1"/>
+          </p:cNvSpPr>
+          <p:nvPr>
+            <p:ph type="body" idx="1"/>
+          </p:nvPr>
+        </p:nvSpPr>
+        <p:spPr/>
+        <p:txBody>
+          <a:bodyPr/>
+          <a:lstStyle/>
+          <a:p>
+            <a:r>
+              <a:rPr dirty="0"/>
+              <a:t>PRESENTER PREPARATION — Closing</a:t>
+            </a:r>
+          </a:p>
+          <a:p>
+            <a:endParaRPr dirty="0"/>
+          </a:p>
+          <a:p>
+            <a:r>
+              <a:rPr dirty="0"/>
+              <a:t>Suggested explanation (30–60 seconds):</a:t>
+            </a:r>
+          </a:p>
+          <a:p>
+            <a:r>
+              <a:rPr dirty="0"/>
+              <a:t>The next milestone is a reproducible evidence package: reconcile detector runs, repeat the policy experiment across scenarios and seeds, and generate real EEG complementary traces. Then judge benefit alongside update burden and uncertainty.</a:t>
+            </a:r>
+          </a:p>
+          <a:p>
+            <a:endParaRPr dirty="0"/>
+          </a:p>
+          <a:p>
+            <a:r>
+              <a:rPr dirty="0"/>
+              <a:t>Likely question and answer:</a:t>
+            </a:r>
+          </a:p>
+          <a:p>
+            <a:r>
+              <a:rPr dirty="0"/>
+              <a:t>What would count as success? Traceable configurations, repeated results with variability, a clear failure analysis, and evidence supporting a specific update policy under stated assumptions.</a:t>
+            </a:r>
+          </a:p>
+          <a:p>
+            <a:endParaRPr dirty="0"/>
+          </a:p>
+          <a:p>
+            <a:r>
+              <a:rPr dirty="0"/>
+              <a:t>Evidence and cautions:</a:t>
+            </a:r>
+          </a:p>
+          <a:p>
+            <a:r>
+              <a:rPr dirty="0"/>
+              <a:t>Closing question: when does a detected change justify updating the model? Return to this rather than claiming the full problem is solved.</a:t>
+            </a:r>
+          </a:p>
+        </p:txBody>
+      </p:sp>
+      <p:sp>
+        <p:nvSpPr>
+          <p:cNvPr id="4" name="Slide Number Placeholder 3"/>
+          <p:cNvSpPr>
+            <a:spLocks noGrp="1"/>
+          </p:cNvSpPr>
+          <p:nvPr>
+            <p:ph type="sldNum" idx="5"/>
+          </p:nvPr>
+        </p:nvSpPr>
+        <p:spPr/>
+        <p:txBody>
+          <a:bodyPr/>
+          <a:lstStyle/>
+          <a:p>
+            <a:endParaRPr dirty="0"/>
+          </a:p>
+        </p:txBody>
+      </p:sp>
+    </p:spTree>
+  </p:cSld>
+  <p:clrMapOvr>
+    <a:masterClrMapping/>
+  </p:clrMapOvr>
+</p:notes>
+</file>
+
+<file path=ppt/notesSlides/notesSlide35.xml><?xml version="1.0" encoding="utf-8"?>
 <p:notes xmlns:a="http://schemas.openxmlformats.org/drawingml/2006/main" xmlns:r="http://schemas.openxmlformats.org/officeDocument/2006/relationships" xmlns:p="http://schemas.openxmlformats.org/presentationml/2006/main">
   <p:cSld>
     <p:spTree>
@@ -16373,7 +16553,13 @@
     </p:bg>
     <p:spTree>
       <p:nvGrpSpPr>
-        <p:cNvPr id="1" name=""/>
+        <p:cNvPr id="1" name="">
+          <a:extLst>
+            <a:ext uri="{FF2B5EF4-FFF2-40B4-BE49-F238E27FC236}">
+              <a16:creationId xmlns:a16="http://schemas.microsoft.com/office/drawing/2014/main" id="{A2CB4248-2361-A6E1-7FB4-8003E8C59818}"/>
+            </a:ext>
+          </a:extLst>
+        </p:cNvPr>
         <p:cNvGrpSpPr/>
         <p:nvPr/>
       </p:nvGrpSpPr>
@@ -16387,14 +16573,20 @@
       </p:grpSpPr>
       <p:sp>
         <p:nvSpPr>
-          <p:cNvPr id="2" name="TextBox 1"/>
+          <p:cNvPr id="2" name="TextBox 1">
+            <a:extLst>
+              <a:ext uri="{FF2B5EF4-FFF2-40B4-BE49-F238E27FC236}">
+                <a16:creationId xmlns:a16="http://schemas.microsoft.com/office/drawing/2014/main" id="{CD63A155-2803-E39F-BC03-DDC278E85975}"/>
+              </a:ext>
+            </a:extLst>
+          </p:cNvPr>
           <p:cNvSpPr txBox="1"/>
           <p:nvPr/>
         </p:nvSpPr>
         <p:spPr>
           <a:xfrm>
-            <a:off x="640080" y="365760"/>
-            <a:ext cx="10972800" cy="274320"/>
+            <a:off x="640080" y="239391"/>
+            <a:ext cx="10972800" cy="261610"/>
           </a:xfrm>
           <a:prstGeom prst="rect">
             <a:avLst/>
@@ -16420,20 +16612,26 @@
             </a:pPr>
             <a:r>
               <a:rPr dirty="0"/>
-              <a:t>MATHEMATICAL READING UPDATE · 12 OCTOBER 2026</a:t>
-            </a:r>
-          </a:p>
-        </p:txBody>
-      </p:sp>
-      <p:sp>
-        <p:nvSpPr>
-          <p:cNvPr id="3" name="TextBox 2"/>
+              <a:t>MATHEMATICAL READING UPDATE</a:t>
+            </a:r>
+          </a:p>
+        </p:txBody>
+      </p:sp>
+      <p:sp>
+        <p:nvSpPr>
+          <p:cNvPr id="3" name="TextBox 2">
+            <a:extLst>
+              <a:ext uri="{FF2B5EF4-FFF2-40B4-BE49-F238E27FC236}">
+                <a16:creationId xmlns:a16="http://schemas.microsoft.com/office/drawing/2014/main" id="{FAB9B7F0-DB3C-37D0-3844-1EC908E8E7D9}"/>
+              </a:ext>
+            </a:extLst>
+          </p:cNvPr>
           <p:cNvSpPr txBox="1"/>
           <p:nvPr/>
         </p:nvSpPr>
         <p:spPr>
           <a:xfrm>
-            <a:off x="640080" y="804672"/>
+            <a:off x="640080" y="594542"/>
             <a:ext cx="10972800" cy="685800"/>
           </a:xfrm>
           <a:prstGeom prst="rect">
@@ -16467,13 +16665,19 @@
       </p:sp>
       <p:sp>
         <p:nvSpPr>
-          <p:cNvPr id="4" name="TextBox 3"/>
+          <p:cNvPr id="4" name="TextBox 3">
+            <a:extLst>
+              <a:ext uri="{FF2B5EF4-FFF2-40B4-BE49-F238E27FC236}">
+                <a16:creationId xmlns:a16="http://schemas.microsoft.com/office/drawing/2014/main" id="{EFBF4062-4D28-4C16-6CD3-000BFECB41D9}"/>
+              </a:ext>
+            </a:extLst>
+          </p:cNvPr>
           <p:cNvSpPr txBox="1"/>
           <p:nvPr/>
         </p:nvSpPr>
         <p:spPr>
           <a:xfrm>
-            <a:off x="640080" y="1412014"/>
+            <a:off x="640080" y="1134205"/>
             <a:ext cx="10972800" cy="677108"/>
           </a:xfrm>
           <a:prstGeom prst="rect">
@@ -16526,13 +16730,19 @@
       </p:sp>
       <p:sp>
         <p:nvSpPr>
-          <p:cNvPr id="5" name="TextBox 4"/>
+          <p:cNvPr id="5" name="TextBox 4">
+            <a:extLst>
+              <a:ext uri="{FF2B5EF4-FFF2-40B4-BE49-F238E27FC236}">
+                <a16:creationId xmlns:a16="http://schemas.microsoft.com/office/drawing/2014/main" id="{19CAA462-E3FD-8F50-6C8C-7695AF113ECD}"/>
+              </a:ext>
+            </a:extLst>
+          </p:cNvPr>
           <p:cNvSpPr txBox="1"/>
           <p:nvPr/>
         </p:nvSpPr>
         <p:spPr>
           <a:xfrm>
-            <a:off x="640080" y="6172200"/>
+            <a:off x="628484" y="6281886"/>
             <a:ext cx="10972800" cy="457200"/>
           </a:xfrm>
           <a:prstGeom prst="rect">
@@ -16566,10 +16776,10 @@
       </p:sp>
       <p:pic>
         <p:nvPicPr>
-          <p:cNvPr id="10" name="Picture 9">
+          <p:cNvPr id="7" name="Picture 6">
             <a:extLst>
               <a:ext uri="{FF2B5EF4-FFF2-40B4-BE49-F238E27FC236}">
-                <a16:creationId xmlns:a16="http://schemas.microsoft.com/office/drawing/2014/main" id="{354B7A09-1E07-4180-B52D-402295125511}"/>
+                <a16:creationId xmlns:a16="http://schemas.microsoft.com/office/drawing/2014/main" id="{157D2653-FAA5-57E0-59EC-75C28649CE38}"/>
               </a:ext>
             </a:extLst>
           </p:cNvPr>
@@ -16586,8 +16796,8 @@
         </p:blipFill>
         <p:spPr>
           <a:xfrm>
-            <a:off x="3579283" y="2696464"/>
-            <a:ext cx="4622800" cy="2641600"/>
+            <a:off x="2043610" y="2270930"/>
+            <a:ext cx="8104780" cy="2316139"/>
           </a:xfrm>
           <a:prstGeom prst="rect">
             <a:avLst/>
@@ -16595,6 +16805,11 @@
         </p:spPr>
       </p:pic>
     </p:spTree>
+    <p:extLst>
+      <p:ext uri="{BB962C8B-B14F-4D97-AF65-F5344CB8AC3E}">
+        <p14:creationId xmlns:p14="http://schemas.microsoft.com/office/powerpoint/2010/main" val="937479140"/>
+      </p:ext>
+    </p:extLst>
   </p:cSld>
   <p:clrMapOvr>
     <a:masterClrMapping/>
@@ -16635,6 +16850,479 @@
         </p:nvSpPr>
         <p:spPr>
           <a:xfrm>
+            <a:off x="640080" y="239391"/>
+            <a:ext cx="10972800" cy="261610"/>
+          </a:xfrm>
+          <a:prstGeom prst="rect">
+            <a:avLst/>
+          </a:prstGeom>
+          <a:noFill/>
+        </p:spPr>
+        <p:txBody>
+          <a:bodyPr wrap="square">
+            <a:spAutoFit/>
+          </a:bodyPr>
+          <a:lstStyle/>
+          <a:p>
+            <a:pPr>
+              <a:spcAft>
+                <a:spcPts val="1200"/>
+              </a:spcAft>
+              <a:defRPr sz="1100" b="1">
+                <a:solidFill>
+                  <a:srgbClr val="009D94"/>
+                </a:solidFill>
+                <a:latin typeface="Aptos"/>
+              </a:defRPr>
+            </a:pPr>
+            <a:r>
+              <a:rPr dirty="0"/>
+              <a:t>MATHEMATICAL READING UPDATE</a:t>
+            </a:r>
+          </a:p>
+        </p:txBody>
+      </p:sp>
+      <p:sp>
+        <p:nvSpPr>
+          <p:cNvPr id="3" name="TextBox 2"/>
+          <p:cNvSpPr txBox="1"/>
+          <p:nvPr/>
+        </p:nvSpPr>
+        <p:spPr>
+          <a:xfrm>
+            <a:off x="640080" y="594542"/>
+            <a:ext cx="10972800" cy="685800"/>
+          </a:xfrm>
+          <a:prstGeom prst="rect">
+            <a:avLst/>
+          </a:prstGeom>
+          <a:noFill/>
+        </p:spPr>
+        <p:txBody>
+          <a:bodyPr wrap="square">
+            <a:spAutoFit/>
+          </a:bodyPr>
+          <a:lstStyle/>
+          <a:p>
+            <a:pPr>
+              <a:spcAft>
+                <a:spcPts val="1200"/>
+              </a:spcAft>
+              <a:defRPr sz="2800" b="1">
+                <a:solidFill>
+                  <a:srgbClr val="12233B"/>
+                </a:solidFill>
+                <a:latin typeface="Aptos"/>
+              </a:defRPr>
+            </a:pPr>
+            <a:r>
+              <a:rPr dirty="0"/>
+              <a:t>Mean validation has a variance-change limitation</a:t>
+            </a:r>
+          </a:p>
+        </p:txBody>
+      </p:sp>
+      <p:sp>
+        <p:nvSpPr>
+          <p:cNvPr id="4" name="TextBox 3"/>
+          <p:cNvSpPr txBox="1"/>
+          <p:nvPr/>
+        </p:nvSpPr>
+        <p:spPr>
+          <a:xfrm>
+            <a:off x="640080" y="1134205"/>
+            <a:ext cx="10972800" cy="677108"/>
+          </a:xfrm>
+          <a:prstGeom prst="rect">
+            <a:avLst/>
+          </a:prstGeom>
+          <a:noFill/>
+        </p:spPr>
+        <p:txBody>
+          <a:bodyPr wrap="square">
+            <a:spAutoFit/>
+          </a:bodyPr>
+          <a:lstStyle/>
+          <a:p>
+            <a:pPr>
+              <a:spcAft>
+                <a:spcPts val="1200"/>
+              </a:spcAft>
+              <a:defRPr sz="1700" b="0">
+                <a:solidFill>
+                  <a:srgbClr val="506580"/>
+                </a:solidFill>
+                <a:latin typeface="Aptos"/>
+              </a:defRPr>
+            </a:pPr>
+            <a:r>
+              <a:rPr sz="1400" dirty="0"/>
+              <a:t>Covariance scaling adjusts the mean contrast but does not make it a direct covariance-equality test.</a:t>
+            </a:r>
+            <a:endParaRPr lang="en-US" sz="1400" dirty="0"/>
+          </a:p>
+          <a:p>
+            <a:pPr>
+              <a:spcAft>
+                <a:spcPts val="1200"/>
+              </a:spcAft>
+              <a:defRPr sz="1700" b="0">
+                <a:solidFill>
+                  <a:srgbClr val="506580"/>
+                </a:solidFill>
+                <a:latin typeface="Aptos"/>
+              </a:defRPr>
+            </a:pPr>
+            <a:r>
+              <a:rPr lang="en-GB" sz="1400" dirty="0"/>
+              <a:t>Different structural changes affect different statistical properties.</a:t>
+            </a:r>
+            <a:endParaRPr lang="en-US" sz="1400" dirty="0"/>
+          </a:p>
+        </p:txBody>
+      </p:sp>
+      <p:sp>
+        <p:nvSpPr>
+          <p:cNvPr id="5" name="TextBox 4"/>
+          <p:cNvSpPr txBox="1"/>
+          <p:nvPr/>
+        </p:nvSpPr>
+        <p:spPr>
+          <a:xfrm>
+            <a:off x="628484" y="6281886"/>
+            <a:ext cx="10972800" cy="457200"/>
+          </a:xfrm>
+          <a:prstGeom prst="rect">
+            <a:avLst/>
+          </a:prstGeom>
+          <a:noFill/>
+        </p:spPr>
+        <p:txBody>
+          <a:bodyPr wrap="square">
+            <a:spAutoFit/>
+          </a:bodyPr>
+          <a:lstStyle/>
+          <a:p>
+            <a:pPr>
+              <a:spcAft>
+                <a:spcPts val="1200"/>
+              </a:spcAft>
+              <a:defRPr sz="1000" b="0">
+                <a:solidFill>
+                  <a:srgbClr val="506580"/>
+                </a:solidFill>
+                <a:latin typeface="Aptos"/>
+              </a:defRPr>
+            </a:pPr>
+            <a:r>
+              <a:rPr dirty="0"/>
+              <a:t>Sources: existing detector slide; Chowdhury et al. (2018), Eq. (9). This expression preserves separate covariance terms.</a:t>
+            </a:r>
+          </a:p>
+        </p:txBody>
+      </p:sp>
+      <p:pic>
+        <p:nvPicPr>
+          <p:cNvPr id="10" name="Picture 9">
+            <a:extLst>
+              <a:ext uri="{FF2B5EF4-FFF2-40B4-BE49-F238E27FC236}">
+                <a16:creationId xmlns:a16="http://schemas.microsoft.com/office/drawing/2014/main" id="{354B7A09-1E07-4180-B52D-402295125511}"/>
+              </a:ext>
+            </a:extLst>
+          </p:cNvPr>
+          <p:cNvPicPr>
+            <a:picLocks noChangeAspect="1"/>
+          </p:cNvPicPr>
+          <p:nvPr/>
+        </p:nvPicPr>
+        <p:blipFill>
+          <a:blip r:embed="rId3"/>
+          <a:stretch>
+            <a:fillRect/>
+          </a:stretch>
+        </p:blipFill>
+        <p:spPr>
+          <a:xfrm>
+            <a:off x="3803484" y="2350976"/>
+            <a:ext cx="4622800" cy="2641600"/>
+          </a:xfrm>
+          <a:prstGeom prst="rect">
+            <a:avLst/>
+          </a:prstGeom>
+        </p:spPr>
+      </p:pic>
+      <p:pic>
+        <p:nvPicPr>
+          <p:cNvPr id="7" name="Picture 6">
+            <a:extLst>
+              <a:ext uri="{FF2B5EF4-FFF2-40B4-BE49-F238E27FC236}">
+                <a16:creationId xmlns:a16="http://schemas.microsoft.com/office/drawing/2014/main" id="{E789E289-557F-BD8B-1BE3-522242889EDF}"/>
+              </a:ext>
+            </a:extLst>
+          </p:cNvPr>
+          <p:cNvPicPr>
+            <a:picLocks noChangeAspect="1"/>
+          </p:cNvPicPr>
+          <p:nvPr/>
+        </p:nvPicPr>
+        <p:blipFill>
+          <a:blip r:embed="rId4"/>
+          <a:stretch>
+            <a:fillRect/>
+          </a:stretch>
+        </p:blipFill>
+        <p:spPr>
+          <a:xfrm>
+            <a:off x="628484" y="3159926"/>
+            <a:ext cx="2784612" cy="795771"/>
+          </a:xfrm>
+          <a:prstGeom prst="rect">
+            <a:avLst/>
+          </a:prstGeom>
+        </p:spPr>
+      </p:pic>
+      <p:pic>
+        <p:nvPicPr>
+          <p:cNvPr id="9" name="Picture 8">
+            <a:extLst>
+              <a:ext uri="{FF2B5EF4-FFF2-40B4-BE49-F238E27FC236}">
+                <a16:creationId xmlns:a16="http://schemas.microsoft.com/office/drawing/2014/main" id="{CC8EFED8-B9CE-3033-A10F-2CC5696B5A3A}"/>
+              </a:ext>
+            </a:extLst>
+          </p:cNvPr>
+          <p:cNvPicPr>
+            <a:picLocks noChangeAspect="1"/>
+          </p:cNvPicPr>
+          <p:nvPr/>
+        </p:nvPicPr>
+        <p:blipFill>
+          <a:blip r:embed="rId5"/>
+          <a:stretch>
+            <a:fillRect/>
+          </a:stretch>
+        </p:blipFill>
+        <p:spPr>
+          <a:xfrm>
+            <a:off x="8671890" y="2712650"/>
+            <a:ext cx="3197087" cy="1918252"/>
+          </a:xfrm>
+          <a:prstGeom prst="rect">
+            <a:avLst/>
+          </a:prstGeom>
+        </p:spPr>
+      </p:pic>
+      <mc:AlternateContent xmlns:mc="http://schemas.openxmlformats.org/markup-compatibility/2006">
+        <mc:Choice xmlns:a14="http://schemas.microsoft.com/office/drawing/2010/main" Requires="a14">
+          <p:sp>
+            <p:nvSpPr>
+              <p:cNvPr id="13" name="TextBox 12">
+                <a:extLst>
+                  <a:ext uri="{FF2B5EF4-FFF2-40B4-BE49-F238E27FC236}">
+                    <a16:creationId xmlns:a16="http://schemas.microsoft.com/office/drawing/2014/main" id="{CF1264DA-1C2B-2111-7C35-134145E7BB60}"/>
+                  </a:ext>
+                </a:extLst>
+              </p:cNvPr>
+              <p:cNvSpPr txBox="1"/>
+              <p:nvPr/>
+            </p:nvSpPr>
+            <p:spPr>
+              <a:xfrm>
+                <a:off x="628484" y="5046688"/>
+                <a:ext cx="4558580" cy="1015663"/>
+              </a:xfrm>
+              <a:prstGeom prst="rect">
+                <a:avLst/>
+              </a:prstGeom>
+              <a:noFill/>
+            </p:spPr>
+            <p:txBody>
+              <a:bodyPr wrap="square">
+                <a:spAutoFit/>
+              </a:bodyPr>
+              <a:lstStyle/>
+              <a:p>
+                <a:pPr>
+                  <a:buNone/>
+                </a:pPr>
+                <a:r>
+                  <a:rPr lang="en-GB" sz="1200" b="1" dirty="0"/>
+                  <a:t>Statistical signatures of three controlled changes.</a:t>
+                </a:r>
+                <a:r>
+                  <a:rPr lang="en-GB" sz="1200" dirty="0"/>
+                  <a:t> Rows represent mean, variance and autoregressive-dependence changes; columns show rolling mean, variance and lag-1 correlation. The dashed vertical line marks the known change point at (</a:t>
+                </a:r>
+                <a14:m>
+                  <m:oMath xmlns:m="http://schemas.openxmlformats.org/officeDocument/2006/math">
+                    <m:sSub>
+                      <m:sSubPr>
+                        <m:ctrlPr>
+                          <a:rPr lang="en-GB" sz="1200" i="1" dirty="0">
+                            <a:latin typeface="Cambria Math" panose="02040503050406030204" pitchFamily="18" charset="0"/>
+                          </a:rPr>
+                        </m:ctrlPr>
+                      </m:sSubPr>
+                      <m:e>
+                        <m:r>
+                          <a:rPr lang="en-GB" sz="1200" i="1" dirty="0">
+                            <a:latin typeface="Cambria Math" panose="02040503050406030204" pitchFamily="18" charset="0"/>
+                          </a:rPr>
+                          <m:t>𝑡</m:t>
+                        </m:r>
+                      </m:e>
+                      <m:sub>
+                        <m:r>
+                          <a:rPr lang="en-GB" sz="1200" i="0" dirty="0">
+                            <a:latin typeface="Cambria Math" panose="02040503050406030204" pitchFamily="18" charset="0"/>
+                          </a:rPr>
+                          <m:t>0</m:t>
+                        </m:r>
+                      </m:sub>
+                    </m:sSub>
+                    <m:r>
+                      <a:rPr lang="en-GB" sz="1200" i="0" dirty="0">
+                        <a:latin typeface="Cambria Math" panose="02040503050406030204" pitchFamily="18" charset="0"/>
+                      </a:rPr>
+                      <m:t>=512</m:t>
+                    </m:r>
+                  </m:oMath>
+                </a14:m>
+                <a:r>
+                  <a:rPr lang="en-GB" sz="1200" dirty="0"/>
+                  <a:t>). These are descriptive simulations, not measured detector performance.</a:t>
+                </a:r>
+              </a:p>
+            </p:txBody>
+          </p:sp>
+        </mc:Choice>
+        <mc:Fallback>
+          <p:sp>
+            <p:nvSpPr>
+              <p:cNvPr id="13" name="TextBox 12">
+                <a:extLst>
+                  <a:ext uri="{FF2B5EF4-FFF2-40B4-BE49-F238E27FC236}">
+                    <a16:creationId xmlns:a16="http://schemas.microsoft.com/office/drawing/2014/main" id="{CF1264DA-1C2B-2111-7C35-134145E7BB60}"/>
+                  </a:ext>
+                </a:extLst>
+              </p:cNvPr>
+              <p:cNvSpPr txBox="1">
+                <a:spLocks noRot="1" noChangeAspect="1" noMove="1" noResize="1" noEditPoints="1" noAdjustHandles="1" noChangeArrowheads="1" noChangeShapeType="1" noTextEdit="1"/>
+              </p:cNvSpPr>
+              <p:nvPr/>
+            </p:nvSpPr>
+            <p:spPr>
+              <a:xfrm>
+                <a:off x="628484" y="5046688"/>
+                <a:ext cx="4558580" cy="1015663"/>
+              </a:xfrm>
+              <a:prstGeom prst="rect">
+                <a:avLst/>
+              </a:prstGeom>
+              <a:blipFill>
+                <a:blip r:embed="rId6"/>
+                <a:stretch>
+                  <a:fillRect t="-602" b="-4217"/>
+                </a:stretch>
+              </a:blipFill>
+            </p:spPr>
+            <p:txBody>
+              <a:bodyPr/>
+              <a:lstStyle/>
+              <a:p>
+                <a:r>
+                  <a:rPr lang="en-GB">
+                    <a:noFill/>
+                  </a:rPr>
+                  <a:t> </a:t>
+                </a:r>
+              </a:p>
+            </p:txBody>
+          </p:sp>
+        </mc:Fallback>
+      </mc:AlternateContent>
+      <p:sp>
+        <p:nvSpPr>
+          <p:cNvPr id="15" name="TextBox 14">
+            <a:extLst>
+              <a:ext uri="{FF2B5EF4-FFF2-40B4-BE49-F238E27FC236}">
+                <a16:creationId xmlns:a16="http://schemas.microsoft.com/office/drawing/2014/main" id="{97443EED-4670-231B-BAEF-6E83C20CDB1D}"/>
+              </a:ext>
+            </a:extLst>
+          </p:cNvPr>
+          <p:cNvSpPr txBox="1"/>
+          <p:nvPr/>
+        </p:nvSpPr>
+        <p:spPr>
+          <a:xfrm>
+            <a:off x="5773807" y="5323687"/>
+            <a:ext cx="6095170" cy="738664"/>
+          </a:xfrm>
+          <a:prstGeom prst="rect">
+            <a:avLst/>
+          </a:prstGeom>
+          <a:noFill/>
+        </p:spPr>
+        <p:txBody>
+          <a:bodyPr wrap="square">
+            <a:spAutoFit/>
+          </a:bodyPr>
+          <a:lstStyle/>
+          <a:p>
+            <a:pPr>
+              <a:buNone/>
+            </a:pPr>
+            <a:r>
+              <a:rPr lang="en-GB" sz="1400" b="1" dirty="0"/>
+              <a:t>Key finding:</a:t>
+            </a:r>
+            <a:r>
+              <a:rPr lang="en-GB" sz="1400" dirty="0"/>
+              <a:t> A shift in temporal dependence need not produce a corresponding shift in the process mean. Consequently, mean-based validation alone does not establish the absence of other structural changes.</a:t>
+            </a:r>
+          </a:p>
+        </p:txBody>
+      </p:sp>
+    </p:spTree>
+  </p:cSld>
+  <p:clrMapOvr>
+    <a:masterClrMapping/>
+  </p:clrMapOvr>
+</p:sld>
+</file>
+
+<file path=ppt/slides/slide25.xml><?xml version="1.0" encoding="utf-8"?>
+<p:sld xmlns:a="http://schemas.openxmlformats.org/drawingml/2006/main" xmlns:r="http://schemas.openxmlformats.org/officeDocument/2006/relationships" xmlns:p="http://schemas.openxmlformats.org/presentationml/2006/main">
+  <p:cSld>
+    <p:bg>
+      <p:bgPr>
+        <a:solidFill>
+          <a:srgbClr val="F7F9FC"/>
+        </a:solidFill>
+        <a:effectLst/>
+      </p:bgPr>
+    </p:bg>
+    <p:spTree>
+      <p:nvGrpSpPr>
+        <p:cNvPr id="1" name=""/>
+        <p:cNvGrpSpPr/>
+        <p:nvPr/>
+      </p:nvGrpSpPr>
+      <p:grpSpPr>
+        <a:xfrm>
+          <a:off x="0" y="0"/>
+          <a:ext cx="0" cy="0"/>
+          <a:chOff x="0" y="0"/>
+          <a:chExt cx="0" cy="0"/>
+        </a:xfrm>
+      </p:grpSpPr>
+      <p:sp>
+        <p:nvSpPr>
+          <p:cNvPr id="2" name="TextBox 1"/>
+          <p:cNvSpPr txBox="1"/>
+          <p:nvPr/>
+        </p:nvSpPr>
+        <p:spPr>
+          <a:xfrm>
             <a:off x="640080" y="365760"/>
             <a:ext cx="10972800" cy="274320"/>
           </a:xfrm>
@@ -16957,7 +17645,7 @@
 </p:sld>
 </file>
 
-<file path=ppt/slides/slide25.xml><?xml version="1.0" encoding="utf-8"?>
+<file path=ppt/slides/slide26.xml><?xml version="1.0" encoding="utf-8"?>
 <p:sld xmlns:a="http://schemas.openxmlformats.org/drawingml/2006/main" xmlns:r="http://schemas.openxmlformats.org/officeDocument/2006/relationships" xmlns:p="http://schemas.openxmlformats.org/presentationml/2006/main">
   <p:cSld>
     <p:bg>
@@ -17621,7 +18309,7 @@
 </p:sld>
 </file>
 
-<file path=ppt/slides/slide26.xml><?xml version="1.0" encoding="utf-8"?>
+<file path=ppt/slides/slide27.xml><?xml version="1.0" encoding="utf-8"?>
 <p:sld xmlns:a="http://schemas.openxmlformats.org/drawingml/2006/main" xmlns:r="http://schemas.openxmlformats.org/officeDocument/2006/relationships" xmlns:p="http://schemas.openxmlformats.org/presentationml/2006/main">
   <p:cSld>
     <p:bg>
@@ -18711,7 +19399,7 @@
 </p:sld>
 </file>
 
-<file path=ppt/slides/slide27.xml><?xml version="1.0" encoding="utf-8"?>
+<file path=ppt/slides/slide28.xml><?xml version="1.0" encoding="utf-8"?>
 <p:sld xmlns:a="http://schemas.openxmlformats.org/drawingml/2006/main" xmlns:r="http://schemas.openxmlformats.org/officeDocument/2006/relationships" xmlns:p="http://schemas.openxmlformats.org/presentationml/2006/main">
   <p:cSld>
     <p:bg>
@@ -19489,7 +20177,7 @@
 </p:sld>
 </file>
 
-<file path=ppt/slides/slide28.xml><?xml version="1.0" encoding="utf-8"?>
+<file path=ppt/slides/slide29.xml><?xml version="1.0" encoding="utf-8"?>
 <p:sld xmlns:a="http://schemas.openxmlformats.org/drawingml/2006/main" xmlns:r="http://schemas.openxmlformats.org/officeDocument/2006/relationships" xmlns:p="http://schemas.openxmlformats.org/presentationml/2006/main">
   <p:cSld>
     <p:bg>
@@ -20069,553 +20757,6 @@
 </p:sld>
 </file>
 
-<file path=ppt/slides/slide29.xml><?xml version="1.0" encoding="utf-8"?>
-<p:sld xmlns:a="http://schemas.openxmlformats.org/drawingml/2006/main" xmlns:r="http://schemas.openxmlformats.org/officeDocument/2006/relationships" xmlns:p="http://schemas.openxmlformats.org/presentationml/2006/main">
-  <p:cSld>
-    <p:spTree>
-      <p:nvGrpSpPr>
-        <p:cNvPr id="1" name=""/>
-        <p:cNvGrpSpPr/>
-        <p:nvPr/>
-      </p:nvGrpSpPr>
-      <p:grpSpPr>
-        <a:xfrm>
-          <a:off x="0" y="0"/>
-          <a:ext cx="0" cy="0"/>
-          <a:chOff x="0" y="0"/>
-          <a:chExt cx="0" cy="0"/>
-        </a:xfrm>
-      </p:grpSpPr>
-      <p:sp>
-        <p:nvSpPr>
-          <p:cNvPr id="2" name="TextBox 1"/>
-          <p:cNvSpPr txBox="1"/>
-          <p:nvPr/>
-        </p:nvSpPr>
-        <p:spPr>
-          <a:xfrm>
-            <a:off x="612648" y="292608"/>
-            <a:ext cx="10881360" cy="320040"/>
-          </a:xfrm>
-          <a:prstGeom prst="rect">
-            <a:avLst/>
-          </a:prstGeom>
-          <a:noFill/>
-        </p:spPr>
-        <p:txBody>
-          <a:bodyPr wrap="square">
-            <a:spAutoFit/>
-          </a:bodyPr>
-          <a:lstStyle/>
-          <a:p>
-            <a:pPr>
-              <a:spcAft>
-                <a:spcPts val="800"/>
-              </a:spcAft>
-              <a:defRPr sz="1300" b="1">
-                <a:solidFill>
-                  <a:srgbClr val="AE9251"/>
-                </a:solidFill>
-                <a:latin typeface="Aptos"/>
-              </a:defRPr>
-            </a:pPr>
-            <a:r>
-              <a:rPr dirty="0"/>
-              <a:t>SEPARATE EXPERIMENTAL CONTEXT</a:t>
-            </a:r>
-          </a:p>
-        </p:txBody>
-      </p:sp>
-      <p:sp>
-        <p:nvSpPr>
-          <p:cNvPr id="3" name="TextBox 2"/>
-          <p:cNvSpPr txBox="1"/>
-          <p:nvPr/>
-        </p:nvSpPr>
-        <p:spPr>
-          <a:xfrm>
-            <a:off x="612648" y="749808"/>
-            <a:ext cx="10972800" cy="640080"/>
-          </a:xfrm>
-          <a:prstGeom prst="rect">
-            <a:avLst/>
-          </a:prstGeom>
-          <a:noFill/>
-        </p:spPr>
-        <p:txBody>
-          <a:bodyPr wrap="square">
-            <a:spAutoFit/>
-          </a:bodyPr>
-          <a:lstStyle/>
-          <a:p>
-            <a:pPr>
-              <a:spcAft>
-                <a:spcPts val="800"/>
-              </a:spcAft>
-              <a:defRPr sz="2700" b="1">
-                <a:solidFill>
-                  <a:srgbClr val="13274B"/>
-                </a:solidFill>
-                <a:latin typeface="Aptos"/>
-              </a:defRPr>
-            </a:pPr>
-            <a:r>
-              <a:rPr dirty="0"/>
-              <a:t>The Diethe policy lab uses supplied feature vectors</a:t>
-            </a:r>
-          </a:p>
-        </p:txBody>
-      </p:sp>
-      <p:sp>
-        <p:nvSpPr>
-          <p:cNvPr id="4" name="TextBox 3"/>
-          <p:cNvSpPr txBox="1"/>
-          <p:nvPr/>
-        </p:nvSpPr>
-        <p:spPr>
-          <a:xfrm>
-            <a:off x="685800" y="1435608"/>
-            <a:ext cx="10881360" cy="512064"/>
-          </a:xfrm>
-          <a:prstGeom prst="rect">
-            <a:avLst/>
-          </a:prstGeom>
-          <a:noFill/>
-        </p:spPr>
-        <p:txBody>
-          <a:bodyPr wrap="square">
-            <a:spAutoFit/>
-          </a:bodyPr>
-          <a:lstStyle/>
-          <a:p>
-            <a:pPr>
-              <a:spcAft>
-                <a:spcPts val="800"/>
-              </a:spcAft>
-              <a:defRPr sz="1400" b="0">
-                <a:solidFill>
-                  <a:srgbClr val="53657C"/>
-                </a:solidFill>
-                <a:latin typeface="Aptos"/>
-              </a:defRPr>
-            </a:pPr>
-            <a:r>
-              <a:rPr dirty="0"/>
-              <a:t>Do not conflate the real-EEG FBCSP/PCA monitoring pipeline with the synthetic policy-comparison branch.</a:t>
-            </a:r>
-          </a:p>
-        </p:txBody>
-      </p:sp>
-      <p:sp>
-        <p:nvSpPr>
-          <p:cNvPr id="5" name="TextBox 4"/>
-          <p:cNvSpPr txBox="1"/>
-          <p:nvPr/>
-        </p:nvSpPr>
-        <p:spPr>
-          <a:xfrm>
-            <a:off x="612648" y="6510528"/>
-            <a:ext cx="8229600" cy="210312"/>
-          </a:xfrm>
-          <a:prstGeom prst="rect">
-            <a:avLst/>
-          </a:prstGeom>
-          <a:noFill/>
-        </p:spPr>
-        <p:txBody>
-          <a:bodyPr wrap="square">
-            <a:spAutoFit/>
-          </a:bodyPr>
-          <a:lstStyle/>
-          <a:p>
-            <a:pPr>
-              <a:spcAft>
-                <a:spcPts val="800"/>
-              </a:spcAft>
-              <a:defRPr sz="900" b="0">
-                <a:solidFill>
-                  <a:srgbClr val="53657C"/>
-                </a:solidFill>
-                <a:latin typeface="Aptos"/>
-              </a:defRPr>
-            </a:pPr>
-            <a:r>
-              <a:rPr dirty="0"/>
-              <a:t>hlin863/ewma_covariate_shift_demo</a:t>
-            </a:r>
-          </a:p>
-        </p:txBody>
-      </p:sp>
-      <p:sp>
-        <p:nvSpPr>
-          <p:cNvPr id="6" name="Rounded Rectangle 5"/>
-          <p:cNvSpPr/>
-          <p:nvPr/>
-        </p:nvSpPr>
-        <p:spPr>
-          <a:xfrm>
-            <a:off x="822960" y="1938528"/>
-            <a:ext cx="5029200" cy="2331720"/>
-          </a:xfrm>
-          <a:prstGeom prst="roundRect">
-            <a:avLst/>
-          </a:prstGeom>
-          <a:solidFill>
-            <a:srgbClr val="ECF2F8"/>
-          </a:solidFill>
-          <a:ln>
-            <a:noFill/>
-          </a:ln>
-        </p:spPr>
-        <p:style>
-          <a:lnRef idx="1">
-            <a:schemeClr val="accent1"/>
-          </a:lnRef>
-          <a:fillRef idx="3">
-            <a:schemeClr val="accent1"/>
-          </a:fillRef>
-          <a:effectRef idx="2">
-            <a:schemeClr val="accent1"/>
-          </a:effectRef>
-          <a:fontRef idx="minor">
-            <a:schemeClr val="lt1"/>
-          </a:fontRef>
-        </p:style>
-        <p:txBody>
-          <a:bodyPr rtlCol="0" anchor="ctr"/>
-          <a:lstStyle/>
-          <a:p>
-            <a:pPr algn="ctr"/>
-            <a:endParaRPr dirty="0"/>
-          </a:p>
-        </p:txBody>
-      </p:sp>
-      <p:sp>
-        <p:nvSpPr>
-          <p:cNvPr id="7" name="Rounded Rectangle 6"/>
-          <p:cNvSpPr/>
-          <p:nvPr/>
-        </p:nvSpPr>
-        <p:spPr>
-          <a:xfrm>
-            <a:off x="6217920" y="1938528"/>
-            <a:ext cx="5029200" cy="2331720"/>
-          </a:xfrm>
-          <a:prstGeom prst="roundRect">
-            <a:avLst/>
-          </a:prstGeom>
-          <a:solidFill>
-            <a:srgbClr val="ECF2F8"/>
-          </a:solidFill>
-          <a:ln>
-            <a:noFill/>
-          </a:ln>
-        </p:spPr>
-        <p:style>
-          <a:lnRef idx="1">
-            <a:schemeClr val="accent1"/>
-          </a:lnRef>
-          <a:fillRef idx="3">
-            <a:schemeClr val="accent1"/>
-          </a:fillRef>
-          <a:effectRef idx="2">
-            <a:schemeClr val="accent1"/>
-          </a:effectRef>
-          <a:fontRef idx="minor">
-            <a:schemeClr val="lt1"/>
-          </a:fontRef>
-        </p:style>
-        <p:txBody>
-          <a:bodyPr rtlCol="0" anchor="ctr"/>
-          <a:lstStyle/>
-          <a:p>
-            <a:pPr algn="ctr"/>
-            <a:endParaRPr dirty="0"/>
-          </a:p>
-        </p:txBody>
-      </p:sp>
-      <p:sp>
-        <p:nvSpPr>
-          <p:cNvPr id="8" name="TextBox 7"/>
-          <p:cNvSpPr txBox="1"/>
-          <p:nvPr/>
-        </p:nvSpPr>
-        <p:spPr>
-          <a:xfrm>
-            <a:off x="1042415" y="2212848"/>
-            <a:ext cx="4535424" cy="411480"/>
-          </a:xfrm>
-          <a:prstGeom prst="rect">
-            <a:avLst/>
-          </a:prstGeom>
-          <a:noFill/>
-        </p:spPr>
-        <p:txBody>
-          <a:bodyPr wrap="square">
-            <a:spAutoFit/>
-          </a:bodyPr>
-          <a:lstStyle/>
-          <a:p>
-            <a:pPr>
-              <a:spcAft>
-                <a:spcPts val="800"/>
-              </a:spcAft>
-              <a:defRPr sz="2000" b="1">
-                <a:solidFill>
-                  <a:srgbClr val="13274B"/>
-                </a:solidFill>
-                <a:latin typeface="Aptos"/>
-              </a:defRPr>
-            </a:pPr>
-            <a:r>
-              <a:rPr dirty="0"/>
-              <a:t>Real-EEG branch</a:t>
-            </a:r>
-          </a:p>
-        </p:txBody>
-      </p:sp>
-      <p:sp>
-        <p:nvSpPr>
-          <p:cNvPr id="9" name="TextBox 8"/>
-          <p:cNvSpPr txBox="1"/>
-          <p:nvPr/>
-        </p:nvSpPr>
-        <p:spPr>
-          <a:xfrm>
-            <a:off x="1042415" y="2798064"/>
-            <a:ext cx="4535424" cy="1097280"/>
-          </a:xfrm>
-          <a:prstGeom prst="rect">
-            <a:avLst/>
-          </a:prstGeom>
-          <a:noFill/>
-        </p:spPr>
-        <p:txBody>
-          <a:bodyPr wrap="square">
-            <a:spAutoFit/>
-          </a:bodyPr>
-          <a:lstStyle/>
-          <a:p>
-            <a:pPr>
-              <a:spcAft>
-                <a:spcPts val="800"/>
-              </a:spcAft>
-              <a:defRPr sz="1600" b="0">
-                <a:solidFill>
-                  <a:srgbClr val="53657C"/>
-                </a:solidFill>
-                <a:latin typeface="Aptos"/>
-              </a:defRPr>
-            </a:pPr>
-            <a:r>
-              <a:rPr dirty="0"/>
-              <a:t>EEG trial → calibrated FBCSP → feature vector fₜ</a:t>
-            </a:r>
-          </a:p>
-          <a:p>
-            <a:pPr>
-              <a:spcAft>
-                <a:spcPts val="800"/>
-              </a:spcAft>
-              <a:defRPr sz="1600" b="0">
-                <a:solidFill>
-                  <a:srgbClr val="53657C"/>
-                </a:solidFill>
-                <a:latin typeface="Aptos"/>
-              </a:defRPr>
-            </a:pPr>
-            <a:r>
-              <a:rPr dirty="0"/>
-              <a:t>PCA is used by monitoring; SVM receives fₜ.</a:t>
-            </a:r>
-          </a:p>
-        </p:txBody>
-      </p:sp>
-      <p:sp>
-        <p:nvSpPr>
-          <p:cNvPr id="10" name="TextBox 9"/>
-          <p:cNvSpPr txBox="1"/>
-          <p:nvPr/>
-        </p:nvSpPr>
-        <p:spPr>
-          <a:xfrm>
-            <a:off x="6437376" y="2212848"/>
-            <a:ext cx="4535424" cy="411480"/>
-          </a:xfrm>
-          <a:prstGeom prst="rect">
-            <a:avLst/>
-          </a:prstGeom>
-          <a:noFill/>
-        </p:spPr>
-        <p:txBody>
-          <a:bodyPr wrap="square">
-            <a:spAutoFit/>
-          </a:bodyPr>
-          <a:lstStyle/>
-          <a:p>
-            <a:pPr>
-              <a:spcAft>
-                <a:spcPts val="800"/>
-              </a:spcAft>
-              <a:defRPr sz="2000" b="1">
-                <a:solidFill>
-                  <a:srgbClr val="13274B"/>
-                </a:solidFill>
-                <a:latin typeface="Aptos"/>
-              </a:defRPr>
-            </a:pPr>
-            <a:r>
-              <a:rPr dirty="0"/>
-              <a:t>Diethe laboratory branch</a:t>
-            </a:r>
-          </a:p>
-        </p:txBody>
-      </p:sp>
-      <p:sp>
-        <p:nvSpPr>
-          <p:cNvPr id="11" name="TextBox 10"/>
-          <p:cNvSpPr txBox="1"/>
-          <p:nvPr/>
-        </p:nvSpPr>
-        <p:spPr>
-          <a:xfrm>
-            <a:off x="6437376" y="2798064"/>
-            <a:ext cx="4535424" cy="1097280"/>
-          </a:xfrm>
-          <a:prstGeom prst="rect">
-            <a:avLst/>
-          </a:prstGeom>
-          <a:noFill/>
-        </p:spPr>
-        <p:txBody>
-          <a:bodyPr wrap="square">
-            <a:spAutoFit/>
-          </a:bodyPr>
-          <a:lstStyle/>
-          <a:p>
-            <a:pPr>
-              <a:spcAft>
-                <a:spcPts val="800"/>
-              </a:spcAft>
-              <a:defRPr sz="1600" b="0">
-                <a:solidFill>
-                  <a:srgbClr val="53657C"/>
-                </a:solidFill>
-                <a:latin typeface="Aptos"/>
-              </a:defRPr>
-            </a:pPr>
-            <a:r>
-              <a:rPr dirty="0"/>
-              <a:t>Supplied / synthetic features → classifier and CSE detector</a:t>
-            </a:r>
-          </a:p>
-          <a:p>
-            <a:pPr>
-              <a:spcAft>
-                <a:spcPts val="800"/>
-              </a:spcAft>
-              <a:defRPr sz="1600" b="0">
-                <a:solidFill>
-                  <a:srgbClr val="53657C"/>
-                </a:solidFill>
-                <a:latin typeface="Aptos"/>
-              </a:defRPr>
-            </a:pPr>
-            <a:r>
-              <a:rPr dirty="0"/>
-              <a:t>No EEG extraction or FBCSP step is present.</a:t>
-            </a:r>
-          </a:p>
-        </p:txBody>
-      </p:sp>
-      <p:sp>
-        <p:nvSpPr>
-          <p:cNvPr id="12" name="TextBox 11"/>
-          <p:cNvSpPr txBox="1"/>
-          <p:nvPr/>
-        </p:nvSpPr>
-        <p:spPr>
-          <a:xfrm>
-            <a:off x="896112" y="4654296"/>
-            <a:ext cx="10607040" cy="594360"/>
-          </a:xfrm>
-          <a:prstGeom prst="rect">
-            <a:avLst/>
-          </a:prstGeom>
-          <a:noFill/>
-        </p:spPr>
-        <p:txBody>
-          <a:bodyPr wrap="square">
-            <a:spAutoFit/>
-          </a:bodyPr>
-          <a:lstStyle/>
-          <a:p>
-            <a:pPr>
-              <a:spcAft>
-                <a:spcPts val="800"/>
-              </a:spcAft>
-              <a:defRPr sz="1800" b="1">
-                <a:solidFill>
-                  <a:srgbClr val="13274B"/>
-                </a:solidFill>
-                <a:latin typeface="Aptos"/>
-              </a:defRPr>
-            </a:pPr>
-            <a:r>
-              <a:rPr dirty="0"/>
-              <a:t>Shared research question: should a confirmed distribution change trigger an update, and does that update help predictive performance?</a:t>
-            </a:r>
-          </a:p>
-        </p:txBody>
-      </p:sp>
-      <p:sp>
-        <p:nvSpPr>
-          <p:cNvPr id="13" name="TextBox 12"/>
-          <p:cNvSpPr txBox="1"/>
-          <p:nvPr/>
-        </p:nvSpPr>
-        <p:spPr>
-          <a:xfrm>
-            <a:off x="896112" y="5705856"/>
-            <a:ext cx="10515600" cy="365760"/>
-          </a:xfrm>
-          <a:prstGeom prst="rect">
-            <a:avLst/>
-          </a:prstGeom>
-          <a:noFill/>
-        </p:spPr>
-        <p:txBody>
-          <a:bodyPr wrap="square">
-            <a:spAutoFit/>
-          </a:bodyPr>
-          <a:lstStyle/>
-          <a:p>
-            <a:pPr>
-              <a:spcAft>
-                <a:spcPts val="800"/>
-              </a:spcAft>
-              <a:defRPr sz="1300" b="0">
-                <a:solidFill>
-                  <a:srgbClr val="53657C"/>
-                </a:solidFill>
-                <a:latin typeface="Aptos"/>
-              </a:defRPr>
-            </a:pPr>
-            <a:r>
-              <a:rPr dirty="0"/>
-              <a:t>Repository interpretation: run_policy_comparison(); the five-policy comparison is a controlled laboratory, not proof of clinical BCI benefit.</a:t>
-            </a:r>
-          </a:p>
-        </p:txBody>
-      </p:sp>
-    </p:spTree>
-  </p:cSld>
-  <p:clrMapOvr>
-    <a:masterClrMapping/>
-  </p:clrMapOvr>
-</p:sld>
-</file>
-
 <file path=ppt/slides/slide3.xml><?xml version="1.0" encoding="utf-8"?>
 <p:sld xmlns:a="http://schemas.openxmlformats.org/drawingml/2006/main" xmlns:r="http://schemas.openxmlformats.org/officeDocument/2006/relationships" xmlns:p="http://schemas.openxmlformats.org/presentationml/2006/main">
   <p:cSld>
@@ -22112,6 +22253,553 @@
 </file>
 
 <file path=ppt/slides/slide30.xml><?xml version="1.0" encoding="utf-8"?>
+<p:sld xmlns:a="http://schemas.openxmlformats.org/drawingml/2006/main" xmlns:r="http://schemas.openxmlformats.org/officeDocument/2006/relationships" xmlns:p="http://schemas.openxmlformats.org/presentationml/2006/main">
+  <p:cSld>
+    <p:spTree>
+      <p:nvGrpSpPr>
+        <p:cNvPr id="1" name=""/>
+        <p:cNvGrpSpPr/>
+        <p:nvPr/>
+      </p:nvGrpSpPr>
+      <p:grpSpPr>
+        <a:xfrm>
+          <a:off x="0" y="0"/>
+          <a:ext cx="0" cy="0"/>
+          <a:chOff x="0" y="0"/>
+          <a:chExt cx="0" cy="0"/>
+        </a:xfrm>
+      </p:grpSpPr>
+      <p:sp>
+        <p:nvSpPr>
+          <p:cNvPr id="2" name="TextBox 1"/>
+          <p:cNvSpPr txBox="1"/>
+          <p:nvPr/>
+        </p:nvSpPr>
+        <p:spPr>
+          <a:xfrm>
+            <a:off x="612648" y="292608"/>
+            <a:ext cx="10881360" cy="320040"/>
+          </a:xfrm>
+          <a:prstGeom prst="rect">
+            <a:avLst/>
+          </a:prstGeom>
+          <a:noFill/>
+        </p:spPr>
+        <p:txBody>
+          <a:bodyPr wrap="square">
+            <a:spAutoFit/>
+          </a:bodyPr>
+          <a:lstStyle/>
+          <a:p>
+            <a:pPr>
+              <a:spcAft>
+                <a:spcPts val="800"/>
+              </a:spcAft>
+              <a:defRPr sz="1300" b="1">
+                <a:solidFill>
+                  <a:srgbClr val="AE9251"/>
+                </a:solidFill>
+                <a:latin typeface="Aptos"/>
+              </a:defRPr>
+            </a:pPr>
+            <a:r>
+              <a:rPr dirty="0"/>
+              <a:t>SEPARATE EXPERIMENTAL CONTEXT</a:t>
+            </a:r>
+          </a:p>
+        </p:txBody>
+      </p:sp>
+      <p:sp>
+        <p:nvSpPr>
+          <p:cNvPr id="3" name="TextBox 2"/>
+          <p:cNvSpPr txBox="1"/>
+          <p:nvPr/>
+        </p:nvSpPr>
+        <p:spPr>
+          <a:xfrm>
+            <a:off x="612648" y="749808"/>
+            <a:ext cx="10972800" cy="640080"/>
+          </a:xfrm>
+          <a:prstGeom prst="rect">
+            <a:avLst/>
+          </a:prstGeom>
+          <a:noFill/>
+        </p:spPr>
+        <p:txBody>
+          <a:bodyPr wrap="square">
+            <a:spAutoFit/>
+          </a:bodyPr>
+          <a:lstStyle/>
+          <a:p>
+            <a:pPr>
+              <a:spcAft>
+                <a:spcPts val="800"/>
+              </a:spcAft>
+              <a:defRPr sz="2700" b="1">
+                <a:solidFill>
+                  <a:srgbClr val="13274B"/>
+                </a:solidFill>
+                <a:latin typeface="Aptos"/>
+              </a:defRPr>
+            </a:pPr>
+            <a:r>
+              <a:rPr dirty="0"/>
+              <a:t>The Diethe policy lab uses supplied feature vectors</a:t>
+            </a:r>
+          </a:p>
+        </p:txBody>
+      </p:sp>
+      <p:sp>
+        <p:nvSpPr>
+          <p:cNvPr id="4" name="TextBox 3"/>
+          <p:cNvSpPr txBox="1"/>
+          <p:nvPr/>
+        </p:nvSpPr>
+        <p:spPr>
+          <a:xfrm>
+            <a:off x="685800" y="1435608"/>
+            <a:ext cx="10881360" cy="512064"/>
+          </a:xfrm>
+          <a:prstGeom prst="rect">
+            <a:avLst/>
+          </a:prstGeom>
+          <a:noFill/>
+        </p:spPr>
+        <p:txBody>
+          <a:bodyPr wrap="square">
+            <a:spAutoFit/>
+          </a:bodyPr>
+          <a:lstStyle/>
+          <a:p>
+            <a:pPr>
+              <a:spcAft>
+                <a:spcPts val="800"/>
+              </a:spcAft>
+              <a:defRPr sz="1400" b="0">
+                <a:solidFill>
+                  <a:srgbClr val="53657C"/>
+                </a:solidFill>
+                <a:latin typeface="Aptos"/>
+              </a:defRPr>
+            </a:pPr>
+            <a:r>
+              <a:rPr dirty="0"/>
+              <a:t>Do not conflate the real-EEG FBCSP/PCA monitoring pipeline with the synthetic policy-comparison branch.</a:t>
+            </a:r>
+          </a:p>
+        </p:txBody>
+      </p:sp>
+      <p:sp>
+        <p:nvSpPr>
+          <p:cNvPr id="5" name="TextBox 4"/>
+          <p:cNvSpPr txBox="1"/>
+          <p:nvPr/>
+        </p:nvSpPr>
+        <p:spPr>
+          <a:xfrm>
+            <a:off x="612648" y="6510528"/>
+            <a:ext cx="8229600" cy="210312"/>
+          </a:xfrm>
+          <a:prstGeom prst="rect">
+            <a:avLst/>
+          </a:prstGeom>
+          <a:noFill/>
+        </p:spPr>
+        <p:txBody>
+          <a:bodyPr wrap="square">
+            <a:spAutoFit/>
+          </a:bodyPr>
+          <a:lstStyle/>
+          <a:p>
+            <a:pPr>
+              <a:spcAft>
+                <a:spcPts val="800"/>
+              </a:spcAft>
+              <a:defRPr sz="900" b="0">
+                <a:solidFill>
+                  <a:srgbClr val="53657C"/>
+                </a:solidFill>
+                <a:latin typeface="Aptos"/>
+              </a:defRPr>
+            </a:pPr>
+            <a:r>
+              <a:rPr dirty="0"/>
+              <a:t>hlin863/ewma_covariate_shift_demo</a:t>
+            </a:r>
+          </a:p>
+        </p:txBody>
+      </p:sp>
+      <p:sp>
+        <p:nvSpPr>
+          <p:cNvPr id="6" name="Rounded Rectangle 5"/>
+          <p:cNvSpPr/>
+          <p:nvPr/>
+        </p:nvSpPr>
+        <p:spPr>
+          <a:xfrm>
+            <a:off x="822960" y="1938528"/>
+            <a:ext cx="5029200" cy="2331720"/>
+          </a:xfrm>
+          <a:prstGeom prst="roundRect">
+            <a:avLst/>
+          </a:prstGeom>
+          <a:solidFill>
+            <a:srgbClr val="ECF2F8"/>
+          </a:solidFill>
+          <a:ln>
+            <a:noFill/>
+          </a:ln>
+        </p:spPr>
+        <p:style>
+          <a:lnRef idx="1">
+            <a:schemeClr val="accent1"/>
+          </a:lnRef>
+          <a:fillRef idx="3">
+            <a:schemeClr val="accent1"/>
+          </a:fillRef>
+          <a:effectRef idx="2">
+            <a:schemeClr val="accent1"/>
+          </a:effectRef>
+          <a:fontRef idx="minor">
+            <a:schemeClr val="lt1"/>
+          </a:fontRef>
+        </p:style>
+        <p:txBody>
+          <a:bodyPr rtlCol="0" anchor="ctr"/>
+          <a:lstStyle/>
+          <a:p>
+            <a:pPr algn="ctr"/>
+            <a:endParaRPr dirty="0"/>
+          </a:p>
+        </p:txBody>
+      </p:sp>
+      <p:sp>
+        <p:nvSpPr>
+          <p:cNvPr id="7" name="Rounded Rectangle 6"/>
+          <p:cNvSpPr/>
+          <p:nvPr/>
+        </p:nvSpPr>
+        <p:spPr>
+          <a:xfrm>
+            <a:off x="6217920" y="1938528"/>
+            <a:ext cx="5029200" cy="2331720"/>
+          </a:xfrm>
+          <a:prstGeom prst="roundRect">
+            <a:avLst/>
+          </a:prstGeom>
+          <a:solidFill>
+            <a:srgbClr val="ECF2F8"/>
+          </a:solidFill>
+          <a:ln>
+            <a:noFill/>
+          </a:ln>
+        </p:spPr>
+        <p:style>
+          <a:lnRef idx="1">
+            <a:schemeClr val="accent1"/>
+          </a:lnRef>
+          <a:fillRef idx="3">
+            <a:schemeClr val="accent1"/>
+          </a:fillRef>
+          <a:effectRef idx="2">
+            <a:schemeClr val="accent1"/>
+          </a:effectRef>
+          <a:fontRef idx="minor">
+            <a:schemeClr val="lt1"/>
+          </a:fontRef>
+        </p:style>
+        <p:txBody>
+          <a:bodyPr rtlCol="0" anchor="ctr"/>
+          <a:lstStyle/>
+          <a:p>
+            <a:pPr algn="ctr"/>
+            <a:endParaRPr dirty="0"/>
+          </a:p>
+        </p:txBody>
+      </p:sp>
+      <p:sp>
+        <p:nvSpPr>
+          <p:cNvPr id="8" name="TextBox 7"/>
+          <p:cNvSpPr txBox="1"/>
+          <p:nvPr/>
+        </p:nvSpPr>
+        <p:spPr>
+          <a:xfrm>
+            <a:off x="1042415" y="2212848"/>
+            <a:ext cx="4535424" cy="411480"/>
+          </a:xfrm>
+          <a:prstGeom prst="rect">
+            <a:avLst/>
+          </a:prstGeom>
+          <a:noFill/>
+        </p:spPr>
+        <p:txBody>
+          <a:bodyPr wrap="square">
+            <a:spAutoFit/>
+          </a:bodyPr>
+          <a:lstStyle/>
+          <a:p>
+            <a:pPr>
+              <a:spcAft>
+                <a:spcPts val="800"/>
+              </a:spcAft>
+              <a:defRPr sz="2000" b="1">
+                <a:solidFill>
+                  <a:srgbClr val="13274B"/>
+                </a:solidFill>
+                <a:latin typeface="Aptos"/>
+              </a:defRPr>
+            </a:pPr>
+            <a:r>
+              <a:rPr dirty="0"/>
+              <a:t>Real-EEG branch</a:t>
+            </a:r>
+          </a:p>
+        </p:txBody>
+      </p:sp>
+      <p:sp>
+        <p:nvSpPr>
+          <p:cNvPr id="9" name="TextBox 8"/>
+          <p:cNvSpPr txBox="1"/>
+          <p:nvPr/>
+        </p:nvSpPr>
+        <p:spPr>
+          <a:xfrm>
+            <a:off x="1042415" y="2798064"/>
+            <a:ext cx="4535424" cy="1097280"/>
+          </a:xfrm>
+          <a:prstGeom prst="rect">
+            <a:avLst/>
+          </a:prstGeom>
+          <a:noFill/>
+        </p:spPr>
+        <p:txBody>
+          <a:bodyPr wrap="square">
+            <a:spAutoFit/>
+          </a:bodyPr>
+          <a:lstStyle/>
+          <a:p>
+            <a:pPr>
+              <a:spcAft>
+                <a:spcPts val="800"/>
+              </a:spcAft>
+              <a:defRPr sz="1600" b="0">
+                <a:solidFill>
+                  <a:srgbClr val="53657C"/>
+                </a:solidFill>
+                <a:latin typeface="Aptos"/>
+              </a:defRPr>
+            </a:pPr>
+            <a:r>
+              <a:rPr dirty="0"/>
+              <a:t>EEG trial → calibrated FBCSP → feature vector fₜ</a:t>
+            </a:r>
+          </a:p>
+          <a:p>
+            <a:pPr>
+              <a:spcAft>
+                <a:spcPts val="800"/>
+              </a:spcAft>
+              <a:defRPr sz="1600" b="0">
+                <a:solidFill>
+                  <a:srgbClr val="53657C"/>
+                </a:solidFill>
+                <a:latin typeface="Aptos"/>
+              </a:defRPr>
+            </a:pPr>
+            <a:r>
+              <a:rPr dirty="0"/>
+              <a:t>PCA is used by monitoring; SVM receives fₜ.</a:t>
+            </a:r>
+          </a:p>
+        </p:txBody>
+      </p:sp>
+      <p:sp>
+        <p:nvSpPr>
+          <p:cNvPr id="10" name="TextBox 9"/>
+          <p:cNvSpPr txBox="1"/>
+          <p:nvPr/>
+        </p:nvSpPr>
+        <p:spPr>
+          <a:xfrm>
+            <a:off x="6437376" y="2212848"/>
+            <a:ext cx="4535424" cy="411480"/>
+          </a:xfrm>
+          <a:prstGeom prst="rect">
+            <a:avLst/>
+          </a:prstGeom>
+          <a:noFill/>
+        </p:spPr>
+        <p:txBody>
+          <a:bodyPr wrap="square">
+            <a:spAutoFit/>
+          </a:bodyPr>
+          <a:lstStyle/>
+          <a:p>
+            <a:pPr>
+              <a:spcAft>
+                <a:spcPts val="800"/>
+              </a:spcAft>
+              <a:defRPr sz="2000" b="1">
+                <a:solidFill>
+                  <a:srgbClr val="13274B"/>
+                </a:solidFill>
+                <a:latin typeface="Aptos"/>
+              </a:defRPr>
+            </a:pPr>
+            <a:r>
+              <a:rPr dirty="0"/>
+              <a:t>Diethe laboratory branch</a:t>
+            </a:r>
+          </a:p>
+        </p:txBody>
+      </p:sp>
+      <p:sp>
+        <p:nvSpPr>
+          <p:cNvPr id="11" name="TextBox 10"/>
+          <p:cNvSpPr txBox="1"/>
+          <p:nvPr/>
+        </p:nvSpPr>
+        <p:spPr>
+          <a:xfrm>
+            <a:off x="6437376" y="2798064"/>
+            <a:ext cx="4535424" cy="1097280"/>
+          </a:xfrm>
+          <a:prstGeom prst="rect">
+            <a:avLst/>
+          </a:prstGeom>
+          <a:noFill/>
+        </p:spPr>
+        <p:txBody>
+          <a:bodyPr wrap="square">
+            <a:spAutoFit/>
+          </a:bodyPr>
+          <a:lstStyle/>
+          <a:p>
+            <a:pPr>
+              <a:spcAft>
+                <a:spcPts val="800"/>
+              </a:spcAft>
+              <a:defRPr sz="1600" b="0">
+                <a:solidFill>
+                  <a:srgbClr val="53657C"/>
+                </a:solidFill>
+                <a:latin typeface="Aptos"/>
+              </a:defRPr>
+            </a:pPr>
+            <a:r>
+              <a:rPr dirty="0"/>
+              <a:t>Supplied / synthetic features → classifier and CSE detector</a:t>
+            </a:r>
+          </a:p>
+          <a:p>
+            <a:pPr>
+              <a:spcAft>
+                <a:spcPts val="800"/>
+              </a:spcAft>
+              <a:defRPr sz="1600" b="0">
+                <a:solidFill>
+                  <a:srgbClr val="53657C"/>
+                </a:solidFill>
+                <a:latin typeface="Aptos"/>
+              </a:defRPr>
+            </a:pPr>
+            <a:r>
+              <a:rPr dirty="0"/>
+              <a:t>No EEG extraction or FBCSP step is present.</a:t>
+            </a:r>
+          </a:p>
+        </p:txBody>
+      </p:sp>
+      <p:sp>
+        <p:nvSpPr>
+          <p:cNvPr id="12" name="TextBox 11"/>
+          <p:cNvSpPr txBox="1"/>
+          <p:nvPr/>
+        </p:nvSpPr>
+        <p:spPr>
+          <a:xfrm>
+            <a:off x="896112" y="4654296"/>
+            <a:ext cx="10607040" cy="594360"/>
+          </a:xfrm>
+          <a:prstGeom prst="rect">
+            <a:avLst/>
+          </a:prstGeom>
+          <a:noFill/>
+        </p:spPr>
+        <p:txBody>
+          <a:bodyPr wrap="square">
+            <a:spAutoFit/>
+          </a:bodyPr>
+          <a:lstStyle/>
+          <a:p>
+            <a:pPr>
+              <a:spcAft>
+                <a:spcPts val="800"/>
+              </a:spcAft>
+              <a:defRPr sz="1800" b="1">
+                <a:solidFill>
+                  <a:srgbClr val="13274B"/>
+                </a:solidFill>
+                <a:latin typeface="Aptos"/>
+              </a:defRPr>
+            </a:pPr>
+            <a:r>
+              <a:rPr dirty="0"/>
+              <a:t>Shared research question: should a confirmed distribution change trigger an update, and does that update help predictive performance?</a:t>
+            </a:r>
+          </a:p>
+        </p:txBody>
+      </p:sp>
+      <p:sp>
+        <p:nvSpPr>
+          <p:cNvPr id="13" name="TextBox 12"/>
+          <p:cNvSpPr txBox="1"/>
+          <p:nvPr/>
+        </p:nvSpPr>
+        <p:spPr>
+          <a:xfrm>
+            <a:off x="896112" y="5705856"/>
+            <a:ext cx="10515600" cy="365760"/>
+          </a:xfrm>
+          <a:prstGeom prst="rect">
+            <a:avLst/>
+          </a:prstGeom>
+          <a:noFill/>
+        </p:spPr>
+        <p:txBody>
+          <a:bodyPr wrap="square">
+            <a:spAutoFit/>
+          </a:bodyPr>
+          <a:lstStyle/>
+          <a:p>
+            <a:pPr>
+              <a:spcAft>
+                <a:spcPts val="800"/>
+              </a:spcAft>
+              <a:defRPr sz="1300" b="0">
+                <a:solidFill>
+                  <a:srgbClr val="53657C"/>
+                </a:solidFill>
+                <a:latin typeface="Aptos"/>
+              </a:defRPr>
+            </a:pPr>
+            <a:r>
+              <a:rPr dirty="0"/>
+              <a:t>Repository interpretation: run_policy_comparison(); the five-policy comparison is a controlled laboratory, not proof of clinical BCI benefit.</a:t>
+            </a:r>
+          </a:p>
+        </p:txBody>
+      </p:sp>
+    </p:spTree>
+  </p:cSld>
+  <p:clrMapOvr>
+    <a:masterClrMapping/>
+  </p:clrMapOvr>
+</p:sld>
+</file>
+
+<file path=ppt/slides/slide31.xml><?xml version="1.0" encoding="utf-8"?>
 <p:sld xmlns:a="http://schemas.openxmlformats.org/drawingml/2006/main" xmlns:r="http://schemas.openxmlformats.org/officeDocument/2006/relationships" xmlns:p="http://schemas.openxmlformats.org/presentationml/2006/main">
   <p:cSld>
     <p:bg>
@@ -22719,7 +23407,7 @@
 </p:sld>
 </file>
 
-<file path=ppt/slides/slide31.xml><?xml version="1.0" encoding="utf-8"?>
+<file path=ppt/slides/slide32.xml><?xml version="1.0" encoding="utf-8"?>
 <p:sld xmlns:a="http://schemas.openxmlformats.org/drawingml/2006/main" xmlns:r="http://schemas.openxmlformats.org/officeDocument/2006/relationships" xmlns:p="http://schemas.openxmlformats.org/presentationml/2006/main">
   <p:cSld>
     <p:bg>
@@ -23351,7 +24039,7 @@
 </p:sld>
 </file>
 
-<file path=ppt/slides/slide32.xml><?xml version="1.0" encoding="utf-8"?>
+<file path=ppt/slides/slide33.xml><?xml version="1.0" encoding="utf-8"?>
 <p:sld xmlns:a="http://schemas.openxmlformats.org/drawingml/2006/main" xmlns:r="http://schemas.openxmlformats.org/officeDocument/2006/relationships" xmlns:p="http://schemas.openxmlformats.org/presentationml/2006/main">
   <p:cSld>
     <p:bg>
@@ -24366,7 +25054,7 @@
 </p:sld>
 </file>
 
-<file path=ppt/slides/slide33.xml><?xml version="1.0" encoding="utf-8"?>
+<file path=ppt/slides/slide34.xml><?xml version="1.0" encoding="utf-8"?>
 <p:sld xmlns:a="http://schemas.openxmlformats.org/drawingml/2006/main" xmlns:r="http://schemas.openxmlformats.org/officeDocument/2006/relationships" xmlns:p="http://schemas.openxmlformats.org/presentationml/2006/main">
   <p:cSld>
     <p:bg>
@@ -25419,7 +26107,7 @@
 </p:sld>
 </file>
 
-<file path=ppt/slides/slide34.xml><?xml version="1.0" encoding="utf-8"?>
+<file path=ppt/slides/slide35.xml><?xml version="1.0" encoding="utf-8"?>
 <p:sld xmlns:a="http://schemas.openxmlformats.org/drawingml/2006/main" xmlns:r="http://schemas.openxmlformats.org/officeDocument/2006/relationships" xmlns:p="http://schemas.openxmlformats.org/presentationml/2006/main">
   <p:cSld>
     <p:bg>
@@ -27122,7 +27810,7 @@
 </p:sld>
 </file>
 
-<file path=ppt/slides/slide35.xml><?xml version="1.0" encoding="utf-8"?>
+<file path=ppt/slides/slide36.xml><?xml version="1.0" encoding="utf-8"?>
 <p:sld xmlns:a="http://schemas.openxmlformats.org/drawingml/2006/main" xmlns:r="http://schemas.openxmlformats.org/officeDocument/2006/relationships" xmlns:p="http://schemas.openxmlformats.org/presentationml/2006/main">
   <p:cSld>
     <p:bg>
@@ -27842,7 +28530,7 @@
 </p:sld>
 </file>
 
-<file path=ppt/slides/slide36.xml><?xml version="1.0" encoding="utf-8"?>
+<file path=ppt/slides/slide37.xml><?xml version="1.0" encoding="utf-8"?>
 <p:sld xmlns:a="http://schemas.openxmlformats.org/drawingml/2006/main" xmlns:r="http://schemas.openxmlformats.org/officeDocument/2006/relationships" xmlns:p="http://schemas.openxmlformats.org/presentationml/2006/main">
   <p:cSld>
     <p:bg>
@@ -28588,7 +29276,7 @@
 </p:sld>
 </file>
 
-<file path=ppt/slides/slide37.xml><?xml version="1.0" encoding="utf-8"?>
+<file path=ppt/slides/slide38.xml><?xml version="1.0" encoding="utf-8"?>
 <p:sld xmlns:a="http://schemas.openxmlformats.org/drawingml/2006/main" xmlns:r="http://schemas.openxmlformats.org/officeDocument/2006/relationships" xmlns:p="http://schemas.openxmlformats.org/presentationml/2006/main">
   <p:cSld>
     <p:bg>
@@ -29184,7 +29872,7 @@
 </p:sld>
 </file>
 
-<file path=ppt/slides/slide38.xml><?xml version="1.0" encoding="utf-8"?>
+<file path=ppt/slides/slide39.xml><?xml version="1.0" encoding="utf-8"?>
 <p:sld xmlns:a="http://schemas.openxmlformats.org/drawingml/2006/main" xmlns:r="http://schemas.openxmlformats.org/officeDocument/2006/relationships" xmlns:p="http://schemas.openxmlformats.org/presentationml/2006/main">
   <p:cSld>
     <p:bg>
@@ -31460,473 +32148,6 @@
 </p:sld>
 </file>
 
-<file path=ppt/slides/slide39.xml><?xml version="1.0" encoding="utf-8"?>
-<p:sld xmlns:a="http://schemas.openxmlformats.org/drawingml/2006/main" xmlns:r="http://schemas.openxmlformats.org/officeDocument/2006/relationships" xmlns:p="http://schemas.openxmlformats.org/presentationml/2006/main">
-  <p:cSld>
-    <p:bg>
-      <p:bgPr>
-        <a:solidFill>
-          <a:srgbClr val="09121F"/>
-        </a:solidFill>
-        <a:effectLst/>
-      </p:bgPr>
-    </p:bg>
-    <p:spTree>
-      <p:nvGrpSpPr>
-        <p:cNvPr id="1" name=""/>
-        <p:cNvGrpSpPr/>
-        <p:nvPr/>
-      </p:nvGrpSpPr>
-      <p:grpSpPr>
-        <a:xfrm>
-          <a:off x="0" y="0"/>
-          <a:ext cx="0" cy="0"/>
-          <a:chOff x="0" y="0"/>
-          <a:chExt cx="0" cy="0"/>
-        </a:xfrm>
-      </p:grpSpPr>
-      <p:sp>
-        <p:nvSpPr>
-          <p:cNvPr id="2" name="TextBox 1"/>
-          <p:cNvSpPr txBox="1"/>
-          <p:nvPr/>
-        </p:nvSpPr>
-        <p:spPr>
-          <a:xfrm>
-            <a:off x="612648" y="292608"/>
-            <a:ext cx="10972800" cy="292608"/>
-          </a:xfrm>
-          <a:prstGeom prst="rect">
-            <a:avLst/>
-          </a:prstGeom>
-          <a:noFill/>
-        </p:spPr>
-        <p:txBody>
-          <a:bodyPr wrap="square" lIns="0" rIns="0">
-            <a:spAutoFit/>
-          </a:bodyPr>
-          <a:lstStyle/>
-          <a:p>
-            <a:pPr>
-              <a:spcAft>
-                <a:spcPts val="900"/>
-              </a:spcAft>
-              <a:defRPr sz="1300" b="1">
-                <a:solidFill>
-                  <a:srgbClr val="78D8CC"/>
-                </a:solidFill>
-                <a:latin typeface="DejaVu Sans"/>
-              </a:defRPr>
-            </a:pPr>
-            <a:r>
-              <a:rPr dirty="0"/>
-              <a:t>NEXT MILESTONE</a:t>
-            </a:r>
-          </a:p>
-        </p:txBody>
-      </p:sp>
-      <p:sp>
-        <p:nvSpPr>
-          <p:cNvPr id="3" name="TextBox 2"/>
-          <p:cNvSpPr txBox="1"/>
-          <p:nvPr/>
-        </p:nvSpPr>
-        <p:spPr>
-          <a:xfrm>
-            <a:off x="612648" y="777240"/>
-            <a:ext cx="10972800" cy="640080"/>
-          </a:xfrm>
-          <a:prstGeom prst="rect">
-            <a:avLst/>
-          </a:prstGeom>
-          <a:noFill/>
-        </p:spPr>
-        <p:txBody>
-          <a:bodyPr wrap="square" lIns="0" rIns="0">
-            <a:spAutoFit/>
-          </a:bodyPr>
-          <a:lstStyle/>
-          <a:p>
-            <a:pPr>
-              <a:spcAft>
-                <a:spcPts val="900"/>
-              </a:spcAft>
-              <a:defRPr sz="2700" b="1">
-                <a:solidFill>
-                  <a:srgbClr val="EAF2F8"/>
-                </a:solidFill>
-                <a:latin typeface="DejaVu Sans"/>
-              </a:defRPr>
-            </a:pPr>
-            <a:r>
-              <a:rPr dirty="0"/>
-              <a:t>Next milestone: a reproducible evidence package</a:t>
-            </a:r>
-          </a:p>
-        </p:txBody>
-      </p:sp>
-      <p:sp>
-        <p:nvSpPr>
-          <p:cNvPr id="4" name="TextBox 3"/>
-          <p:cNvSpPr txBox="1"/>
-          <p:nvPr/>
-        </p:nvSpPr>
-        <p:spPr>
-          <a:xfrm>
-            <a:off x="612648" y="6053328"/>
-            <a:ext cx="10972800" cy="329184"/>
-          </a:xfrm>
-          <a:prstGeom prst="rect">
-            <a:avLst/>
-          </a:prstGeom>
-          <a:noFill/>
-        </p:spPr>
-        <p:txBody>
-          <a:bodyPr wrap="square" lIns="0" rIns="0">
-            <a:spAutoFit/>
-          </a:bodyPr>
-          <a:lstStyle/>
-          <a:p>
-            <a:pPr>
-              <a:spcAft>
-                <a:spcPts val="900"/>
-              </a:spcAft>
-              <a:defRPr sz="1100" b="0">
-                <a:solidFill>
-                  <a:srgbClr val="9CB0C3"/>
-                </a:solidFill>
-                <a:latin typeface="DejaVu Sans"/>
-              </a:defRPr>
-            </a:pPr>
-            <a:r>
-              <a:rPr dirty="0"/>
-              <a:t>Repository evidence: 2a8d20b. Implemented capabilities and stored results are distinguished.</a:t>
-            </a:r>
-          </a:p>
-        </p:txBody>
-      </p:sp>
-      <p:sp>
-        <p:nvSpPr>
-          <p:cNvPr id="5" name="TextBox 4"/>
-          <p:cNvSpPr txBox="1"/>
-          <p:nvPr/>
-        </p:nvSpPr>
-        <p:spPr>
-          <a:xfrm>
-            <a:off x="612648" y="6510528"/>
-            <a:ext cx="9144000" cy="182880"/>
-          </a:xfrm>
-          <a:prstGeom prst="rect">
-            <a:avLst/>
-          </a:prstGeom>
-          <a:noFill/>
-        </p:spPr>
-        <p:txBody>
-          <a:bodyPr wrap="square" lIns="0" rIns="0">
-            <a:spAutoFit/>
-          </a:bodyPr>
-          <a:lstStyle/>
-          <a:p>
-            <a:pPr>
-              <a:spcAft>
-                <a:spcPts val="900"/>
-              </a:spcAft>
-              <a:defRPr sz="800" b="0">
-                <a:solidFill>
-                  <a:srgbClr val="9CB0C3"/>
-                </a:solidFill>
-                <a:latin typeface="DejaVu Sans"/>
-              </a:defRPr>
-            </a:pPr>
-            <a:r>
-              <a:rPr dirty="0"/>
-              <a:t>hlin863/ewma_covariate_shift_demo</a:t>
-            </a:r>
-          </a:p>
-        </p:txBody>
-      </p:sp>
-      <p:sp>
-        <p:nvSpPr>
-          <p:cNvPr id="6" name="TextBox 5"/>
-          <p:cNvSpPr txBox="1"/>
-          <p:nvPr/>
-        </p:nvSpPr>
-        <p:spPr>
-          <a:xfrm>
-            <a:off x="685800" y="1709928"/>
-            <a:ext cx="10789920" cy="457200"/>
-          </a:xfrm>
-          <a:prstGeom prst="rect">
-            <a:avLst/>
-          </a:prstGeom>
-          <a:noFill/>
-        </p:spPr>
-        <p:txBody>
-          <a:bodyPr wrap="square" lIns="0" rIns="0">
-            <a:spAutoFit/>
-          </a:bodyPr>
-          <a:lstStyle/>
-          <a:p>
-            <a:pPr>
-              <a:spcAft>
-                <a:spcPts val="900"/>
-              </a:spcAft>
-              <a:defRPr sz="2300" b="1">
-                <a:solidFill>
-                  <a:srgbClr val="78D8CC"/>
-                </a:solidFill>
-                <a:latin typeface="DejaVu Sans"/>
-              </a:defRPr>
-            </a:pPr>
-            <a:r>
-              <a:rPr dirty="0"/>
-              <a:t>1. Reconcile the saved reproduction runs</a:t>
-            </a:r>
-          </a:p>
-        </p:txBody>
-      </p:sp>
-      <p:sp>
-        <p:nvSpPr>
-          <p:cNvPr id="7" name="TextBox 6"/>
-          <p:cNvSpPr txBox="1"/>
-          <p:nvPr/>
-        </p:nvSpPr>
-        <p:spPr>
-          <a:xfrm>
-            <a:off x="685800" y="2249424"/>
-            <a:ext cx="10789920" cy="548640"/>
-          </a:xfrm>
-          <a:prstGeom prst="rect">
-            <a:avLst/>
-          </a:prstGeom>
-          <a:noFill/>
-        </p:spPr>
-        <p:txBody>
-          <a:bodyPr wrap="square" lIns="0" rIns="0">
-            <a:spAutoFit/>
-          </a:bodyPr>
-          <a:lstStyle/>
-          <a:p>
-            <a:pPr>
-              <a:spcAft>
-                <a:spcPts val="900"/>
-              </a:spcAft>
-              <a:defRPr sz="2000" b="0">
-                <a:solidFill>
-                  <a:srgbClr val="EAF2F8"/>
-                </a:solidFill>
-                <a:latin typeface="DejaVu Sans"/>
-              </a:defRPr>
-            </a:pPr>
-            <a:r>
-              <a:rPr dirty="0"/>
-              <a:t>Lock settings and explain the Stage-II accepted, rejected and ineligible events.</a:t>
-            </a:r>
-          </a:p>
-        </p:txBody>
-      </p:sp>
-      <p:sp>
-        <p:nvSpPr>
-          <p:cNvPr id="8" name="TextBox 7"/>
-          <p:cNvSpPr txBox="1"/>
-          <p:nvPr/>
-        </p:nvSpPr>
-        <p:spPr>
-          <a:xfrm>
-            <a:off x="685800" y="2990088"/>
-            <a:ext cx="10789920" cy="457200"/>
-          </a:xfrm>
-          <a:prstGeom prst="rect">
-            <a:avLst/>
-          </a:prstGeom>
-          <a:noFill/>
-        </p:spPr>
-        <p:txBody>
-          <a:bodyPr wrap="square" lIns="0" rIns="0">
-            <a:spAutoFit/>
-          </a:bodyPr>
-          <a:lstStyle/>
-          <a:p>
-            <a:pPr>
-              <a:spcAft>
-                <a:spcPts val="900"/>
-              </a:spcAft>
-              <a:defRPr sz="2300" b="1">
-                <a:solidFill>
-                  <a:srgbClr val="78D8CC"/>
-                </a:solidFill>
-                <a:latin typeface="DejaVu Sans"/>
-              </a:defRPr>
-            </a:pPr>
-            <a:r>
-              <a:rPr dirty="0"/>
-              <a:t>2. Generate adaptation and real EEG evidence</a:t>
-            </a:r>
-          </a:p>
-        </p:txBody>
-      </p:sp>
-      <p:sp>
-        <p:nvSpPr>
-          <p:cNvPr id="9" name="TextBox 8"/>
-          <p:cNvSpPr txBox="1"/>
-          <p:nvPr/>
-        </p:nvSpPr>
-        <p:spPr>
-          <a:xfrm>
-            <a:off x="685800" y="3529584"/>
-            <a:ext cx="10789920" cy="640080"/>
-          </a:xfrm>
-          <a:prstGeom prst="rect">
-            <a:avLst/>
-          </a:prstGeom>
-          <a:noFill/>
-        </p:spPr>
-        <p:txBody>
-          <a:bodyPr wrap="square" lIns="0" rIns="0">
-            <a:spAutoFit/>
-          </a:bodyPr>
-          <a:lstStyle/>
-          <a:p>
-            <a:pPr>
-              <a:spcAft>
-                <a:spcPts val="900"/>
-              </a:spcAft>
-              <a:defRPr sz="2000" b="0">
-                <a:solidFill>
-                  <a:srgbClr val="EAF2F8"/>
-                </a:solidFill>
-                <a:latin typeface="DejaVu Sans"/>
-              </a:defRPr>
-            </a:pPr>
-            <a:r>
-              <a:rPr dirty="0"/>
-              <a:t>Extend the saved Diethe pilot across three scenarios and 20 seeds. Export 2A/2B complementary traces.</a:t>
-            </a:r>
-          </a:p>
-        </p:txBody>
-      </p:sp>
-      <p:sp>
-        <p:nvSpPr>
-          <p:cNvPr id="10" name="TextBox 9"/>
-          <p:cNvSpPr txBox="1"/>
-          <p:nvPr/>
-        </p:nvSpPr>
-        <p:spPr>
-          <a:xfrm>
-            <a:off x="685800" y="4389120"/>
-            <a:ext cx="10789920" cy="457200"/>
-          </a:xfrm>
-          <a:prstGeom prst="rect">
-            <a:avLst/>
-          </a:prstGeom>
-          <a:noFill/>
-        </p:spPr>
-        <p:txBody>
-          <a:bodyPr wrap="square" lIns="0" rIns="0">
-            <a:spAutoFit/>
-          </a:bodyPr>
-          <a:lstStyle/>
-          <a:p>
-            <a:pPr>
-              <a:spcAft>
-                <a:spcPts val="900"/>
-              </a:spcAft>
-              <a:defRPr sz="2300" b="1">
-                <a:solidFill>
-                  <a:srgbClr val="78D8CC"/>
-                </a:solidFill>
-                <a:latin typeface="DejaVu Sans"/>
-              </a:defRPr>
-            </a:pPr>
-            <a:r>
-              <a:rPr dirty="0"/>
-              <a:t>3. Align tests, slides and research notes</a:t>
-            </a:r>
-          </a:p>
-        </p:txBody>
-      </p:sp>
-      <p:sp>
-        <p:nvSpPr>
-          <p:cNvPr id="11" name="TextBox 10"/>
-          <p:cNvSpPr txBox="1"/>
-          <p:nvPr/>
-        </p:nvSpPr>
-        <p:spPr>
-          <a:xfrm>
-            <a:off x="685800" y="4919472"/>
-            <a:ext cx="10789920" cy="777240"/>
-          </a:xfrm>
-          <a:prstGeom prst="rect">
-            <a:avLst/>
-          </a:prstGeom>
-          <a:noFill/>
-        </p:spPr>
-        <p:txBody>
-          <a:bodyPr wrap="square" lIns="0" rIns="0">
-            <a:spAutoFit/>
-          </a:bodyPr>
-          <a:lstStyle/>
-          <a:p>
-            <a:pPr>
-              <a:spcAft>
-                <a:spcPts val="900"/>
-              </a:spcAft>
-              <a:defRPr sz="2000" b="0">
-                <a:solidFill>
-                  <a:srgbClr val="EAF2F8"/>
-                </a:solidFill>
-                <a:latin typeface="DejaVu Sans"/>
-              </a:defRPr>
-            </a:pPr>
-            <a:r>
-              <a:rPr dirty="0"/>
-              <a:t>Resolve the homepage route assertion. Refresh Notion implementation status and link every numerical claim to its run.</a:t>
-            </a:r>
-          </a:p>
-        </p:txBody>
-      </p:sp>
-      <p:sp>
-        <p:nvSpPr>
-          <p:cNvPr id="12" name="TextBox 11"/>
-          <p:cNvSpPr txBox="1"/>
-          <p:nvPr/>
-        </p:nvSpPr>
-        <p:spPr>
-          <a:xfrm>
-            <a:off x="11045952" y="6510528"/>
-            <a:ext cx="548640" cy="182880"/>
-          </a:xfrm>
-          <a:prstGeom prst="rect">
-            <a:avLst/>
-          </a:prstGeom>
-          <a:noFill/>
-        </p:spPr>
-        <p:txBody>
-          <a:bodyPr wrap="square" lIns="0" rIns="0">
-            <a:spAutoFit/>
-          </a:bodyPr>
-          <a:lstStyle/>
-          <a:p>
-            <a:r>
-              <a:rPr dirty="0"/>
-              <a:t>26</a:t>
-            </a:r>
-          </a:p>
-        </p:txBody>
-      </p:sp>
-    </p:spTree>
-    <p:extLst>
-      <p:ext uri="{BB962C8B-B14F-4D97-AF65-F5344CB8AC3E}">
-        <p14:creationId xmlns:p14="http://schemas.microsoft.com/office/powerpoint/2010/main" val="190331914"/>
-      </p:ext>
-    </p:extLst>
-  </p:cSld>
-  <p:clrMapOvr>
-    <a:masterClrMapping/>
-  </p:clrMapOvr>
-</p:sld>
-</file>
-
 <file path=ppt/slides/slide4.xml><?xml version="1.0" encoding="utf-8"?>
 <p:sld xmlns:a="http://schemas.openxmlformats.org/drawingml/2006/main" xmlns:r="http://schemas.openxmlformats.org/officeDocument/2006/relationships" xmlns:p="http://schemas.openxmlformats.org/presentationml/2006/main">
   <p:cSld>
@@ -32542,6 +32763,473 @@
     <p:bg>
       <p:bgPr>
         <a:solidFill>
+          <a:srgbClr val="09121F"/>
+        </a:solidFill>
+        <a:effectLst/>
+      </p:bgPr>
+    </p:bg>
+    <p:spTree>
+      <p:nvGrpSpPr>
+        <p:cNvPr id="1" name=""/>
+        <p:cNvGrpSpPr/>
+        <p:nvPr/>
+      </p:nvGrpSpPr>
+      <p:grpSpPr>
+        <a:xfrm>
+          <a:off x="0" y="0"/>
+          <a:ext cx="0" cy="0"/>
+          <a:chOff x="0" y="0"/>
+          <a:chExt cx="0" cy="0"/>
+        </a:xfrm>
+      </p:grpSpPr>
+      <p:sp>
+        <p:nvSpPr>
+          <p:cNvPr id="2" name="TextBox 1"/>
+          <p:cNvSpPr txBox="1"/>
+          <p:nvPr/>
+        </p:nvSpPr>
+        <p:spPr>
+          <a:xfrm>
+            <a:off x="612648" y="292608"/>
+            <a:ext cx="10972800" cy="292608"/>
+          </a:xfrm>
+          <a:prstGeom prst="rect">
+            <a:avLst/>
+          </a:prstGeom>
+          <a:noFill/>
+        </p:spPr>
+        <p:txBody>
+          <a:bodyPr wrap="square" lIns="0" rIns="0">
+            <a:spAutoFit/>
+          </a:bodyPr>
+          <a:lstStyle/>
+          <a:p>
+            <a:pPr>
+              <a:spcAft>
+                <a:spcPts val="900"/>
+              </a:spcAft>
+              <a:defRPr sz="1300" b="1">
+                <a:solidFill>
+                  <a:srgbClr val="78D8CC"/>
+                </a:solidFill>
+                <a:latin typeface="DejaVu Sans"/>
+              </a:defRPr>
+            </a:pPr>
+            <a:r>
+              <a:rPr dirty="0"/>
+              <a:t>NEXT MILESTONE</a:t>
+            </a:r>
+          </a:p>
+        </p:txBody>
+      </p:sp>
+      <p:sp>
+        <p:nvSpPr>
+          <p:cNvPr id="3" name="TextBox 2"/>
+          <p:cNvSpPr txBox="1"/>
+          <p:nvPr/>
+        </p:nvSpPr>
+        <p:spPr>
+          <a:xfrm>
+            <a:off x="612648" y="777240"/>
+            <a:ext cx="10972800" cy="640080"/>
+          </a:xfrm>
+          <a:prstGeom prst="rect">
+            <a:avLst/>
+          </a:prstGeom>
+          <a:noFill/>
+        </p:spPr>
+        <p:txBody>
+          <a:bodyPr wrap="square" lIns="0" rIns="0">
+            <a:spAutoFit/>
+          </a:bodyPr>
+          <a:lstStyle/>
+          <a:p>
+            <a:pPr>
+              <a:spcAft>
+                <a:spcPts val="900"/>
+              </a:spcAft>
+              <a:defRPr sz="2700" b="1">
+                <a:solidFill>
+                  <a:srgbClr val="EAF2F8"/>
+                </a:solidFill>
+                <a:latin typeface="DejaVu Sans"/>
+              </a:defRPr>
+            </a:pPr>
+            <a:r>
+              <a:rPr dirty="0"/>
+              <a:t>Next milestone: a reproducible evidence package</a:t>
+            </a:r>
+          </a:p>
+        </p:txBody>
+      </p:sp>
+      <p:sp>
+        <p:nvSpPr>
+          <p:cNvPr id="4" name="TextBox 3"/>
+          <p:cNvSpPr txBox="1"/>
+          <p:nvPr/>
+        </p:nvSpPr>
+        <p:spPr>
+          <a:xfrm>
+            <a:off x="612648" y="6053328"/>
+            <a:ext cx="10972800" cy="329184"/>
+          </a:xfrm>
+          <a:prstGeom prst="rect">
+            <a:avLst/>
+          </a:prstGeom>
+          <a:noFill/>
+        </p:spPr>
+        <p:txBody>
+          <a:bodyPr wrap="square" lIns="0" rIns="0">
+            <a:spAutoFit/>
+          </a:bodyPr>
+          <a:lstStyle/>
+          <a:p>
+            <a:pPr>
+              <a:spcAft>
+                <a:spcPts val="900"/>
+              </a:spcAft>
+              <a:defRPr sz="1100" b="0">
+                <a:solidFill>
+                  <a:srgbClr val="9CB0C3"/>
+                </a:solidFill>
+                <a:latin typeface="DejaVu Sans"/>
+              </a:defRPr>
+            </a:pPr>
+            <a:r>
+              <a:rPr dirty="0"/>
+              <a:t>Repository evidence: 2a8d20b. Implemented capabilities and stored results are distinguished.</a:t>
+            </a:r>
+          </a:p>
+        </p:txBody>
+      </p:sp>
+      <p:sp>
+        <p:nvSpPr>
+          <p:cNvPr id="5" name="TextBox 4"/>
+          <p:cNvSpPr txBox="1"/>
+          <p:nvPr/>
+        </p:nvSpPr>
+        <p:spPr>
+          <a:xfrm>
+            <a:off x="612648" y="6510528"/>
+            <a:ext cx="9144000" cy="182880"/>
+          </a:xfrm>
+          <a:prstGeom prst="rect">
+            <a:avLst/>
+          </a:prstGeom>
+          <a:noFill/>
+        </p:spPr>
+        <p:txBody>
+          <a:bodyPr wrap="square" lIns="0" rIns="0">
+            <a:spAutoFit/>
+          </a:bodyPr>
+          <a:lstStyle/>
+          <a:p>
+            <a:pPr>
+              <a:spcAft>
+                <a:spcPts val="900"/>
+              </a:spcAft>
+              <a:defRPr sz="800" b="0">
+                <a:solidFill>
+                  <a:srgbClr val="9CB0C3"/>
+                </a:solidFill>
+                <a:latin typeface="DejaVu Sans"/>
+              </a:defRPr>
+            </a:pPr>
+            <a:r>
+              <a:rPr dirty="0"/>
+              <a:t>hlin863/ewma_covariate_shift_demo</a:t>
+            </a:r>
+          </a:p>
+        </p:txBody>
+      </p:sp>
+      <p:sp>
+        <p:nvSpPr>
+          <p:cNvPr id="6" name="TextBox 5"/>
+          <p:cNvSpPr txBox="1"/>
+          <p:nvPr/>
+        </p:nvSpPr>
+        <p:spPr>
+          <a:xfrm>
+            <a:off x="685800" y="1709928"/>
+            <a:ext cx="10789920" cy="457200"/>
+          </a:xfrm>
+          <a:prstGeom prst="rect">
+            <a:avLst/>
+          </a:prstGeom>
+          <a:noFill/>
+        </p:spPr>
+        <p:txBody>
+          <a:bodyPr wrap="square" lIns="0" rIns="0">
+            <a:spAutoFit/>
+          </a:bodyPr>
+          <a:lstStyle/>
+          <a:p>
+            <a:pPr>
+              <a:spcAft>
+                <a:spcPts val="900"/>
+              </a:spcAft>
+              <a:defRPr sz="2300" b="1">
+                <a:solidFill>
+                  <a:srgbClr val="78D8CC"/>
+                </a:solidFill>
+                <a:latin typeface="DejaVu Sans"/>
+              </a:defRPr>
+            </a:pPr>
+            <a:r>
+              <a:rPr dirty="0"/>
+              <a:t>1. Reconcile the saved reproduction runs</a:t>
+            </a:r>
+          </a:p>
+        </p:txBody>
+      </p:sp>
+      <p:sp>
+        <p:nvSpPr>
+          <p:cNvPr id="7" name="TextBox 6"/>
+          <p:cNvSpPr txBox="1"/>
+          <p:nvPr/>
+        </p:nvSpPr>
+        <p:spPr>
+          <a:xfrm>
+            <a:off x="685800" y="2249424"/>
+            <a:ext cx="10789920" cy="548640"/>
+          </a:xfrm>
+          <a:prstGeom prst="rect">
+            <a:avLst/>
+          </a:prstGeom>
+          <a:noFill/>
+        </p:spPr>
+        <p:txBody>
+          <a:bodyPr wrap="square" lIns="0" rIns="0">
+            <a:spAutoFit/>
+          </a:bodyPr>
+          <a:lstStyle/>
+          <a:p>
+            <a:pPr>
+              <a:spcAft>
+                <a:spcPts val="900"/>
+              </a:spcAft>
+              <a:defRPr sz="2000" b="0">
+                <a:solidFill>
+                  <a:srgbClr val="EAF2F8"/>
+                </a:solidFill>
+                <a:latin typeface="DejaVu Sans"/>
+              </a:defRPr>
+            </a:pPr>
+            <a:r>
+              <a:rPr dirty="0"/>
+              <a:t>Lock settings and explain the Stage-II accepted, rejected and ineligible events.</a:t>
+            </a:r>
+          </a:p>
+        </p:txBody>
+      </p:sp>
+      <p:sp>
+        <p:nvSpPr>
+          <p:cNvPr id="8" name="TextBox 7"/>
+          <p:cNvSpPr txBox="1"/>
+          <p:nvPr/>
+        </p:nvSpPr>
+        <p:spPr>
+          <a:xfrm>
+            <a:off x="685800" y="2990088"/>
+            <a:ext cx="10789920" cy="457200"/>
+          </a:xfrm>
+          <a:prstGeom prst="rect">
+            <a:avLst/>
+          </a:prstGeom>
+          <a:noFill/>
+        </p:spPr>
+        <p:txBody>
+          <a:bodyPr wrap="square" lIns="0" rIns="0">
+            <a:spAutoFit/>
+          </a:bodyPr>
+          <a:lstStyle/>
+          <a:p>
+            <a:pPr>
+              <a:spcAft>
+                <a:spcPts val="900"/>
+              </a:spcAft>
+              <a:defRPr sz="2300" b="1">
+                <a:solidFill>
+                  <a:srgbClr val="78D8CC"/>
+                </a:solidFill>
+                <a:latin typeface="DejaVu Sans"/>
+              </a:defRPr>
+            </a:pPr>
+            <a:r>
+              <a:rPr dirty="0"/>
+              <a:t>2. Generate adaptation and real EEG evidence</a:t>
+            </a:r>
+          </a:p>
+        </p:txBody>
+      </p:sp>
+      <p:sp>
+        <p:nvSpPr>
+          <p:cNvPr id="9" name="TextBox 8"/>
+          <p:cNvSpPr txBox="1"/>
+          <p:nvPr/>
+        </p:nvSpPr>
+        <p:spPr>
+          <a:xfrm>
+            <a:off x="685800" y="3529584"/>
+            <a:ext cx="10789920" cy="640080"/>
+          </a:xfrm>
+          <a:prstGeom prst="rect">
+            <a:avLst/>
+          </a:prstGeom>
+          <a:noFill/>
+        </p:spPr>
+        <p:txBody>
+          <a:bodyPr wrap="square" lIns="0" rIns="0">
+            <a:spAutoFit/>
+          </a:bodyPr>
+          <a:lstStyle/>
+          <a:p>
+            <a:pPr>
+              <a:spcAft>
+                <a:spcPts val="900"/>
+              </a:spcAft>
+              <a:defRPr sz="2000" b="0">
+                <a:solidFill>
+                  <a:srgbClr val="EAF2F8"/>
+                </a:solidFill>
+                <a:latin typeface="DejaVu Sans"/>
+              </a:defRPr>
+            </a:pPr>
+            <a:r>
+              <a:rPr dirty="0"/>
+              <a:t>Extend the saved Diethe pilot across three scenarios and 20 seeds. Export 2A/2B complementary traces.</a:t>
+            </a:r>
+          </a:p>
+        </p:txBody>
+      </p:sp>
+      <p:sp>
+        <p:nvSpPr>
+          <p:cNvPr id="10" name="TextBox 9"/>
+          <p:cNvSpPr txBox="1"/>
+          <p:nvPr/>
+        </p:nvSpPr>
+        <p:spPr>
+          <a:xfrm>
+            <a:off x="685800" y="4389120"/>
+            <a:ext cx="10789920" cy="457200"/>
+          </a:xfrm>
+          <a:prstGeom prst="rect">
+            <a:avLst/>
+          </a:prstGeom>
+          <a:noFill/>
+        </p:spPr>
+        <p:txBody>
+          <a:bodyPr wrap="square" lIns="0" rIns="0">
+            <a:spAutoFit/>
+          </a:bodyPr>
+          <a:lstStyle/>
+          <a:p>
+            <a:pPr>
+              <a:spcAft>
+                <a:spcPts val="900"/>
+              </a:spcAft>
+              <a:defRPr sz="2300" b="1">
+                <a:solidFill>
+                  <a:srgbClr val="78D8CC"/>
+                </a:solidFill>
+                <a:latin typeface="DejaVu Sans"/>
+              </a:defRPr>
+            </a:pPr>
+            <a:r>
+              <a:rPr dirty="0"/>
+              <a:t>3. Align tests, slides and research notes</a:t>
+            </a:r>
+          </a:p>
+        </p:txBody>
+      </p:sp>
+      <p:sp>
+        <p:nvSpPr>
+          <p:cNvPr id="11" name="TextBox 10"/>
+          <p:cNvSpPr txBox="1"/>
+          <p:nvPr/>
+        </p:nvSpPr>
+        <p:spPr>
+          <a:xfrm>
+            <a:off x="685800" y="4919472"/>
+            <a:ext cx="10789920" cy="777240"/>
+          </a:xfrm>
+          <a:prstGeom prst="rect">
+            <a:avLst/>
+          </a:prstGeom>
+          <a:noFill/>
+        </p:spPr>
+        <p:txBody>
+          <a:bodyPr wrap="square" lIns="0" rIns="0">
+            <a:spAutoFit/>
+          </a:bodyPr>
+          <a:lstStyle/>
+          <a:p>
+            <a:pPr>
+              <a:spcAft>
+                <a:spcPts val="900"/>
+              </a:spcAft>
+              <a:defRPr sz="2000" b="0">
+                <a:solidFill>
+                  <a:srgbClr val="EAF2F8"/>
+                </a:solidFill>
+                <a:latin typeface="DejaVu Sans"/>
+              </a:defRPr>
+            </a:pPr>
+            <a:r>
+              <a:rPr dirty="0"/>
+              <a:t>Resolve the homepage route assertion. Refresh Notion implementation status and link every numerical claim to its run.</a:t>
+            </a:r>
+          </a:p>
+        </p:txBody>
+      </p:sp>
+      <p:sp>
+        <p:nvSpPr>
+          <p:cNvPr id="12" name="TextBox 11"/>
+          <p:cNvSpPr txBox="1"/>
+          <p:nvPr/>
+        </p:nvSpPr>
+        <p:spPr>
+          <a:xfrm>
+            <a:off x="11045952" y="6510528"/>
+            <a:ext cx="548640" cy="182880"/>
+          </a:xfrm>
+          <a:prstGeom prst="rect">
+            <a:avLst/>
+          </a:prstGeom>
+          <a:noFill/>
+        </p:spPr>
+        <p:txBody>
+          <a:bodyPr wrap="square" lIns="0" rIns="0">
+            <a:spAutoFit/>
+          </a:bodyPr>
+          <a:lstStyle/>
+          <a:p>
+            <a:r>
+              <a:rPr dirty="0"/>
+              <a:t>26</a:t>
+            </a:r>
+          </a:p>
+        </p:txBody>
+      </p:sp>
+    </p:spTree>
+    <p:extLst>
+      <p:ext uri="{BB962C8B-B14F-4D97-AF65-F5344CB8AC3E}">
+        <p14:creationId xmlns:p14="http://schemas.microsoft.com/office/powerpoint/2010/main" val="190331914"/>
+      </p:ext>
+    </p:extLst>
+  </p:cSld>
+  <p:clrMapOvr>
+    <a:masterClrMapping/>
+  </p:clrMapOvr>
+</p:sld>
+</file>
+
+<file path=ppt/slides/slide41.xml><?xml version="1.0" encoding="utf-8"?>
+<p:sld xmlns:a="http://schemas.openxmlformats.org/drawingml/2006/main" xmlns:r="http://schemas.openxmlformats.org/officeDocument/2006/relationships" xmlns:p="http://schemas.openxmlformats.org/presentationml/2006/main">
+  <p:cSld>
+    <p:bg>
+      <p:bgPr>
+        <a:solidFill>
           <a:srgbClr val="F7F9FC"/>
         </a:solidFill>
         <a:effectLst/>
@@ -33020,7 +33708,7 @@
 </p:sld>
 </file>
 
-<file path=ppt/slides/slide41.xml><?xml version="1.0" encoding="utf-8"?>
+<file path=ppt/slides/slide42.xml><?xml version="1.0" encoding="utf-8"?>
 <p:sld xmlns:a="http://schemas.openxmlformats.org/drawingml/2006/main" xmlns:r="http://schemas.openxmlformats.org/officeDocument/2006/relationships" xmlns:p="http://schemas.openxmlformats.org/presentationml/2006/main">
   <p:cSld>
     <p:bg>
@@ -34798,8 +35486,8 @@
           </a:p>
         </p:txBody>
       </p:sp>
-      <mc:AlternateContent xmlns:mc="http://schemas.openxmlformats.org/markup-compatibility/2006">
-        <mc:Choice xmlns:a14="http://schemas.microsoft.com/office/drawing/2010/main" Requires="a14">
+      <mc:AlternateContent xmlns:mc="http://schemas.openxmlformats.org/markup-compatibility/2006" xmlns:a14="http://schemas.microsoft.com/office/drawing/2010/main">
+        <mc:Choice Requires="a14">
           <p:sp>
             <p:nvSpPr>
               <p:cNvPr id="13" name="TextBox 12">
@@ -34828,16 +35516,14 @@
               </a:bodyPr>
               <a:lstStyle/>
               <a:p>
+                <a:pPr/>
                 <a14:m>
                   <m:oMathPara xmlns:m="http://schemas.openxmlformats.org/officeDocument/2006/math">
-                    <m:oMathParaPr>
-                      <m:jc m:val="centerGroup"/>
-                    </m:oMathParaPr>
-                    <m:oMath xmlns:m="http://schemas.openxmlformats.org/officeDocument/2006/math">
+                    <m:oMath>
                       <m:sSubSup>
                         <m:sSubSupPr>
                           <m:ctrlPr>
-                            <a:rPr lang="en-GB" sz="1200" i="1" smtClean="0">
+                            <a:rPr lang="en-US" sz="1200" b="0" i="1" smtClean="0">
                               <a:latin typeface="Cambria Math" panose="02040503050406030204" pitchFamily="18" charset="0"/>
                             </a:rPr>
                           </m:ctrlPr>
@@ -35222,7 +35908,7 @@
                               <m:f>
                                 <m:fPr>
                                   <m:ctrlPr>
-                                    <a:rPr lang="en-US" sz="1200" i="1">
+                                    <a:rPr lang="en-US" sz="1200" b="0" i="1" smtClean="0">
                                       <a:latin typeface="Cambria Math" panose="02040503050406030204" pitchFamily="18" charset="0"/>
                                     </a:rPr>
                                   </m:ctrlPr>
@@ -35393,7 +36079,7 @@
             </p:txBody>
           </p:sp>
         </mc:Choice>
-        <mc:Fallback>
+        <mc:Fallback xmlns="">
           <p:sp>
             <p:nvSpPr>
               <p:cNvPr id="13" name="TextBox 12">
@@ -35772,8 +36458,8 @@
           </a:p>
         </p:txBody>
       </p:sp>
-      <mc:AlternateContent xmlns:mc="http://schemas.openxmlformats.org/markup-compatibility/2006">
-        <mc:Choice xmlns:a14="http://schemas.microsoft.com/office/drawing/2010/main" Requires="a14">
+      <mc:AlternateContent xmlns:mc="http://schemas.openxmlformats.org/markup-compatibility/2006" xmlns:a14="http://schemas.microsoft.com/office/drawing/2010/main">
+        <mc:Choice Requires="a14">
           <p:sp>
             <p:nvSpPr>
               <p:cNvPr id="8" name="TextBox 7"/>
@@ -35809,14 +36495,11 @@
                 </a:pPr>
                 <a14:m>
                   <m:oMathPara xmlns:m="http://schemas.openxmlformats.org/officeDocument/2006/math">
-                    <m:oMathParaPr>
-                      <m:jc m:val="centerGroup"/>
-                    </m:oMathParaPr>
-                    <m:oMath xmlns:m="http://schemas.openxmlformats.org/officeDocument/2006/math">
+                    <m:oMath>
                       <m:sSubSup>
                         <m:sSubSupPr>
                           <m:ctrlPr>
-                            <a:rPr lang="en-US" sz="1200" i="1" smtClean="0">
+                            <a:rPr lang="en-US" sz="1200" b="0" i="1" smtClean="0">
                               <a:latin typeface="Cambria Math" panose="02040503050406030204" pitchFamily="18" charset="0"/>
                             </a:rPr>
                           </m:ctrlPr>
@@ -35864,7 +36547,7 @@
                           <m:limLow>
                             <m:limLowPr>
                               <m:ctrlPr>
-                                <a:rPr lang="en-US" sz="1200" b="0" i="1" smtClean="0">
+                                <a:rPr lang="en-US" sz="1200" b="0" i="0" smtClean="0">
                                   <a:latin typeface="Cambria Math" panose="02040503050406030204" pitchFamily="18" charset="0"/>
                                 </a:rPr>
                               </m:ctrlPr>
@@ -35974,7 +36657,7 @@
             </p:txBody>
           </p:sp>
         </mc:Choice>
-        <mc:Fallback>
+        <mc:Fallback xmlns="">
           <p:sp>
             <p:nvSpPr>
               <p:cNvPr id="8" name="TextBox 7"/>
@@ -36140,8 +36823,8 @@
           </a:p>
         </p:txBody>
       </p:sp>
-      <mc:AlternateContent xmlns:mc="http://schemas.openxmlformats.org/markup-compatibility/2006">
-        <mc:Choice xmlns:a14="http://schemas.microsoft.com/office/drawing/2010/main" Requires="a14">
+      <mc:AlternateContent xmlns:mc="http://schemas.openxmlformats.org/markup-compatibility/2006" xmlns:a14="http://schemas.microsoft.com/office/drawing/2010/main">
+        <mc:Choice Requires="a14">
           <p:sp>
             <p:nvSpPr>
               <p:cNvPr id="18" name="TextBox 17">
@@ -36170,16 +36853,14 @@
               </a:bodyPr>
               <a:lstStyle/>
               <a:p>
+                <a:pPr/>
                 <a14:m>
                   <m:oMathPara xmlns:m="http://schemas.openxmlformats.org/officeDocument/2006/math">
-                    <m:oMathParaPr>
-                      <m:jc m:val="centerGroup"/>
-                    </m:oMathParaPr>
-                    <m:oMath xmlns:m="http://schemas.openxmlformats.org/officeDocument/2006/math">
+                    <m:oMath>
                       <m:sSubSup>
                         <m:sSubSupPr>
                           <m:ctrlPr>
-                            <a:rPr lang="en-GB" sz="1200" i="1" smtClean="0">
+                            <a:rPr lang="en-US" sz="1200" b="0" i="1" smtClean="0">
                               <a:latin typeface="Cambria Math" panose="02040503050406030204" pitchFamily="18" charset="0"/>
                             </a:rPr>
                           </m:ctrlPr>
@@ -36330,7 +37011,7 @@
             </p:txBody>
           </p:sp>
         </mc:Choice>
-        <mc:Fallback>
+        <mc:Fallback xmlns="">
           <p:sp>
             <p:nvSpPr>
               <p:cNvPr id="18" name="TextBox 17">
@@ -36375,8 +37056,8 @@
           </p:sp>
         </mc:Fallback>
       </mc:AlternateContent>
-      <mc:AlternateContent xmlns:mc="http://schemas.openxmlformats.org/markup-compatibility/2006">
-        <mc:Choice xmlns:a14="http://schemas.microsoft.com/office/drawing/2010/main" Requires="a14">
+      <mc:AlternateContent xmlns:mc="http://schemas.openxmlformats.org/markup-compatibility/2006" xmlns:a14="http://schemas.microsoft.com/office/drawing/2010/main">
+        <mc:Choice Requires="a14">
           <p:sp>
             <p:nvSpPr>
               <p:cNvPr id="19" name="TextBox 18">
@@ -36418,10 +37099,7 @@
                 </a:pPr>
                 <a14:m>
                   <m:oMathPara xmlns:m="http://schemas.openxmlformats.org/officeDocument/2006/math">
-                    <m:oMathParaPr>
-                      <m:jc m:val="centerGroup"/>
-                    </m:oMathParaPr>
-                    <m:oMath xmlns:m="http://schemas.openxmlformats.org/officeDocument/2006/math">
+                    <m:oMath>
                       <m:sSubSup>
                         <m:sSubSupPr>
                           <m:ctrlPr>
@@ -36435,7 +37113,7 @@
                             <m:accPr>
                               <m:chr m:val="̃"/>
                               <m:ctrlPr>
-                                <a:rPr lang="en-US" sz="1200" i="1" smtClean="0">
+                                <a:rPr lang="en-US" sz="1200" b="0" i="1" smtClean="0">
                                   <a:latin typeface="Cambria Math" panose="02040503050406030204" pitchFamily="18" charset="0"/>
                                 </a:rPr>
                               </m:ctrlPr>
@@ -36474,16 +37152,7 @@
                         <a:rPr lang="en-US" sz="1200" b="0" i="0" smtClean="0">
                           <a:latin typeface="Cambria Math" panose="02040503050406030204" pitchFamily="18" charset="0"/>
                         </a:rPr>
-                        <m:t>=</m:t>
-                      </m:r>
-                      <m:r>
-                        <m:rPr>
-                          <m:nor/>
-                        </m:rPr>
-                        <a:rPr lang="en-US" sz="1200" b="0" i="0" smtClean="0">
-                          <a:latin typeface="Cambria Math" panose="02040503050406030204" pitchFamily="18" charset="0"/>
-                        </a:rPr>
-                        <m:t>LOESS</m:t>
+                        <m:t>=LOESS</m:t>
                       </m:r>
                       <m:d>
                         <m:dPr>
@@ -36537,7 +37206,7 @@
             </p:txBody>
           </p:sp>
         </mc:Choice>
-        <mc:Fallback>
+        <mc:Fallback xmlns="">
           <p:sp>
             <p:nvSpPr>
               <p:cNvPr id="19" name="TextBox 18">
@@ -36582,8 +37251,8 @@
           </p:sp>
         </mc:Fallback>
       </mc:AlternateContent>
-      <mc:AlternateContent xmlns:mc="http://schemas.openxmlformats.org/markup-compatibility/2006">
-        <mc:Choice xmlns:a14="http://schemas.microsoft.com/office/drawing/2010/main" Requires="a14">
+      <mc:AlternateContent xmlns:mc="http://schemas.openxmlformats.org/markup-compatibility/2006" xmlns:a14="http://schemas.microsoft.com/office/drawing/2010/main">
+        <mc:Choice Requires="a14">
           <p:sp>
             <p:nvSpPr>
               <p:cNvPr id="20" name="TextBox 19">
@@ -36625,10 +37294,7 @@
                 </a:pPr>
                 <a14:m>
                   <m:oMathPara xmlns:m="http://schemas.openxmlformats.org/officeDocument/2006/math">
-                    <m:oMathParaPr>
-                      <m:jc m:val="centerGroup"/>
-                    </m:oMathParaPr>
-                    <m:oMath xmlns:m="http://schemas.openxmlformats.org/officeDocument/2006/math">
+                    <m:oMath>
                       <m:sSubSup>
                         <m:sSubSupPr>
                           <m:ctrlPr>
@@ -36642,7 +37308,7 @@
                             <m:accPr>
                               <m:chr m:val="̃"/>
                               <m:ctrlPr>
-                                <a:rPr lang="en-US" sz="1200" i="1" smtClean="0">
+                                <a:rPr lang="en-US" sz="1200" b="0" i="1" smtClean="0">
                                   <a:latin typeface="Cambria Math" panose="02040503050406030204" pitchFamily="18" charset="0"/>
                                 </a:rPr>
                               </m:ctrlPr>
@@ -36681,16 +37347,7 @@
                         <a:rPr lang="en-US" sz="1200" b="0" i="0" smtClean="0">
                           <a:latin typeface="Cambria Math" panose="02040503050406030204" pitchFamily="18" charset="0"/>
                         </a:rPr>
-                        <m:t>=</m:t>
-                      </m:r>
-                      <m:r>
-                        <m:rPr>
-                          <m:nor/>
-                        </m:rPr>
-                        <a:rPr lang="en-US" sz="1200" b="0" i="0" smtClean="0">
-                          <a:latin typeface="Cambria Math" panose="02040503050406030204" pitchFamily="18" charset="0"/>
-                        </a:rPr>
-                        <m:t>LOESS</m:t>
+                        <m:t>=LOESS</m:t>
                       </m:r>
                       <m:d>
                         <m:dPr>
@@ -36744,7 +37401,7 @@
             </p:txBody>
           </p:sp>
         </mc:Choice>
-        <mc:Fallback>
+        <mc:Fallback xmlns="">
           <p:sp>
             <p:nvSpPr>
               <p:cNvPr id="20" name="TextBox 19">
@@ -36825,8 +37482,8 @@
           </a:p>
         </p:txBody>
       </p:sp>
-      <mc:AlternateContent xmlns:mc="http://schemas.openxmlformats.org/markup-compatibility/2006">
-        <mc:Choice xmlns:a14="http://schemas.microsoft.com/office/drawing/2010/main" Requires="a14">
+      <mc:AlternateContent xmlns:mc="http://schemas.openxmlformats.org/markup-compatibility/2006" xmlns:a14="http://schemas.microsoft.com/office/drawing/2010/main">
+        <mc:Choice Requires="a14">
           <p:sp>
             <p:nvSpPr>
               <p:cNvPr id="23" name="TextBox 22">
@@ -36855,18 +37512,17 @@
               </a:bodyPr>
               <a:lstStyle/>
               <a:p>
+                <a:pPr/>
                 <a14:m>
                   <m:oMathPara xmlns:m="http://schemas.openxmlformats.org/officeDocument/2006/math">
-                    <m:oMathParaPr>
-                      <m:jc m:val="centerGroup"/>
-                    </m:oMathParaPr>
-                    <m:oMath xmlns:m="http://schemas.openxmlformats.org/officeDocument/2006/math">
+                    <m:oMath>
                       <m:groupChr>
                         <m:groupChrPr>
                           <m:chr m:val="→"/>
+                          <m:pos m:val="bot"/>
                           <m:vertJc m:val="bot"/>
                           <m:ctrlPr>
-                            <a:rPr lang="en-GB" sz="1400" i="1" smtClean="0">
+                            <a:rPr lang="en-US" sz="1400" b="0" i="0" smtClean="0">
                               <a:latin typeface="Cambria Math" panose="02040503050406030204" pitchFamily="18" charset="0"/>
                             </a:rPr>
                           </m:ctrlPr>
@@ -36879,52 +37535,7 @@
                             <a:rPr lang="en-US" sz="1400" b="0" i="0" smtClean="0">
                               <a:latin typeface="Cambria Math" panose="02040503050406030204" pitchFamily="18" charset="0"/>
                             </a:rPr>
-                            <m:t>local</m:t>
-                          </m:r>
-                          <m:r>
-                            <m:rPr>
-                              <m:nor/>
-                            </m:rPr>
-                            <a:rPr lang="en-US" sz="1400" b="0" i="0" smtClean="0">
-                              <a:latin typeface="Cambria Math" panose="02040503050406030204" pitchFamily="18" charset="0"/>
-                            </a:rPr>
-                            <m:t> </m:t>
-                          </m:r>
-                          <m:r>
-                            <m:rPr>
-                              <m:nor/>
-                            </m:rPr>
-                            <a:rPr lang="en-US" sz="1400" b="0" i="0" smtClean="0">
-                              <a:latin typeface="Cambria Math" panose="02040503050406030204" pitchFamily="18" charset="0"/>
-                            </a:rPr>
-                            <m:t>polynomial</m:t>
-                          </m:r>
-                          <m:r>
-                            <m:rPr>
-                              <m:nor/>
-                            </m:rPr>
-                            <a:rPr lang="en-US" sz="1400" b="0" i="0" smtClean="0">
-                              <a:latin typeface="Cambria Math" panose="02040503050406030204" pitchFamily="18" charset="0"/>
-                            </a:rPr>
-                            <m:t> </m:t>
-                          </m:r>
-                          <m:r>
-                            <m:rPr>
-                              <m:nor/>
-                            </m:rPr>
-                            <a:rPr lang="en-US" sz="1400" b="0" i="0" smtClean="0">
-                              <a:latin typeface="Cambria Math" panose="02040503050406030204" pitchFamily="18" charset="0"/>
-                            </a:rPr>
-                            <m:t>smoothing</m:t>
-                          </m:r>
-                          <m:r>
-                            <m:rPr>
-                              <m:nor/>
-                            </m:rPr>
-                            <a:rPr lang="en-US" sz="1400" b="0" i="0" smtClean="0">
-                              <a:latin typeface="Cambria Math" panose="02040503050406030204" pitchFamily="18" charset="0"/>
-                            </a:rPr>
-                            <m:t>, </m:t>
+                            <m:t>local polynomial smoothing, </m:t>
                           </m:r>
                           <m:r>
                             <a:rPr lang="en-US" sz="1400" b="0" i="1" smtClean="0">
@@ -36950,7 +37561,7 @@
             </p:txBody>
           </p:sp>
         </mc:Choice>
-        <mc:Fallback>
+        <mc:Fallback xmlns="">
           <p:sp>
             <p:nvSpPr>
               <p:cNvPr id="23" name="TextBox 22">

</xml_diff>